<commit_message>
Nexa deck: CAPD open outcry slide and comparison row (16 slides)
</commit_message>
<xml_diff>
--- a/docs/nexa-vs-bitcoin-ethereum/Nexa-vs-Bitcoin-Ethereum-NO.pptx
+++ b/docs/nexa-vs-bitcoin-ethereum/Nexa-vs-Bitcoin-Ethereum-NO.pptx
@@ -20,9 +20,10 @@
     <p:sldId id="268" r:id="rId14"/>
     <p:sldId id="269" r:id="rId15"/>
     <p:sldId id="270" r:id="rId16"/>
+    <p:sldId id="271" r:id="rId17"/>
   </p:sldIdLst>
   <p:notesMasterIdLst>
-    <p:notesMasterId r:id="rId17"/>
+    <p:notesMasterId r:id="rId18"/>
   </p:notesMasterIdLst>
   <p:sldSz cx="12192000" cy="6858000"/>
   <p:notesSz cx="6858000" cy="12192000"/>
@@ -780,7 +781,7 @@
           <a:p>
             <a:r>
               <a:rPr lang="en-US" dirty="0"/>
-              <a:t>nexa.org: «Native on-chain programmability without EVM complexity», «No EVM overhead». Utviklerstacken: Wally-lommebok, TDPP-betalingsprotokoll, nexid-identitet, CAPD-meldinger, NexaJS og libnexakotlin. Hold denne sliden kort for et ikke-teknisk publikum; utdyp bare hvis noen spør.</a:t>
+              <a:t>CAPD er unikt for Nexa: en desentralisert, proof-of-work-begrenset, flyktig meldingsbuss på P2P-nettverket (spesifikasjon: spec.nexa.org/network/capd). Open outcry: børsgulv-modellen der tilbud ropes ut offentlig og hvem som helst kan ta dem. Mekanikk: tilbudet er en delvis signert transaksjon; det annonserte sammendraget (hvilken token for hvilken) er bare veiledende, den halvsignerte transaksjonen er det som gjelder, så en løgnaktig annonse er ufarlig: den som tar tilbudet får nøyaktig det transaksjonen sier, ellers er den ugyldig. Meldinger har opprettelsestid og utløp, videresendingsprioriteten faller til null etter rundt 600 sekunder, og en tilbakekallingshash lar avsenderen trekke tilbudet tidlig. Bruk: token- og NFT-markedsplasser uten markedsplassoperatør, handel med gjenstander i spill, atomiske bytter, oppretting av multisig-lommebøker og signeringsrunder. Kontrast: Bitcoin har ikke noe oppdagelseslag, så handel betyr sentraliserte børser; Ethereum trenger en DEX-kontrakt på kjeden og betaler gass for hver ordre og handel.</a:t>
             </a:r>
             <a:endParaRPr lang="en-US" dirty="0"/>
           </a:p>
@@ -868,7 +869,7 @@
           <a:p>
             <a:r>
               <a:rPr lang="en-US" dirty="0"/>
-              <a:t>SSB: 98 % av Norges strøm fra vann og vind (sent 2025); normal årsproduksjon ~157 TWh, forbruk ~140 TWh. Juni 2025: regjeringen varslet et midlertidig forbud mot nye proof-of-work-datasentre for mining, med obligatorisk datasenterregister; myndighetene har antydet at det kan bli permanent. Vær ærlig: forbudet gjelder PoW-mining generelt, så en Nexa-farm ville også vært omfattet. Poenget er at Nexas nettverk ikke er avhengig av farmer noe sted.</a:t>
+              <a:t>nexa.org: «Native on-chain programmability without EVM complexity», «No EVM overhead». Utviklerstacken: Wally-lommebok, TDPP-betalingsprotokoll, nexid-identitet, CAPD-meldinger, NexaJS og libnexakotlin. Hold denne sliden kort for et ikke-teknisk publikum; utdyp bare hvis noen spør.</a:t>
             </a:r>
             <a:endParaRPr lang="en-US" dirty="0"/>
           </a:p>
@@ -956,7 +957,7 @@
           <a:p>
             <a:r>
               <a:rPr lang="en-US" dirty="0"/>
-              <a:t>Ett-slides svar på arrangørenes tre temaer: energi og e-avfall, hvem som tjener på det, og NFT-spekulasjon. Hvert tall står tidligere i presentasjonen med kilde.</a:t>
+              <a:t>SSB: 98 % av Norges strøm fra vann og vind (sent 2025); normal årsproduksjon ~157 TWh, forbruk ~140 TWh. Juni 2025: regjeringen varslet et midlertidig forbud mot nye proof-of-work-datasentre for mining, med obligatorisk datasenterregister; myndighetene har antydet at det kan bli permanent. Vær ærlig: forbudet gjelder PoW-mining generelt, så en Nexa-farm ville også vært omfattet. Poenget er at Nexas nettverk ikke er avhengig av farmer noe sted.</a:t>
             </a:r>
             <a:endParaRPr lang="en-US" dirty="0"/>
           </a:p>
@@ -1044,7 +1045,7 @@
           <a:p>
             <a:r>
               <a:rPr lang="en-US" dirty="0"/>
-              <a:t>Avslutt med de tre svarene på de tre bekymringene. Hvis 13 000×-tallet utfordres: det er en kapasitetssammenligning ved lik nettverkseffekt, 5 600× på dagens benchmark og 13 000× med Blitz; gulvet er 1 000× fordi Bitcoin ikke kan overstige ~14 TPS.</a:t>
+              <a:t>Ett-slides svar på arrangørenes tre temaer: energi og e-avfall, hvem som tjener på det, og NFT-spekulasjon. Hvert tall står tidligere i presentasjonen med kilde.</a:t>
             </a:r>
             <a:endParaRPr lang="en-US" dirty="0"/>
           </a:p>
@@ -1068,6 +1069,94 @@
             <a:fld id="{F7021451-1387-4CA6-816F-3879F97B5CBC}" type="slidenum">
               <a:rPr lang="en-US"/>
               <a:t>15</a:t>
+            </a:fld>
+            <a:endParaRPr lang="en-US"/>
+          </a:p>
+        </p:txBody>
+      </p:sp>
+    </p:spTree>
+    <p:extLst>
+      <p:ext uri="{BB962C8B-B14F-4D97-AF65-F5344CB8AC3E}">
+        <p14:creationId xmlns:p14="http://schemas.microsoft.com/office/powerpoint/2010/main" val="1024086991"/>
+      </p:ext>
+    </p:extLst>
+  </p:cSld>
+  <p:clrMapOvr>
+    <a:masterClrMapping/>
+  </p:clrMapOvr>
+</p:notes>
+</file>
+
+<file path=ppt/notesSlides/notesSlide16.xml><?xml version="1.0" encoding="utf-8"?>
+<p:notes xmlns:a="http://schemas.openxmlformats.org/drawingml/2006/main" xmlns:r="http://schemas.openxmlformats.org/officeDocument/2006/relationships" xmlns:p="http://schemas.openxmlformats.org/presentationml/2006/main">
+  <p:cSld>
+    <p:spTree>
+      <p:nvGrpSpPr>
+        <p:cNvPr id="1" name=""/>
+        <p:cNvGrpSpPr/>
+        <p:nvPr/>
+      </p:nvGrpSpPr>
+      <p:grpSpPr>
+        <a:xfrm>
+          <a:off x="0" y="0"/>
+          <a:ext cx="0" cy="0"/>
+          <a:chOff x="0" y="0"/>
+          <a:chExt cx="0" cy="0"/>
+        </a:xfrm>
+      </p:grpSpPr>
+      <p:sp>
+        <p:nvSpPr>
+          <p:cNvPr id="2" name="Slide Image Placeholder 1"/>
+          <p:cNvSpPr>
+            <a:spLocks noGrp="1" noRot="1" noChangeAspect="1"/>
+          </p:cNvSpPr>
+          <p:nvPr>
+            <p:ph type="sldImg"/>
+          </p:nvPr>
+        </p:nvSpPr>
+        <p:spPr/>
+      </p:sp>
+      <p:sp>
+        <p:nvSpPr>
+          <p:cNvPr id="3" name="Notes Placeholder 2"/>
+          <p:cNvSpPr>
+            <a:spLocks noGrp="1"/>
+          </p:cNvSpPr>
+          <p:nvPr>
+            <p:ph type="body" idx="1"/>
+          </p:nvPr>
+        </p:nvSpPr>
+        <p:spPr/>
+        <p:txBody>
+          <a:bodyPr/>
+          <a:lstStyle/>
+          <a:p>
+            <a:r>
+              <a:rPr lang="en-US" dirty="0"/>
+              <a:t>Avslutt med de tre svarene på de tre bekymringene. Hvis 13 000×-tallet utfordres: det er en kapasitetssammenligning ved lik nettverkseffekt, 5 600× på dagens benchmark og 13 000× med Blitz; gulvet er 1 000× fordi Bitcoin ikke kan overstige ~14 TPS.</a:t>
+            </a:r>
+            <a:endParaRPr lang="en-US" dirty="0"/>
+          </a:p>
+        </p:txBody>
+      </p:sp>
+      <p:sp>
+        <p:nvSpPr>
+          <p:cNvPr id="4" name="Slide Number Placeholder 3"/>
+          <p:cNvSpPr>
+            <a:spLocks noGrp="1"/>
+          </p:cNvSpPr>
+          <p:nvPr>
+            <p:ph type="sldNum" sz="quarter" idx="10"/>
+          </p:nvPr>
+        </p:nvSpPr>
+        <p:spPr/>
+        <p:txBody>
+          <a:bodyPr/>
+          <a:lstStyle/>
+          <a:p>
+            <a:fld id="{F7021451-1387-4CA6-816F-3879F97B5CBC}" type="slidenum">
+              <a:rPr lang="en-US"/>
+              <a:t>16</a:t>
             </a:fld>
             <a:endParaRPr lang="en-US"/>
           </a:p>
@@ -3842,7 +3931,7 @@
                 <a:ea typeface="Calibri" pitchFamily="34" charset="-122"/>
                 <a:cs typeface="Calibri" pitchFamily="34" charset="-120"/>
               </a:rPr>
-              <a:t>Smartkontrakter uten EVM</a:t>
+              <a:t>Open outcry-handel over CAPD: rop ut et tilbud, hvem som helst kan ta det</a:t>
             </a:r>
             <a:endParaRPr lang="en-US" sz="3000" dirty="0"/>
           </a:p>
@@ -3957,7 +4046,7 @@
                 <a:ea typeface="Calibri" pitchFamily="34" charset="-122"/>
                 <a:cs typeface="Calibri" pitchFamily="34" charset="-120"/>
               </a:rPr>
-              <a:t>Skriptmaler</a:t>
+              <a:t>Rop tilbudet ut til nettverket</a:t>
             </a:r>
             <a:endParaRPr lang="en-US" sz="1800" dirty="0"/>
           </a:p>
@@ -3999,7 +4088,7 @@
                 <a:ea typeface="Calibri" pitchFamily="34" charset="-122"/>
                 <a:cs typeface="Calibri" pitchFamily="34" charset="-120"/>
               </a:rPr>
-              <a:t>Kontrakter er små, deterministiske skript knyttet til mynter og valideres parallelt som enhver annen transaksjon. Det finnes ingen global tilstandsmaskin å tette igjen.</a:t>
+              <a:t>CAPD (Counterparty and Protocol Discovery) er en meldingsbuss som bæres av de samme nodene som videresender transaksjoner. Du kringkaster et halvsignert tilbud, si 100 tokens for 5 000 NEXA, og alle noder sender det videre, som en megler som roper ut en pris på gulvet.</a:t>
             </a:r>
             <a:endParaRPr lang="en-US" sz="1500" dirty="0"/>
           </a:p>
@@ -4114,7 +4203,7 @@
                 <a:ea typeface="Calibri" pitchFamily="34" charset="-122"/>
                 <a:cs typeface="Calibri" pitchFamily="34" charset="-120"/>
               </a:rPr>
-              <a:t>Ingen EVM-overhead</a:t>
+              <a:t>Ingen børs, ingen ordrebok-server</a:t>
             </a:r>
             <a:endParaRPr lang="en-US" sz="1800" dirty="0"/>
           </a:p>
@@ -4156,7 +4245,7 @@
                 <a:ea typeface="Calibri" pitchFamily="34" charset="-122"/>
                 <a:cs typeface="Calibri" pitchFamily="34" charset="-120"/>
               </a:rPr>
-              <a:t>Intet gassmarked, ingen reentrancy-feilklasse, ingen gebyrhopp for alle når én app blir populær. Kontrakter kjører i de samme 42 000 TPS som vanlige betalinger.</a:t>
+              <a:t>Den som vil ha handelen, fullfører den halvsignerte transaksjonen og kringkaster den. Byttet gjøres opp på kjeden i én atomisk transaksjon, uten børs, noteringsgebyr eller matchingserver imellom. Bitcoin har ikke noe slikt lag; på Ethereum krever det en DEX-kontrakt og gass per handel.</a:t>
             </a:r>
             <a:endParaRPr lang="en-US" sz="1500" dirty="0"/>
           </a:p>
@@ -4271,7 +4360,7 @@
                 <a:ea typeface="Calibri" pitchFamily="34" charset="-122"/>
                 <a:cs typeface="Calibri" pitchFamily="34" charset="-120"/>
               </a:rPr>
-              <a:t>En hel plattform</a:t>
+              <a:t>Proof of work i stedet for gebyr, så forsvinner det</a:t>
             </a:r>
             <a:endParaRPr lang="en-US" sz="1800" dirty="0"/>
           </a:p>
@@ -4313,7 +4402,7 @@
                 <a:ea typeface="Calibri" pitchFamily="34" charset="-122"/>
                 <a:cs typeface="Calibri" pitchFamily="34" charset="-120"/>
               </a:rPr>
-              <a:t>Lommebokinnlogging med identitet på kjeden, betalingsforespørsler til brukerens lommebok og peer-to-peer-meldinger er del av stacken, med Kotlin- og JavaScript-biblioteker.</a:t>
+              <a:t>Avsenderen løser et lite proof of work i stedet for å betale gebyr, og det holder spam ute. Tilbud er flyktige: de faller ut av videresendingen etter rundt ti minutter om de ikke sendes på nytt, kan trekkes tilbake tidlig, og rører aldri blokkjeden før noen tar dem.</a:t>
             </a:r>
             <a:endParaRPr lang="en-US" sz="1500" dirty="0"/>
           </a:p>
@@ -4486,7 +4575,7 @@
                 <a:ea typeface="Calibri" pitchFamily="34" charset="-122"/>
                 <a:cs typeface="Calibri" pitchFamily="34" charset="-120"/>
               </a:rPr>
-              <a:t>Hvorfor dette betyr noe i Norge</a:t>
+              <a:t>Smartkontrakter uten EVM</a:t>
             </a:r>
             <a:endParaRPr lang="en-US" sz="3000" dirty="0"/>
           </a:p>
@@ -4601,7 +4690,7 @@
                 <a:ea typeface="Calibri" pitchFamily="34" charset="-122"/>
                 <a:cs typeface="Calibri" pitchFamily="34" charset="-120"/>
               </a:rPr>
-              <a:t>Et rent nett under press</a:t>
+              <a:t>Skriptmaler</a:t>
             </a:r>
             <a:endParaRPr lang="en-US" sz="1800" dirty="0"/>
           </a:p>
@@ -4643,7 +4732,7 @@
                 <a:ea typeface="Calibri" pitchFamily="34" charset="-122"/>
                 <a:cs typeface="Calibri" pitchFamily="34" charset="-120"/>
               </a:rPr>
-              <a:t>98 % av Norges strøm er vann og vind, likevel stanset regjeringen i 2025 nye proof-of-work-datasentre for å verne nettkapasiteten. Nexa-mining kjører på vanlige GPU-er og er ikke avhengig av datasentre.</a:t>
+              <a:t>Kontrakter er små, deterministiske skript knyttet til mynter og valideres parallelt som enhver annen transaksjon. Det finnes ingen global tilstandsmaskin å tette igjen.</a:t>
             </a:r>
             <a:endParaRPr lang="en-US" sz="1500" dirty="0"/>
           </a:p>
@@ -4691,11 +4780,11 @@
             <a:avLst/>
           </a:prstGeom>
           <a:solidFill>
-            <a:srgbClr val="F7931A"/>
+            <a:srgbClr val="F2CD3A"/>
           </a:solidFill>
           <a:ln w="12700">
             <a:solidFill>
-              <a:srgbClr val="F7931A"/>
+              <a:srgbClr val="F2CD3A"/>
             </a:solidFill>
             <a:prstDash val="solid"/>
           </a:ln>
@@ -4758,7 +4847,7 @@
                 <a:ea typeface="Calibri" pitchFamily="34" charset="-122"/>
                 <a:cs typeface="Calibri" pitchFamily="34" charset="-120"/>
               </a:rPr>
-              <a:t>Bitcoin ≈ Norge</a:t>
+              <a:t>Ingen EVM-overhead</a:t>
             </a:r>
             <a:endParaRPr lang="en-US" sz="1800" dirty="0"/>
           </a:p>
@@ -4800,7 +4889,7 @@
                 <a:ea typeface="Calibri" pitchFamily="34" charset="-122"/>
                 <a:cs typeface="Calibri" pitchFamily="34" charset="-120"/>
               </a:rPr>
-              <a:t>Bitcoins rundt 140 TWh i året tilsvarer hele Norges strømforbruk, for 7 transaksjoner i sekundet. Samme strøm på Nexa ville båret tusenvis av ganger flere betalinger.</a:t>
+              <a:t>Intet gassmarked, ingen reentrancy-feilklasse, ingen gebyrhopp for alle når én app blir populær. Kontrakter kjører i de samme 42 000 TPS som vanlige betalinger.</a:t>
             </a:r>
             <a:endParaRPr lang="en-US" sz="1500" dirty="0"/>
           </a:p>
@@ -4915,7 +5004,7 @@
                 <a:ea typeface="Calibri" pitchFamily="34" charset="-122"/>
                 <a:cs typeface="Calibri" pitchFamily="34" charset="-120"/>
               </a:rPr>
-              <a:t>Et kontantløst land</a:t>
+              <a:t>En hel plattform</a:t>
             </a:r>
             <a:endParaRPr lang="en-US" sz="1800" dirty="0"/>
           </a:p>
@@ -4957,7 +5046,7 @@
                 <a:ea typeface="Calibri" pitchFamily="34" charset="-122"/>
                 <a:cs typeface="Calibri" pitchFamily="34" charset="-120"/>
               </a:rPr>
-              <a:t>Nordmenn betaler allerede med mobilen på sekunder. En rail for energieffektive penger som gjør opp på to sekunder for en brøkdel av et øre passer slik folk her allerede lever.</a:t>
+              <a:t>Lommebokinnlogging med identitet på kjeden, betalingsforespørsler til brukerens lommebok og peer-to-peer-meldinger er del av stacken, med Kotlin- og JavaScript-biblioteker.</a:t>
             </a:r>
             <a:endParaRPr lang="en-US" sz="1500" dirty="0"/>
           </a:p>
@@ -5130,6 +5219,650 @@
                 <a:ea typeface="Calibri" pitchFamily="34" charset="-122"/>
                 <a:cs typeface="Calibri" pitchFamily="34" charset="-120"/>
               </a:rPr>
+              <a:t>Hvorfor dette betyr noe i Norge</a:t>
+            </a:r>
+            <a:endParaRPr lang="en-US" sz="3000" dirty="0"/>
+          </a:p>
+        </p:txBody>
+      </p:sp>
+      <p:sp>
+        <p:nvSpPr>
+          <p:cNvPr id="3" name="Shape 1"/>
+          <p:cNvSpPr/>
+          <p:nvPr/>
+        </p:nvSpPr>
+        <p:spPr>
+          <a:xfrm>
+            <a:off x="548640" y="1691640"/>
+            <a:ext cx="3515258" cy="3657600"/>
+          </a:xfrm>
+          <a:prstGeom prst="roundRect">
+            <a:avLst>
+              <a:gd name="adj" fmla="val 3121"/>
+            </a:avLst>
+          </a:prstGeom>
+          <a:solidFill>
+            <a:srgbClr val="18181B"/>
+          </a:solidFill>
+          <a:ln w="9525">
+            <a:solidFill>
+              <a:srgbClr val="2E2E35"/>
+            </a:solidFill>
+            <a:prstDash val="solid"/>
+          </a:ln>
+        </p:spPr>
+      </p:sp>
+      <p:sp>
+        <p:nvSpPr>
+          <p:cNvPr id="4" name="Shape 2"/>
+          <p:cNvSpPr/>
+          <p:nvPr/>
+        </p:nvSpPr>
+        <p:spPr>
+          <a:xfrm>
+            <a:off x="822960" y="1965960"/>
+            <a:ext cx="640080" cy="640080"/>
+          </a:xfrm>
+          <a:prstGeom prst="ellipse">
+            <a:avLst/>
+          </a:prstGeom>
+          <a:solidFill>
+            <a:srgbClr val="F2CD3A"/>
+          </a:solidFill>
+          <a:ln w="12700">
+            <a:solidFill>
+              <a:srgbClr val="F2CD3A"/>
+            </a:solidFill>
+            <a:prstDash val="solid"/>
+          </a:ln>
+        </p:spPr>
+      </p:sp>
+      <p:pic>
+        <p:nvPicPr>
+          <p:cNvPr id="5" name="Image 0" descr="preencoded.png">    </p:cNvPr>
+          <p:cNvPicPr>
+            <a:picLocks noChangeAspect="1"/>
+          </p:cNvPicPr>
+          <p:nvPr/>
+        </p:nvPicPr>
+        <p:blipFill>
+          <a:blip r:embed="rId1"/>
+          <a:stretch>
+            <a:fillRect/>
+          </a:stretch>
+        </p:blipFill>
+        <p:spPr>
+          <a:xfrm>
+            <a:off x="976579" y="2119579"/>
+            <a:ext cx="332842" cy="332842"/>
+          </a:xfrm>
+          <a:prstGeom prst="rect">
+            <a:avLst/>
+          </a:prstGeom>
+        </p:spPr>
+      </p:pic>
+      <p:sp>
+        <p:nvSpPr>
+          <p:cNvPr id="6" name="Text 3"/>
+          <p:cNvSpPr txBox="1"/>
+          <p:nvPr/>
+        </p:nvSpPr>
+        <p:spPr>
+          <a:xfrm>
+            <a:off x="822960" y="2788920"/>
+            <a:ext cx="2966618" cy="640080"/>
+          </a:xfrm>
+          <a:prstGeom prst="rect">
+            <a:avLst/>
+          </a:prstGeom>
+          <a:noFill/>
+          <a:ln/>
+        </p:spPr>
+        <p:txBody>
+          <a:bodyPr wrap="square" lIns="0" tIns="0" rIns="0" bIns="0" rtlCol="0" anchor="t"/>
+          <a:lstStyle/>
+          <a:p>
+            <a:pPr indent="0" marL="0">
+              <a:buNone/>
+            </a:pPr>
+            <a:r>
+              <a:rPr lang="en-US" sz="1800" b="1" dirty="0">
+                <a:solidFill>
+                  <a:srgbClr val="FFFFFF"/>
+                </a:solidFill>
+                <a:latin typeface="Calibri" pitchFamily="34" charset="0"/>
+                <a:ea typeface="Calibri" pitchFamily="34" charset="-122"/>
+                <a:cs typeface="Calibri" pitchFamily="34" charset="-120"/>
+              </a:rPr>
+              <a:t>Et rent nett under press</a:t>
+            </a:r>
+            <a:endParaRPr lang="en-US" sz="1800" dirty="0"/>
+          </a:p>
+        </p:txBody>
+      </p:sp>
+      <p:sp>
+        <p:nvSpPr>
+          <p:cNvPr id="7" name="Text 4"/>
+          <p:cNvSpPr txBox="1"/>
+          <p:nvPr/>
+        </p:nvSpPr>
+        <p:spPr>
+          <a:xfrm>
+            <a:off x="822960" y="3474720"/>
+            <a:ext cx="2966618" cy="1600200"/>
+          </a:xfrm>
+          <a:prstGeom prst="rect">
+            <a:avLst/>
+          </a:prstGeom>
+          <a:noFill/>
+          <a:ln/>
+        </p:spPr>
+        <p:txBody>
+          <a:bodyPr wrap="square" lIns="0" tIns="0" rIns="0" bIns="0" rtlCol="0" anchor="t"/>
+          <a:lstStyle/>
+          <a:p>
+            <a:pPr indent="0" marL="0">
+              <a:spcAft>
+                <a:spcPts val="600"/>
+              </a:spcAft>
+              <a:buNone/>
+            </a:pPr>
+            <a:r>
+              <a:rPr lang="en-US" sz="1500" dirty="0">
+                <a:solidFill>
+                  <a:srgbClr val="E4E4E7"/>
+                </a:solidFill>
+                <a:latin typeface="Calibri" pitchFamily="34" charset="0"/>
+                <a:ea typeface="Calibri" pitchFamily="34" charset="-122"/>
+                <a:cs typeface="Calibri" pitchFamily="34" charset="-120"/>
+              </a:rPr>
+              <a:t>98 % av Norges strøm er vann og vind, likevel stanset regjeringen i 2025 nye proof-of-work-datasentre for å verne nettkapasiteten. Nexa-mining kjører på vanlige GPU-er og er ikke avhengig av datasentre.</a:t>
+            </a:r>
+            <a:endParaRPr lang="en-US" sz="1500" dirty="0"/>
+          </a:p>
+        </p:txBody>
+      </p:sp>
+      <p:sp>
+        <p:nvSpPr>
+          <p:cNvPr id="8" name="Shape 5"/>
+          <p:cNvSpPr/>
+          <p:nvPr/>
+        </p:nvSpPr>
+        <p:spPr>
+          <a:xfrm>
+            <a:off x="4338218" y="1691640"/>
+            <a:ext cx="3515258" cy="3657600"/>
+          </a:xfrm>
+          <a:prstGeom prst="roundRect">
+            <a:avLst>
+              <a:gd name="adj" fmla="val 3121"/>
+            </a:avLst>
+          </a:prstGeom>
+          <a:solidFill>
+            <a:srgbClr val="18181B"/>
+          </a:solidFill>
+          <a:ln w="9525">
+            <a:solidFill>
+              <a:srgbClr val="2E2E35"/>
+            </a:solidFill>
+            <a:prstDash val="solid"/>
+          </a:ln>
+        </p:spPr>
+      </p:sp>
+      <p:sp>
+        <p:nvSpPr>
+          <p:cNvPr id="9" name="Shape 6"/>
+          <p:cNvSpPr/>
+          <p:nvPr/>
+        </p:nvSpPr>
+        <p:spPr>
+          <a:xfrm>
+            <a:off x="4612538" y="1965960"/>
+            <a:ext cx="640080" cy="640080"/>
+          </a:xfrm>
+          <a:prstGeom prst="ellipse">
+            <a:avLst/>
+          </a:prstGeom>
+          <a:solidFill>
+            <a:srgbClr val="F7931A"/>
+          </a:solidFill>
+          <a:ln w="12700">
+            <a:solidFill>
+              <a:srgbClr val="F7931A"/>
+            </a:solidFill>
+            <a:prstDash val="solid"/>
+          </a:ln>
+        </p:spPr>
+      </p:sp>
+      <p:pic>
+        <p:nvPicPr>
+          <p:cNvPr id="10" name="Image 1" descr="preencoded.png">    </p:cNvPr>
+          <p:cNvPicPr>
+            <a:picLocks noChangeAspect="1"/>
+          </p:cNvPicPr>
+          <p:nvPr/>
+        </p:nvPicPr>
+        <p:blipFill>
+          <a:blip r:embed="rId2"/>
+          <a:stretch>
+            <a:fillRect/>
+          </a:stretch>
+        </p:blipFill>
+        <p:spPr>
+          <a:xfrm>
+            <a:off x="4766158" y="2119579"/>
+            <a:ext cx="332842" cy="332842"/>
+          </a:xfrm>
+          <a:prstGeom prst="rect">
+            <a:avLst/>
+          </a:prstGeom>
+        </p:spPr>
+      </p:pic>
+      <p:sp>
+        <p:nvSpPr>
+          <p:cNvPr id="11" name="Text 7"/>
+          <p:cNvSpPr txBox="1"/>
+          <p:nvPr/>
+        </p:nvSpPr>
+        <p:spPr>
+          <a:xfrm>
+            <a:off x="4612538" y="2788920"/>
+            <a:ext cx="2966618" cy="640080"/>
+          </a:xfrm>
+          <a:prstGeom prst="rect">
+            <a:avLst/>
+          </a:prstGeom>
+          <a:noFill/>
+          <a:ln/>
+        </p:spPr>
+        <p:txBody>
+          <a:bodyPr wrap="square" lIns="0" tIns="0" rIns="0" bIns="0" rtlCol="0" anchor="t"/>
+          <a:lstStyle/>
+          <a:p>
+            <a:pPr indent="0" marL="0">
+              <a:buNone/>
+            </a:pPr>
+            <a:r>
+              <a:rPr lang="en-US" sz="1800" b="1" dirty="0">
+                <a:solidFill>
+                  <a:srgbClr val="FFFFFF"/>
+                </a:solidFill>
+                <a:latin typeface="Calibri" pitchFamily="34" charset="0"/>
+                <a:ea typeface="Calibri" pitchFamily="34" charset="-122"/>
+                <a:cs typeface="Calibri" pitchFamily="34" charset="-120"/>
+              </a:rPr>
+              <a:t>Bitcoin ≈ Norge</a:t>
+            </a:r>
+            <a:endParaRPr lang="en-US" sz="1800" dirty="0"/>
+          </a:p>
+        </p:txBody>
+      </p:sp>
+      <p:sp>
+        <p:nvSpPr>
+          <p:cNvPr id="12" name="Text 8"/>
+          <p:cNvSpPr txBox="1"/>
+          <p:nvPr/>
+        </p:nvSpPr>
+        <p:spPr>
+          <a:xfrm>
+            <a:off x="4612538" y="3474720"/>
+            <a:ext cx="2966618" cy="1600200"/>
+          </a:xfrm>
+          <a:prstGeom prst="rect">
+            <a:avLst/>
+          </a:prstGeom>
+          <a:noFill/>
+          <a:ln/>
+        </p:spPr>
+        <p:txBody>
+          <a:bodyPr wrap="square" lIns="0" tIns="0" rIns="0" bIns="0" rtlCol="0" anchor="t"/>
+          <a:lstStyle/>
+          <a:p>
+            <a:pPr indent="0" marL="0">
+              <a:spcAft>
+                <a:spcPts val="600"/>
+              </a:spcAft>
+              <a:buNone/>
+            </a:pPr>
+            <a:r>
+              <a:rPr lang="en-US" sz="1500" dirty="0">
+                <a:solidFill>
+                  <a:srgbClr val="E4E4E7"/>
+                </a:solidFill>
+                <a:latin typeface="Calibri" pitchFamily="34" charset="0"/>
+                <a:ea typeface="Calibri" pitchFamily="34" charset="-122"/>
+                <a:cs typeface="Calibri" pitchFamily="34" charset="-120"/>
+              </a:rPr>
+              <a:t>Bitcoins rundt 140 TWh i året tilsvarer hele Norges strømforbruk, for 7 transaksjoner i sekundet. Samme strøm på Nexa ville båret tusenvis av ganger flere betalinger.</a:t>
+            </a:r>
+            <a:endParaRPr lang="en-US" sz="1500" dirty="0"/>
+          </a:p>
+        </p:txBody>
+      </p:sp>
+      <p:sp>
+        <p:nvSpPr>
+          <p:cNvPr id="13" name="Shape 9"/>
+          <p:cNvSpPr/>
+          <p:nvPr/>
+        </p:nvSpPr>
+        <p:spPr>
+          <a:xfrm>
+            <a:off x="8127797" y="1691640"/>
+            <a:ext cx="3515258" cy="3657600"/>
+          </a:xfrm>
+          <a:prstGeom prst="roundRect">
+            <a:avLst>
+              <a:gd name="adj" fmla="val 3121"/>
+            </a:avLst>
+          </a:prstGeom>
+          <a:solidFill>
+            <a:srgbClr val="18181B"/>
+          </a:solidFill>
+          <a:ln w="9525">
+            <a:solidFill>
+              <a:srgbClr val="2E2E35"/>
+            </a:solidFill>
+            <a:prstDash val="solid"/>
+          </a:ln>
+        </p:spPr>
+      </p:sp>
+      <p:sp>
+        <p:nvSpPr>
+          <p:cNvPr id="14" name="Shape 10"/>
+          <p:cNvSpPr/>
+          <p:nvPr/>
+        </p:nvSpPr>
+        <p:spPr>
+          <a:xfrm>
+            <a:off x="8402117" y="1965960"/>
+            <a:ext cx="640080" cy="640080"/>
+          </a:xfrm>
+          <a:prstGeom prst="ellipse">
+            <a:avLst/>
+          </a:prstGeom>
+          <a:solidFill>
+            <a:srgbClr val="F2CD3A"/>
+          </a:solidFill>
+          <a:ln w="12700">
+            <a:solidFill>
+              <a:srgbClr val="F2CD3A"/>
+            </a:solidFill>
+            <a:prstDash val="solid"/>
+          </a:ln>
+        </p:spPr>
+      </p:sp>
+      <p:pic>
+        <p:nvPicPr>
+          <p:cNvPr id="15" name="Image 2" descr="preencoded.png">    </p:cNvPr>
+          <p:cNvPicPr>
+            <a:picLocks noChangeAspect="1"/>
+          </p:cNvPicPr>
+          <p:nvPr/>
+        </p:nvPicPr>
+        <p:blipFill>
+          <a:blip r:embed="rId3"/>
+          <a:stretch>
+            <a:fillRect/>
+          </a:stretch>
+        </p:blipFill>
+        <p:spPr>
+          <a:xfrm>
+            <a:off x="8555736" y="2119579"/>
+            <a:ext cx="332842" cy="332842"/>
+          </a:xfrm>
+          <a:prstGeom prst="rect">
+            <a:avLst/>
+          </a:prstGeom>
+        </p:spPr>
+      </p:pic>
+      <p:sp>
+        <p:nvSpPr>
+          <p:cNvPr id="16" name="Text 11"/>
+          <p:cNvSpPr txBox="1"/>
+          <p:nvPr/>
+        </p:nvSpPr>
+        <p:spPr>
+          <a:xfrm>
+            <a:off x="8402117" y="2788920"/>
+            <a:ext cx="2966618" cy="640080"/>
+          </a:xfrm>
+          <a:prstGeom prst="rect">
+            <a:avLst/>
+          </a:prstGeom>
+          <a:noFill/>
+          <a:ln/>
+        </p:spPr>
+        <p:txBody>
+          <a:bodyPr wrap="square" lIns="0" tIns="0" rIns="0" bIns="0" rtlCol="0" anchor="t"/>
+          <a:lstStyle/>
+          <a:p>
+            <a:pPr indent="0" marL="0">
+              <a:buNone/>
+            </a:pPr>
+            <a:r>
+              <a:rPr lang="en-US" sz="1800" b="1" dirty="0">
+                <a:solidFill>
+                  <a:srgbClr val="FFFFFF"/>
+                </a:solidFill>
+                <a:latin typeface="Calibri" pitchFamily="34" charset="0"/>
+                <a:ea typeface="Calibri" pitchFamily="34" charset="-122"/>
+                <a:cs typeface="Calibri" pitchFamily="34" charset="-120"/>
+              </a:rPr>
+              <a:t>Et kontantløst land</a:t>
+            </a:r>
+            <a:endParaRPr lang="en-US" sz="1800" dirty="0"/>
+          </a:p>
+        </p:txBody>
+      </p:sp>
+      <p:sp>
+        <p:nvSpPr>
+          <p:cNvPr id="17" name="Text 12"/>
+          <p:cNvSpPr txBox="1"/>
+          <p:nvPr/>
+        </p:nvSpPr>
+        <p:spPr>
+          <a:xfrm>
+            <a:off x="8402117" y="3474720"/>
+            <a:ext cx="2966618" cy="1600200"/>
+          </a:xfrm>
+          <a:prstGeom prst="rect">
+            <a:avLst/>
+          </a:prstGeom>
+          <a:noFill/>
+          <a:ln/>
+        </p:spPr>
+        <p:txBody>
+          <a:bodyPr wrap="square" lIns="0" tIns="0" rIns="0" bIns="0" rtlCol="0" anchor="t"/>
+          <a:lstStyle/>
+          <a:p>
+            <a:pPr indent="0" marL="0">
+              <a:spcAft>
+                <a:spcPts val="600"/>
+              </a:spcAft>
+              <a:buNone/>
+            </a:pPr>
+            <a:r>
+              <a:rPr lang="en-US" sz="1500" dirty="0">
+                <a:solidFill>
+                  <a:srgbClr val="E4E4E7"/>
+                </a:solidFill>
+                <a:latin typeface="Calibri" pitchFamily="34" charset="0"/>
+                <a:ea typeface="Calibri" pitchFamily="34" charset="-122"/>
+                <a:cs typeface="Calibri" pitchFamily="34" charset="-120"/>
+              </a:rPr>
+              <a:t>Nordmenn betaler allerede med mobilen på sekunder. En rail for energieffektive penger som gjør opp på to sekunder for en brøkdel av et øre passer slik folk her allerede lever.</a:t>
+            </a:r>
+            <a:endParaRPr lang="en-US" sz="1500" dirty="0"/>
+          </a:p>
+        </p:txBody>
+      </p:sp>
+      <p:pic>
+        <p:nvPicPr>
+          <p:cNvPr id="19" name="Image 3" descr="preencoded.png">    </p:cNvPr>
+          <p:cNvPicPr>
+            <a:picLocks noChangeAspect="1"/>
+          </p:cNvPicPr>
+          <p:nvPr/>
+        </p:nvPicPr>
+        <p:blipFill>
+          <a:blip r:embed="rId4"/>
+          <a:stretch>
+            <a:fillRect/>
+          </a:stretch>
+        </p:blipFill>
+        <p:spPr>
+          <a:xfrm>
+            <a:off x="548640" y="6355080"/>
+            <a:ext cx="256032" cy="246888"/>
+          </a:xfrm>
+          <a:prstGeom prst="rect">
+            <a:avLst/>
+          </a:prstGeom>
+        </p:spPr>
+      </p:pic>
+      <p:sp>
+        <p:nvSpPr>
+          <p:cNvPr id="20" name="Text 13"/>
+          <p:cNvSpPr txBox="1"/>
+          <p:nvPr/>
+        </p:nvSpPr>
+        <p:spPr>
+          <a:xfrm>
+            <a:off x="877824" y="6400800"/>
+            <a:ext cx="2743200" cy="274320"/>
+          </a:xfrm>
+          <a:prstGeom prst="rect">
+            <a:avLst/>
+          </a:prstGeom>
+          <a:noFill/>
+          <a:ln/>
+        </p:spPr>
+        <p:txBody>
+          <a:bodyPr wrap="square" lIns="0" tIns="0" rIns="0" bIns="0" rtlCol="0" anchor="ctr"/>
+          <a:lstStyle/>
+          <a:p>
+            <a:pPr algn="l" indent="0" marL="0">
+              <a:buNone/>
+            </a:pPr>
+            <a:r>
+              <a:rPr lang="en-US" sz="1000" dirty="0">
+                <a:solidFill>
+                  <a:srgbClr val="A1A1AA"/>
+                </a:solidFill>
+                <a:latin typeface="Calibri" pitchFamily="34" charset="0"/>
+                <a:ea typeface="Calibri" pitchFamily="34" charset="-122"/>
+                <a:cs typeface="Calibri" pitchFamily="34" charset="-120"/>
+              </a:rPr>
+              <a:t>Nexa · 2026</a:t>
+            </a:r>
+            <a:endParaRPr lang="en-US" sz="1000" dirty="0"/>
+          </a:p>
+        </p:txBody>
+      </p:sp>
+      <p:sp>
+        <p:nvSpPr>
+          <p:cNvPr id="21" name="Text 14"/>
+          <p:cNvSpPr txBox="1"/>
+          <p:nvPr/>
+        </p:nvSpPr>
+        <p:spPr>
+          <a:xfrm>
+            <a:off x="11094415" y="6400800"/>
+            <a:ext cx="548640" cy="274320"/>
+          </a:xfrm>
+          <a:prstGeom prst="rect">
+            <a:avLst/>
+          </a:prstGeom>
+          <a:noFill/>
+          <a:ln/>
+        </p:spPr>
+        <p:txBody>
+          <a:bodyPr wrap="square" lIns="0" tIns="0" rIns="0" bIns="0" rtlCol="0" anchor="ctr"/>
+          <a:lstStyle/>
+          <a:p>
+            <a:pPr algn="r" indent="0" marL="0">
+              <a:buNone/>
+            </a:pPr>
+            <a:r>
+              <a:rPr lang="en-US" sz="1000" dirty="0">
+                <a:solidFill>
+                  <a:srgbClr val="A1A1AA"/>
+                </a:solidFill>
+                <a:latin typeface="Calibri" pitchFamily="34" charset="0"/>
+                <a:ea typeface="Calibri" pitchFamily="34" charset="-122"/>
+                <a:cs typeface="Calibri" pitchFamily="34" charset="-120"/>
+              </a:rPr>
+              <a:t>14</a:t>
+            </a:r>
+            <a:endParaRPr lang="en-US" sz="1000" dirty="0"/>
+          </a:p>
+        </p:txBody>
+      </p:sp>
+    </p:spTree>
+  </p:cSld>
+  <p:clrMapOvr>
+    <a:masterClrMapping/>
+  </p:clrMapOvr>
+</p:sld>
+</file>
+
+<file path=ppt/slides/slide15.xml><?xml version="1.0" encoding="utf-8"?>
+<p:sld xmlns:a="http://schemas.openxmlformats.org/drawingml/2006/main" xmlns:r="http://schemas.openxmlformats.org/officeDocument/2006/relationships" xmlns:p="http://schemas.openxmlformats.org/presentationml/2006/main">
+  <p:cSld name="Slide 15">
+    <p:bg>
+      <p:bgPr>
+        <a:solidFill>
+          <a:srgbClr val="0A0A0F"/>
+        </a:solidFill>
+      </p:bgPr>
+    </p:bg>
+    <p:spTree>
+      <p:nvGrpSpPr>
+        <p:cNvPr id="1" name=""/>
+        <p:cNvGrpSpPr/>
+        <p:nvPr/>
+      </p:nvGrpSpPr>
+      <p:grpSpPr>
+        <a:xfrm>
+          <a:off x="0" y="0"/>
+          <a:ext cx="0" cy="0"/>
+          <a:chOff x="0" y="0"/>
+          <a:chExt cx="0" cy="0"/>
+        </a:xfrm>
+      </p:grpSpPr>
+      <p:sp>
+        <p:nvSpPr>
+          <p:cNvPr id="2" name="Text 0"/>
+          <p:cNvSpPr txBox="1"/>
+          <p:nvPr/>
+        </p:nvSpPr>
+        <p:spPr>
+          <a:xfrm>
+            <a:off x="548640" y="411480"/>
+            <a:ext cx="11094415" cy="1005840"/>
+          </a:xfrm>
+          <a:prstGeom prst="rect">
+            <a:avLst/>
+          </a:prstGeom>
+          <a:noFill/>
+          <a:ln/>
+        </p:spPr>
+        <p:txBody>
+          <a:bodyPr wrap="square" lIns="0" tIns="0" rIns="0" bIns="0" rtlCol="0" anchor="t"/>
+          <a:lstStyle/>
+          <a:p>
+            <a:pPr algn="l" indent="0" marL="0">
+              <a:buNone/>
+            </a:pPr>
+            <a:r>
+              <a:rPr lang="en-US" sz="3000" b="1" dirty="0">
+                <a:solidFill>
+                  <a:srgbClr val="FFFFFF"/>
+                </a:solidFill>
+                <a:latin typeface="Calibri" pitchFamily="34" charset="0"/>
+                <a:ea typeface="Calibri" pitchFamily="34" charset="-122"/>
+                <a:cs typeface="Calibri" pitchFamily="34" charset="-120"/>
+              </a:rPr>
               <a:t>Sammenligning i oversikt</a:t>
             </a:r>
             <a:endParaRPr lang="en-US" sz="3000" dirty="0"/>
@@ -5138,7 +5871,7 @@
       </p:sp>
       <p:graphicFrame>
         <p:nvGraphicFramePr>
-          <p:cNvPr id="15" name="Table 0"/>
+          <p:cNvPr id="16" name="Table 0"/>
           <p:cNvGraphicFramePr>
             <a:graphicFrameLocks noGrp="1"/>
           </p:cNvGraphicFramePr>
@@ -5438,7 +6171,7 @@
                   </a:tcPr>
                 </a:tc>
               </a:tr>
-              <a:tr h="1188720">
+              <a:tr h="1005840">
                 <a:tc>
                   <a:txBody>
                     <a:bodyPr/>
@@ -5712,7 +6445,7 @@
                   </a:tcPr>
                 </a:tc>
               </a:tr>
-              <a:tr h="1188720">
+              <a:tr h="1005840">
                 <a:tc>
                   <a:txBody>
                     <a:bodyPr/>
@@ -5986,7 +6719,7 @@
                   </a:tcPr>
                 </a:tc>
               </a:tr>
-              <a:tr h="1188720">
+              <a:tr h="1005840">
                 <a:tc>
                   <a:txBody>
                     <a:bodyPr/>
@@ -6260,6 +6993,280 @@
                   </a:tcPr>
                 </a:tc>
               </a:tr>
+              <a:tr h="1005840">
+                <a:tc>
+                  <a:txBody>
+                    <a:bodyPr/>
+                    <a:lstStyle/>
+                    <a:p>
+                      <a:pPr indent="0" marL="0">
+                        <a:buNone/>
+                      </a:pPr>
+                      <a:r>
+                        <a:rPr lang="en-US" sz="1300" b="1" dirty="0">
+                          <a:solidFill>
+                            <a:srgbClr val="FFFFFF"/>
+                          </a:solidFill>
+                          <a:latin typeface="Calibri" pitchFamily="34" charset="0"/>
+                          <a:ea typeface="Calibri" pitchFamily="34" charset="-122"/>
+                          <a:cs typeface="Calibri" pitchFamily="34" charset="-120"/>
+                        </a:rPr>
+                        <a:t>Å finne en motpart</a:t>
+                      </a:r>
+                      <a:endParaRPr lang="en-US" sz="1300" dirty="0">
+                        <a:latin typeface="Calibri" charset="0"/>
+                        <a:ea typeface="Calibri" charset="0"/>
+                        <a:cs typeface="Calibri" charset="0"/>
+                      </a:endParaRPr>
+                    </a:p>
+                  </a:txBody>
+                  <a:tcPr marL="101600" marR="101600" marT="76200" marB="76200" anchor="ctr">
+                    <a:lnL w="25400" cap="flat" cmpd="sng" algn="ctr">
+                      <a:solidFill>
+                        <a:srgbClr val="0A0A0F"/>
+                      </a:solidFill>
+                      <a:prstDash val="solid"/>
+                      <a:round/>
+                      <a:headEnd type="none" w="med" len="med"/>
+                      <a:tailEnd type="none" w="med" len="med"/>
+                    </a:lnL>
+                    <a:lnR w="25400" cap="flat" cmpd="sng" algn="ctr">
+                      <a:solidFill>
+                        <a:srgbClr val="0A0A0F"/>
+                      </a:solidFill>
+                      <a:prstDash val="solid"/>
+                      <a:round/>
+                      <a:headEnd type="none" w="med" len="med"/>
+                      <a:tailEnd type="none" w="med" len="med"/>
+                    </a:lnR>
+                    <a:lnT w="25400" cap="flat" cmpd="sng" algn="ctr">
+                      <a:solidFill>
+                        <a:srgbClr val="0A0A0F"/>
+                      </a:solidFill>
+                      <a:prstDash val="solid"/>
+                      <a:round/>
+                      <a:headEnd type="none" w="med" len="med"/>
+                      <a:tailEnd type="none" w="med" len="med"/>
+                    </a:lnT>
+                    <a:lnB w="25400" cap="flat" cmpd="sng" algn="ctr">
+                      <a:solidFill>
+                        <a:srgbClr val="0A0A0F"/>
+                      </a:solidFill>
+                      <a:prstDash val="solid"/>
+                      <a:round/>
+                      <a:headEnd type="none" w="med" len="med"/>
+                      <a:tailEnd type="none" w="med" len="med"/>
+                    </a:lnB>
+                    <a:solidFill>
+                      <a:srgbClr val="18181B"/>
+                    </a:solidFill>
+                  </a:tcPr>
+                </a:tc>
+                <a:tc>
+                  <a:txBody>
+                    <a:bodyPr/>
+                    <a:lstStyle/>
+                    <a:p>
+                      <a:pPr indent="0" marL="0">
+                        <a:buNone/>
+                      </a:pPr>
+                      <a:r>
+                        <a:rPr lang="en-US" sz="1300" dirty="0">
+                          <a:solidFill>
+                            <a:srgbClr val="E4E4E7"/>
+                          </a:solidFill>
+                          <a:latin typeface="Calibri" pitchFamily="34" charset="0"/>
+                          <a:ea typeface="Calibri" pitchFamily="34" charset="-122"/>
+                          <a:cs typeface="Calibri" pitchFamily="34" charset="-120"/>
+                        </a:rPr>
+                        <a:t>Ikke noe innebygd lag. Handel betyr en sentralisert børs.</a:t>
+                      </a:r>
+                      <a:endParaRPr lang="en-US" sz="1300" dirty="0">
+                        <a:latin typeface="Calibri" charset="0"/>
+                        <a:ea typeface="Calibri" charset="0"/>
+                        <a:cs typeface="Calibri" charset="0"/>
+                      </a:endParaRPr>
+                    </a:p>
+                  </a:txBody>
+                  <a:tcPr marL="101600" marR="101600" marT="76200" marB="76200" anchor="ctr">
+                    <a:lnL w="25400" cap="flat" cmpd="sng" algn="ctr">
+                      <a:solidFill>
+                        <a:srgbClr val="0A0A0F"/>
+                      </a:solidFill>
+                      <a:prstDash val="solid"/>
+                      <a:round/>
+                      <a:headEnd type="none" w="med" len="med"/>
+                      <a:tailEnd type="none" w="med" len="med"/>
+                    </a:lnL>
+                    <a:lnR w="25400" cap="flat" cmpd="sng" algn="ctr">
+                      <a:solidFill>
+                        <a:srgbClr val="0A0A0F"/>
+                      </a:solidFill>
+                      <a:prstDash val="solid"/>
+                      <a:round/>
+                      <a:headEnd type="none" w="med" len="med"/>
+                      <a:tailEnd type="none" w="med" len="med"/>
+                    </a:lnR>
+                    <a:lnT w="25400" cap="flat" cmpd="sng" algn="ctr">
+                      <a:solidFill>
+                        <a:srgbClr val="0A0A0F"/>
+                      </a:solidFill>
+                      <a:prstDash val="solid"/>
+                      <a:round/>
+                      <a:headEnd type="none" w="med" len="med"/>
+                      <a:tailEnd type="none" w="med" len="med"/>
+                    </a:lnT>
+                    <a:lnB w="25400" cap="flat" cmpd="sng" algn="ctr">
+                      <a:solidFill>
+                        <a:srgbClr val="0A0A0F"/>
+                      </a:solidFill>
+                      <a:prstDash val="solid"/>
+                      <a:round/>
+                      <a:headEnd type="none" w="med" len="med"/>
+                      <a:tailEnd type="none" w="med" len="med"/>
+                    </a:lnB>
+                    <a:solidFill>
+                      <a:srgbClr val="2A1A0C"/>
+                    </a:solidFill>
+                  </a:tcPr>
+                </a:tc>
+                <a:tc>
+                  <a:txBody>
+                    <a:bodyPr/>
+                    <a:lstStyle/>
+                    <a:p>
+                      <a:pPr indent="0" marL="0">
+                        <a:buNone/>
+                      </a:pPr>
+                      <a:r>
+                        <a:rPr lang="en-US" sz="1300" dirty="0">
+                          <a:solidFill>
+                            <a:srgbClr val="E4E4E7"/>
+                          </a:solidFill>
+                          <a:latin typeface="Calibri" pitchFamily="34" charset="0"/>
+                          <a:ea typeface="Calibri" pitchFamily="34" charset="-122"/>
+                          <a:cs typeface="Calibri" pitchFamily="34" charset="-120"/>
+                        </a:rPr>
+                        <a:t>DEX-kontrakter på kjeden, gass for hver ordre og handel.</a:t>
+                      </a:r>
+                      <a:endParaRPr lang="en-US" sz="1300" dirty="0">
+                        <a:latin typeface="Calibri" charset="0"/>
+                        <a:ea typeface="Calibri" charset="0"/>
+                        <a:cs typeface="Calibri" charset="0"/>
+                      </a:endParaRPr>
+                    </a:p>
+                  </a:txBody>
+                  <a:tcPr marL="101600" marR="101600" marT="76200" marB="76200" anchor="ctr">
+                    <a:lnL w="25400" cap="flat" cmpd="sng" algn="ctr">
+                      <a:solidFill>
+                        <a:srgbClr val="0A0A0F"/>
+                      </a:solidFill>
+                      <a:prstDash val="solid"/>
+                      <a:round/>
+                      <a:headEnd type="none" w="med" len="med"/>
+                      <a:tailEnd type="none" w="med" len="med"/>
+                    </a:lnL>
+                    <a:lnR w="25400" cap="flat" cmpd="sng" algn="ctr">
+                      <a:solidFill>
+                        <a:srgbClr val="0A0A0F"/>
+                      </a:solidFill>
+                      <a:prstDash val="solid"/>
+                      <a:round/>
+                      <a:headEnd type="none" w="med" len="med"/>
+                      <a:tailEnd type="none" w="med" len="med"/>
+                    </a:lnR>
+                    <a:lnT w="25400" cap="flat" cmpd="sng" algn="ctr">
+                      <a:solidFill>
+                        <a:srgbClr val="0A0A0F"/>
+                      </a:solidFill>
+                      <a:prstDash val="solid"/>
+                      <a:round/>
+                      <a:headEnd type="none" w="med" len="med"/>
+                      <a:tailEnd type="none" w="med" len="med"/>
+                    </a:lnT>
+                    <a:lnB w="25400" cap="flat" cmpd="sng" algn="ctr">
+                      <a:solidFill>
+                        <a:srgbClr val="0A0A0F"/>
+                      </a:solidFill>
+                      <a:prstDash val="solid"/>
+                      <a:round/>
+                      <a:headEnd type="none" w="med" len="med"/>
+                      <a:tailEnd type="none" w="med" len="med"/>
+                    </a:lnB>
+                    <a:solidFill>
+                      <a:srgbClr val="1A1F3A"/>
+                    </a:solidFill>
+                  </a:tcPr>
+                </a:tc>
+                <a:tc>
+                  <a:txBody>
+                    <a:bodyPr/>
+                    <a:lstStyle/>
+                    <a:p>
+                      <a:pPr indent="0" marL="0">
+                        <a:buNone/>
+                      </a:pPr>
+                      <a:r>
+                        <a:rPr lang="en-US" sz="1300" dirty="0">
+                          <a:solidFill>
+                            <a:srgbClr val="E4E4E7"/>
+                          </a:solidFill>
+                          <a:latin typeface="Calibri" pitchFamily="34" charset="0"/>
+                          <a:ea typeface="Calibri" pitchFamily="34" charset="-122"/>
+                          <a:cs typeface="Calibri" pitchFamily="34" charset="-120"/>
+                        </a:rPr>
+                        <a:t>CAPD open outcry: kringkast tilbudet utenfor kjeden, gjør opp på kjeden, ingen børs imellom.</a:t>
+                      </a:r>
+                      <a:endParaRPr lang="en-US" sz="1300" dirty="0">
+                        <a:latin typeface="Calibri" charset="0"/>
+                        <a:ea typeface="Calibri" charset="0"/>
+                        <a:cs typeface="Calibri" charset="0"/>
+                      </a:endParaRPr>
+                    </a:p>
+                  </a:txBody>
+                  <a:tcPr marL="101600" marR="101600" marT="76200" marB="76200" anchor="ctr">
+                    <a:lnL w="25400" cap="flat" cmpd="sng" algn="ctr">
+                      <a:solidFill>
+                        <a:srgbClr val="0A0A0F"/>
+                      </a:solidFill>
+                      <a:prstDash val="solid"/>
+                      <a:round/>
+                      <a:headEnd type="none" w="med" len="med"/>
+                      <a:tailEnd type="none" w="med" len="med"/>
+                    </a:lnL>
+                    <a:lnR w="25400" cap="flat" cmpd="sng" algn="ctr">
+                      <a:solidFill>
+                        <a:srgbClr val="0A0A0F"/>
+                      </a:solidFill>
+                      <a:prstDash val="solid"/>
+                      <a:round/>
+                      <a:headEnd type="none" w="med" len="med"/>
+                      <a:tailEnd type="none" w="med" len="med"/>
+                    </a:lnR>
+                    <a:lnT w="25400" cap="flat" cmpd="sng" algn="ctr">
+                      <a:solidFill>
+                        <a:srgbClr val="0A0A0F"/>
+                      </a:solidFill>
+                      <a:prstDash val="solid"/>
+                      <a:round/>
+                      <a:headEnd type="none" w="med" len="med"/>
+                      <a:tailEnd type="none" w="med" len="med"/>
+                    </a:lnT>
+                    <a:lnB w="25400" cap="flat" cmpd="sng" algn="ctr">
+                      <a:solidFill>
+                        <a:srgbClr val="0A0A0F"/>
+                      </a:solidFill>
+                      <a:prstDash val="solid"/>
+                      <a:round/>
+                      <a:headEnd type="none" w="med" len="med"/>
+                      <a:tailEnd type="none" w="med" len="med"/>
+                    </a:lnB>
+                    <a:solidFill>
+                      <a:srgbClr val="26210F"/>
+                    </a:solidFill>
+                  </a:tcPr>
+                </a:tc>
+              </a:tr>
             </a:tbl>
           </a:graphicData>
         </a:graphic>
@@ -6360,7 +7367,7 @@
                 <a:ea typeface="Calibri" pitchFamily="34" charset="-122"/>
                 <a:cs typeface="Calibri" pitchFamily="34" charset="-120"/>
               </a:rPr>
-              <a:t>14</a:t>
+              <a:t>15</a:t>
             </a:r>
             <a:endParaRPr lang="en-US" sz="1000" dirty="0"/>
           </a:p>
@@ -6374,9 +7381,9 @@
 </p:sld>
 </file>
 
-<file path=ppt/slides/slide15.xml><?xml version="1.0" encoding="utf-8"?>
+<file path=ppt/slides/slide16.xml><?xml version="1.0" encoding="utf-8"?>
 <p:sld xmlns:a="http://schemas.openxmlformats.org/drawingml/2006/main" xmlns:r="http://schemas.openxmlformats.org/officeDocument/2006/relationships" xmlns:p="http://schemas.openxmlformats.org/presentationml/2006/main">
-  <p:cSld name="Slide 15">
+  <p:cSld name="Slide 16">
     <p:bg>
       <p:bgPr>
         <a:solidFill>
@@ -6893,7 +7900,7 @@
                 <a:ea typeface="Calibri" pitchFamily="34" charset="-122"/>
                 <a:cs typeface="Calibri" pitchFamily="34" charset="-120"/>
               </a:rPr>
-              <a:t>Betalinger på to sekunder for under et øre og protokoll-innebygde tokens for spill, billetter og identitet. Bygget for bruk, ikke for spekulasjon.</a:t>
+              <a:t>Betalinger på to sekunder for under et øre, protokoll-innebygde tokens for spill, billetter og identitet, og open outcry-handel over CAPD. Bygget for bruk, ikke for spekulasjon.</a:t>
             </a:r>
             <a:endParaRPr lang="en-US" sz="1500" dirty="0"/>
           </a:p>
@@ -7034,7 +8041,7 @@
                 <a:ea typeface="Calibri" pitchFamily="34" charset="-122"/>
                 <a:cs typeface="Calibri" pitchFamily="34" charset="-120"/>
               </a:rPr>
-              <a:t>15</a:t>
+              <a:t>16</a:t>
             </a:r>
             <a:endParaRPr lang="en-US" sz="1000" dirty="0"/>
           </a:p>

</xml_diff>

<commit_message>
Nexa deck: authority batons, Token Secrets, wallet identity and payments, Tailstorm (19 slides)
</commit_message>
<xml_diff>
--- a/docs/nexa-vs-bitcoin-ethereum/Nexa-vs-Bitcoin-Ethereum-NO.pptx
+++ b/docs/nexa-vs-bitcoin-ethereum/Nexa-vs-Bitcoin-Ethereum-NO.pptx
@@ -21,9 +21,12 @@
     <p:sldId id="269" r:id="rId15"/>
     <p:sldId id="270" r:id="rId16"/>
     <p:sldId id="271" r:id="rId17"/>
+    <p:sldId id="272" r:id="rId18"/>
+    <p:sldId id="273" r:id="rId19"/>
+    <p:sldId id="274" r:id="rId20"/>
   </p:sldIdLst>
   <p:notesMasterIdLst>
-    <p:notesMasterId r:id="rId18"/>
+    <p:notesMasterId r:id="rId21"/>
   </p:notesMasterIdLst>
   <p:sldSz cx="12192000" cy="6858000"/>
   <p:notesSz cx="6858000" cy="12192000"/>
@@ -605,7 +608,7 @@
           <a:p>
             <a:r>
               <a:rPr lang="en-US" dirty="0"/>
-              <a:t>Gebyrtall fra explorer.nexa.org 15. sept. 2026: nettverkets gebyrsats er 1 satoshi per byte, og en enkel transaksjon er 250 til 320 byte, altså 2,5 til 3,2 NEXA (100 satoshi = 1 NEXA). Med explorerens kurs på 0,0000013 dollar per NEXA blir det rundt 0,000004 dollar, omtrent 0,004 øre. Oppdater kursen før du presenterer. nexa.org: «confirms in under two seconds with near-zero fees», «under $0.0001 per transaction». Nullbekreftelse med bevis mot dobbeltforbruk er Bitcoin Unlimited-teknologi videreført i Nexa. Vipps-referansen: Norge er nesten kontantløst; poenget er at brukeropplevelsen nordmenn forventer allerede er grunnlinjen her.</a:t>
+              <a:t>Tailstorm (spec.nexa.org/blocks/tailstorm): etter Hard Fork 2 støttes hver to-minutters oppsummeringsblokk av 120 underblokker, omtrent én i sekundet, som gir et sannsynlig, energistøttet signal om inkludering innen ett sekund og jevnere inntekt for minere; selve hovedboken gjøres fortsatt opp av to-minutters-kjeden. Gebyrtall fra explorer.nexa.org 15. sept. 2026: nettverkets gebyrsats er 1 satoshi per byte, og en enkel transaksjon er 250 til 320 byte, altså 2,5 til 3,2 NEXA (100 satoshi = 1 NEXA). Med explorerens kurs på 0,0000013 dollar per NEXA blir det rundt 0,000004 dollar, omtrent 0,004 øre. Oppdater kursen før du presenterer. nexa.org: «confirms in under two seconds with near-zero fees», «under $0.0001 per transaction». Nullbekreftelse med bevis mot dobbeltforbruk er Bitcoin Unlimited-teknologi videreført i Nexa. Vipps-referansen: Norge er nesten kontantløst; poenget er at brukeropplevelsen nordmenn forventer allerede er grunnlinjen her.</a:t>
             </a:r>
             <a:endParaRPr lang="en-US" dirty="0"/>
           </a:p>
@@ -781,7 +784,7 @@
           <a:p>
             <a:r>
               <a:rPr lang="en-US" dirty="0"/>
-              <a:t>CAPD er unikt for Nexa: en desentralisert, proof-of-work-begrenset, flyktig meldingsbuss på P2P-nettverket (spesifikasjon: spec.nexa.org/network/capd). Open outcry: børsgulv-modellen der tilbud ropes ut offentlig og hvem som helst kan ta dem. Mekanikk: tilbudet er en delvis signert transaksjon; det annonserte sammendraget (hvilken token for hvilken) er bare veiledende, den halvsignerte transaksjonen er det som gjelder, så en løgnaktig annonse er ufarlig: den som tar tilbudet får nøyaktig det transaksjonen sier, ellers er den ugyldig. Meldinger har opprettelsestid og utløp, videresendingsprioriteten faller til null etter rundt 600 sekunder, og en tilbakekallingshash lar avsenderen trekke tilbudet tidlig. Bruk: token- og NFT-markedsplasser uten markedsplassoperatør, handel med gjenstander i spill, atomiske bytter, oppretting av multisig-lommebøker og signeringsrunder. Kontrast: Bitcoin har ikke noe oppdagelseslag, så handel betyr sentraliserte børser; Ethereum trenger en DEX-kontrakt på kjeden og betaler gass for hver ordre og handel.</a:t>
+              <a:t>Kilde: spec.nexa.org/tokens/grouptokens og token-biblioteket i libnexakotlin. Autoritets-outputs bærer en negativ fortegn-og-størrelse-verdi i mengdefeltet med flaggbitene AUTHORITY, MINT, MELT, BATON, RESCRIPT og SUBGROUP. Utstedelse er å bruke en MINT-autoritet; destruksjon krever MELT; SUBGROUP lager undergrupper (NFT-er og SFT-er under en forelder). BATON er hovedretten til å lage nye autoriteter, så rutinemessig utstedelse bør bruke en ren MINT-autoritet og bevare batongen; lommebøker holder en pool av ledige MINT-autoriteter så samtidige utstedelser ikke slåss om én UTXO. Autoriteter er vanlige outputs: betal én til en annen adresse for å delegere, eller til en kontrakts låseskript så kontrakten styrer utstedelsen (mint-on-demand som en halvsignert transaksjon kjøperen finansierer). Read-only inputs (spec.nexa.org/script/read-only-inputs) lar en BATON-autoritet gi rettigheter til en transaksjon uten å bli brukt. Kontrast: ERC-20-utstedelse er en privilegert funksjon beskyttet av en eiernøkkel inne i kontrakten; på Nexa er retten en mynt du kan dele, sende, låse eller destruere.</a:t>
             </a:r>
             <a:endParaRPr lang="en-US" dirty="0"/>
           </a:p>
@@ -869,7 +872,7 @@
           <a:p>
             <a:r>
               <a:rPr lang="en-US" dirty="0"/>
-              <a:t>nexa.org: «Native on-chain programmability without EVM complexity», «No EVM overhead». Utviklerstacken: Wally-lommebok, TDPP-betalingsprotokoll, nexid-identitet, CAPD-meldinger, NexaJS og libnexakotlin. Hold denne sliden kort for et ikke-teknisk publikum; utdyp bare hvis noen spør.</a:t>
+              <a:t>CAPD er unikt for Nexa: en desentralisert, proof-of-work-begrenset, flyktig meldingsbuss på P2P-nettverket (spesifikasjon: spec.nexa.org/network/capd). Open outcry: børsgulv-modellen der tilbud ropes ut offentlig og hvem som helst kan ta dem. Mekanikk: tilbudet er en delvis signert transaksjon; det annonserte sammendraget (hvilken token for hvilken) er bare veiledende, den halvsignerte transaksjonen er det som gjelder, så en løgnaktig annonse er ufarlig: den som tar tilbudet får nøyaktig det transaksjonen sier, ellers er den ugyldig. Meldinger har opprettelsestid og utløp, videresendingsprioriteten faller til null etter rundt 600 sekunder, og en tilbakekallingshash lar avsenderen trekke tilbudet tidlig. Bruk: token- og NFT-markedsplasser uten markedsplassoperatør, handel med gjenstander i spill, atomiske bytter, oppretting av multisig-lommebøker og signeringsrunder. Kontrast: Bitcoin har ikke noe oppdagelseslag, så handel betyr sentraliserte børser; Ethereum trenger en DEX-kontrakt på kjeden og betaler gass for hver ordre og handel.</a:t>
             </a:r>
             <a:endParaRPr lang="en-US" dirty="0"/>
           </a:p>
@@ -957,7 +960,7 @@
           <a:p>
             <a:r>
               <a:rPr lang="en-US" dirty="0"/>
-              <a:t>SSB: 98 % av Norges strøm fra vann og vind (sent 2025); normal årsproduksjon ~157 TWh, forbruk ~140 TWh. Juni 2025: regjeringen varslet et midlertidig forbud mot nye proof-of-work-datasentre for mining, med obligatorisk datasenterregister; myndighetene har antydet at det kan bli permanent. Vær ærlig: forbudet gjelder PoW-mining generelt, så en Nexa-farm ville også vært omfattet. Poenget er at Nexas nettverk ikke er avhengig av farmer noe sted.</a:t>
+              <a:t>Kilde: spec.nexa.org/tokensecret (Token Secrets, også kalt Atomic Secret Exchange, ASE, og grunnlaget for private NFT-er). Kravene protokollen oppfyller: overføringen avslører hemmeligheten for mottakeren samtidig med tokenet; transaksjonen avslører ingenting for tredjeparter selv om den ligger på en offentlig kjede; mottakeren eller kjeden verifiserer at den kommuniserte hemmeligheten stemmer med den tokenet forpliktet seg til. Mekanikk: hemmeligheten må være en privat EC-nøkkel med offentlig nøkkel forpliktet i utstedelsen eller gruppe-ID-en; Alice og Bob bygger en halvtransaksjon der Bobs input krever to signaturer, én fra hemmelighetens nøkkel og én fra en nøkkel bare Bob har; en ECDH-delt hemmelighet krypterer den private nøkkelen til Bob. Forbehold fra spesifikasjonen: etter overføringen kjenner Alice fortsatt nøkkelen, så dette passer for salg av tilgang til innhold der perfekt DRM er urealistisk; verdien er verifisering mot utbytting under handelen.</a:t>
             </a:r>
             <a:endParaRPr lang="en-US" dirty="0"/>
           </a:p>
@@ -1045,7 +1048,7 @@
           <a:p>
             <a:r>
               <a:rPr lang="en-US" dirty="0"/>
-              <a:t>Ett-slides svar på arrangørenes tre temaer: energi og e-avfall, hvem som tjener på det, og NFT-spekulasjon. Hvert tall står tidligere i presentasjonen med kilde.</a:t>
+              <a:t>nexa.org: «Native on-chain programmability without EVM complexity», «No EVM overhead». Utviklerstacken: Wally-lommebok, TDPP-betalingsprotokoll, nexid-identitet, CAPD-meldinger, NexaJS og libnexakotlin. Hold denne sliden kort for et ikke-teknisk publikum; utdyp bare hvis noen spør.</a:t>
             </a:r>
             <a:endParaRPr lang="en-US" dirty="0"/>
           </a:p>
@@ -1133,7 +1136,7 @@
           <a:p>
             <a:r>
               <a:rPr lang="en-US" dirty="0"/>
-              <a:t>Avslutt med de tre svarene på de tre bekymringene. Hvis 13 000×-tallet utfordres: det er en kapasitetssammenligning ved lik nettverkseffekt, 5 600× på dagens benchmark og 13 000× med Blitz; gulvet er 1 000× fordi Bitcoin ikke kan overstige ~14 TPS.</a:t>
+              <a:t>Kilder: spec.nexa.org/nexid (Nexa Identity Protocol), spec.nexa.org/transactions/challengeTransaction, spec.nexa.org/dpp (Delegated Payment Protocol). nexid: nettstedet presenterer et innloggingstilbud med en tilfeldig utfordring via QR eller nettleserutvidelse; lommeboken avleder en nettstedsspesifikk privat nøkkel fra hovednøkkelen pluss et valgfritt nettstedspassord, signerer og sender den signerte meldingen direkte til serveren utenom den ubetrodde datamaskinen; sikkerhetskopi er de 12 ordene. Challenge transactions: en transaksjon med høyeste bit i versjonsfeltet satt er ugyldig for alltid; ett data-output bærer utfordrerens identitet og en tilfeldig utfordring; å signere den beviser kontroll over de refererte UTXO-ene under et hvilket som helst skript, noe vanlig meldingssignering ikke kan for multisig eller kontrakter. DPP: aktøren registrerer seg med foreslåtte grenser og sender signerte betalingsforespørsler; lommeboken, ikke butikken, avgjør automatisk eller godkjent utførelse. For et norsk publikum: BankID for innlogging, AvtaleGiro og kort på fil for betalinger er de kjente sammenligningene.</a:t>
             </a:r>
             <a:endParaRPr lang="en-US" dirty="0"/>
           </a:p>
@@ -1157,6 +1160,270 @@
             <a:fld id="{F7021451-1387-4CA6-816F-3879F97B5CBC}" type="slidenum">
               <a:rPr lang="en-US"/>
               <a:t>16</a:t>
+            </a:fld>
+            <a:endParaRPr lang="en-US"/>
+          </a:p>
+        </p:txBody>
+      </p:sp>
+    </p:spTree>
+    <p:extLst>
+      <p:ext uri="{BB962C8B-B14F-4D97-AF65-F5344CB8AC3E}">
+        <p14:creationId xmlns:p14="http://schemas.microsoft.com/office/powerpoint/2010/main" val="1024086991"/>
+      </p:ext>
+    </p:extLst>
+  </p:cSld>
+  <p:clrMapOvr>
+    <a:masterClrMapping/>
+  </p:clrMapOvr>
+</p:notes>
+</file>
+
+<file path=ppt/notesSlides/notesSlide17.xml><?xml version="1.0" encoding="utf-8"?>
+<p:notes xmlns:a="http://schemas.openxmlformats.org/drawingml/2006/main" xmlns:r="http://schemas.openxmlformats.org/officeDocument/2006/relationships" xmlns:p="http://schemas.openxmlformats.org/presentationml/2006/main">
+  <p:cSld>
+    <p:spTree>
+      <p:nvGrpSpPr>
+        <p:cNvPr id="1" name=""/>
+        <p:cNvGrpSpPr/>
+        <p:nvPr/>
+      </p:nvGrpSpPr>
+      <p:grpSpPr>
+        <a:xfrm>
+          <a:off x="0" y="0"/>
+          <a:ext cx="0" cy="0"/>
+          <a:chOff x="0" y="0"/>
+          <a:chExt cx="0" cy="0"/>
+        </a:xfrm>
+      </p:grpSpPr>
+      <p:sp>
+        <p:nvSpPr>
+          <p:cNvPr id="2" name="Slide Image Placeholder 1"/>
+          <p:cNvSpPr>
+            <a:spLocks noGrp="1" noRot="1" noChangeAspect="1"/>
+          </p:cNvSpPr>
+          <p:nvPr>
+            <p:ph type="sldImg"/>
+          </p:nvPr>
+        </p:nvSpPr>
+        <p:spPr/>
+      </p:sp>
+      <p:sp>
+        <p:nvSpPr>
+          <p:cNvPr id="3" name="Notes Placeholder 2"/>
+          <p:cNvSpPr>
+            <a:spLocks noGrp="1"/>
+          </p:cNvSpPr>
+          <p:nvPr>
+            <p:ph type="body" idx="1"/>
+          </p:nvPr>
+        </p:nvSpPr>
+        <p:spPr/>
+        <p:txBody>
+          <a:bodyPr/>
+          <a:lstStyle/>
+          <a:p>
+            <a:r>
+              <a:rPr lang="en-US" dirty="0"/>
+              <a:t>SSB: 98 % av Norges strøm fra vann og vind (sent 2025); normal årsproduksjon ~157 TWh, forbruk ~140 TWh. Juni 2025: regjeringen varslet et midlertidig forbud mot nye proof-of-work-datasentre for mining, med obligatorisk datasenterregister; myndighetene har antydet at det kan bli permanent. Vær ærlig: forbudet gjelder PoW-mining generelt, så en Nexa-farm ville også vært omfattet. Poenget er at Nexas nettverk ikke er avhengig av farmer noe sted.</a:t>
+            </a:r>
+            <a:endParaRPr lang="en-US" dirty="0"/>
+          </a:p>
+        </p:txBody>
+      </p:sp>
+      <p:sp>
+        <p:nvSpPr>
+          <p:cNvPr id="4" name="Slide Number Placeholder 3"/>
+          <p:cNvSpPr>
+            <a:spLocks noGrp="1"/>
+          </p:cNvSpPr>
+          <p:nvPr>
+            <p:ph type="sldNum" sz="quarter" idx="10"/>
+          </p:nvPr>
+        </p:nvSpPr>
+        <p:spPr/>
+        <p:txBody>
+          <a:bodyPr/>
+          <a:lstStyle/>
+          <a:p>
+            <a:fld id="{F7021451-1387-4CA6-816F-3879F97B5CBC}" type="slidenum">
+              <a:rPr lang="en-US"/>
+              <a:t>17</a:t>
+            </a:fld>
+            <a:endParaRPr lang="en-US"/>
+          </a:p>
+        </p:txBody>
+      </p:sp>
+    </p:spTree>
+    <p:extLst>
+      <p:ext uri="{BB962C8B-B14F-4D97-AF65-F5344CB8AC3E}">
+        <p14:creationId xmlns:p14="http://schemas.microsoft.com/office/powerpoint/2010/main" val="1024086991"/>
+      </p:ext>
+    </p:extLst>
+  </p:cSld>
+  <p:clrMapOvr>
+    <a:masterClrMapping/>
+  </p:clrMapOvr>
+</p:notes>
+</file>
+
+<file path=ppt/notesSlides/notesSlide18.xml><?xml version="1.0" encoding="utf-8"?>
+<p:notes xmlns:a="http://schemas.openxmlformats.org/drawingml/2006/main" xmlns:r="http://schemas.openxmlformats.org/officeDocument/2006/relationships" xmlns:p="http://schemas.openxmlformats.org/presentationml/2006/main">
+  <p:cSld>
+    <p:spTree>
+      <p:nvGrpSpPr>
+        <p:cNvPr id="1" name=""/>
+        <p:cNvGrpSpPr/>
+        <p:nvPr/>
+      </p:nvGrpSpPr>
+      <p:grpSpPr>
+        <a:xfrm>
+          <a:off x="0" y="0"/>
+          <a:ext cx="0" cy="0"/>
+          <a:chOff x="0" y="0"/>
+          <a:chExt cx="0" cy="0"/>
+        </a:xfrm>
+      </p:grpSpPr>
+      <p:sp>
+        <p:nvSpPr>
+          <p:cNvPr id="2" name="Slide Image Placeholder 1"/>
+          <p:cNvSpPr>
+            <a:spLocks noGrp="1" noRot="1" noChangeAspect="1"/>
+          </p:cNvSpPr>
+          <p:nvPr>
+            <p:ph type="sldImg"/>
+          </p:nvPr>
+        </p:nvSpPr>
+        <p:spPr/>
+      </p:sp>
+      <p:sp>
+        <p:nvSpPr>
+          <p:cNvPr id="3" name="Notes Placeholder 2"/>
+          <p:cNvSpPr>
+            <a:spLocks noGrp="1"/>
+          </p:cNvSpPr>
+          <p:nvPr>
+            <p:ph type="body" idx="1"/>
+          </p:nvPr>
+        </p:nvSpPr>
+        <p:spPr/>
+        <p:txBody>
+          <a:bodyPr/>
+          <a:lstStyle/>
+          <a:p>
+            <a:r>
+              <a:rPr lang="en-US" dirty="0"/>
+              <a:t>Ett-slides svar på arrangørenes tre temaer: energi og e-avfall, hvem som tjener på det, og NFT-spekulasjon. Hvert tall står tidligere i presentasjonen med kilde.</a:t>
+            </a:r>
+            <a:endParaRPr lang="en-US" dirty="0"/>
+          </a:p>
+        </p:txBody>
+      </p:sp>
+      <p:sp>
+        <p:nvSpPr>
+          <p:cNvPr id="4" name="Slide Number Placeholder 3"/>
+          <p:cNvSpPr>
+            <a:spLocks noGrp="1"/>
+          </p:cNvSpPr>
+          <p:nvPr>
+            <p:ph type="sldNum" sz="quarter" idx="10"/>
+          </p:nvPr>
+        </p:nvSpPr>
+        <p:spPr/>
+        <p:txBody>
+          <a:bodyPr/>
+          <a:lstStyle/>
+          <a:p>
+            <a:fld id="{F7021451-1387-4CA6-816F-3879F97B5CBC}" type="slidenum">
+              <a:rPr lang="en-US"/>
+              <a:t>18</a:t>
+            </a:fld>
+            <a:endParaRPr lang="en-US"/>
+          </a:p>
+        </p:txBody>
+      </p:sp>
+    </p:spTree>
+    <p:extLst>
+      <p:ext uri="{BB962C8B-B14F-4D97-AF65-F5344CB8AC3E}">
+        <p14:creationId xmlns:p14="http://schemas.microsoft.com/office/powerpoint/2010/main" val="1024086991"/>
+      </p:ext>
+    </p:extLst>
+  </p:cSld>
+  <p:clrMapOvr>
+    <a:masterClrMapping/>
+  </p:clrMapOvr>
+</p:notes>
+</file>
+
+<file path=ppt/notesSlides/notesSlide19.xml><?xml version="1.0" encoding="utf-8"?>
+<p:notes xmlns:a="http://schemas.openxmlformats.org/drawingml/2006/main" xmlns:r="http://schemas.openxmlformats.org/officeDocument/2006/relationships" xmlns:p="http://schemas.openxmlformats.org/presentationml/2006/main">
+  <p:cSld>
+    <p:spTree>
+      <p:nvGrpSpPr>
+        <p:cNvPr id="1" name=""/>
+        <p:cNvGrpSpPr/>
+        <p:nvPr/>
+      </p:nvGrpSpPr>
+      <p:grpSpPr>
+        <a:xfrm>
+          <a:off x="0" y="0"/>
+          <a:ext cx="0" cy="0"/>
+          <a:chOff x="0" y="0"/>
+          <a:chExt cx="0" cy="0"/>
+        </a:xfrm>
+      </p:grpSpPr>
+      <p:sp>
+        <p:nvSpPr>
+          <p:cNvPr id="2" name="Slide Image Placeholder 1"/>
+          <p:cNvSpPr>
+            <a:spLocks noGrp="1" noRot="1" noChangeAspect="1"/>
+          </p:cNvSpPr>
+          <p:nvPr>
+            <p:ph type="sldImg"/>
+          </p:nvPr>
+        </p:nvSpPr>
+        <p:spPr/>
+      </p:sp>
+      <p:sp>
+        <p:nvSpPr>
+          <p:cNvPr id="3" name="Notes Placeholder 2"/>
+          <p:cNvSpPr>
+            <a:spLocks noGrp="1"/>
+          </p:cNvSpPr>
+          <p:nvPr>
+            <p:ph type="body" idx="1"/>
+          </p:nvPr>
+        </p:nvSpPr>
+        <p:spPr/>
+        <p:txBody>
+          <a:bodyPr/>
+          <a:lstStyle/>
+          <a:p>
+            <a:r>
+              <a:rPr lang="en-US" dirty="0"/>
+              <a:t>Avslutt med de tre svarene på de tre bekymringene. Hvis 13 000×-tallet utfordres: det er en kapasitetssammenligning ved lik nettverkseffekt, 5 600× på dagens benchmark og 13 000× med Blitz; gulvet er 1 000× fordi Bitcoin ikke kan overstige ~14 TPS.</a:t>
+            </a:r>
+            <a:endParaRPr lang="en-US" dirty="0"/>
+          </a:p>
+        </p:txBody>
+      </p:sp>
+      <p:sp>
+        <p:nvSpPr>
+          <p:cNvPr id="4" name="Slide Number Placeholder 3"/>
+          <p:cNvSpPr>
+            <a:spLocks noGrp="1"/>
+          </p:cNvSpPr>
+          <p:nvPr>
+            <p:ph type="sldNum" sz="quarter" idx="10"/>
+          </p:nvPr>
+        </p:nvSpPr>
+        <p:spPr/>
+        <p:txBody>
+          <a:bodyPr/>
+          <a:lstStyle/>
+          <a:p>
+            <a:fld id="{F7021451-1387-4CA6-816F-3879F97B5CBC}" type="slidenum">
+              <a:rPr lang="en-US"/>
+              <a:t>19</a:t>
             </a:fld>
             <a:endParaRPr lang="en-US"/>
           </a:p>
@@ -2800,7 +3067,7 @@
                 <a:ea typeface="Calibri" pitchFamily="34" charset="-122"/>
                 <a:cs typeface="Calibri" pitchFamily="34" charset="-120"/>
               </a:rPr>
-              <a:t>Nullbekreftelses-betalinger sikret med bevis mot dobbeltforbruk bekreftes på under to sekunder. Blokker kommer hvert andre minutt. Ingen venting i en time på seks bekreftelser.</a:t>
+              <a:t>Nullbekreftelses-betalinger sikret med bevis mot dobbeltforbruk bekreftes på under to sekunder. Blokker kommer hvert andre minutt, og etter Hard Fork 2 gir Tailstorm en proof-of-work-støttet underblokk hvert sekund.</a:t>
             </a:r>
             <a:endParaRPr lang="en-US" sz="1500" dirty="0"/>
           </a:p>
@@ -3931,7 +4198,7 @@
                 <a:ea typeface="Calibri" pitchFamily="34" charset="-122"/>
                 <a:cs typeface="Calibri" pitchFamily="34" charset="-120"/>
               </a:rPr>
-              <a:t>Open outcry-handel over CAPD: rop ut et tilbud, hvem som helst kan ta det</a:t>
+              <a:t>Utstedelsesretten er også en mynt: autoritetsbatonger</a:t>
             </a:r>
             <a:endParaRPr lang="en-US" sz="3000" dirty="0"/>
           </a:p>
@@ -3946,7 +4213,7 @@
         <p:spPr>
           <a:xfrm>
             <a:off x="548640" y="1691640"/>
-            <a:ext cx="3515258" cy="3657600"/>
+            <a:ext cx="3515258" cy="4206240"/>
           </a:xfrm>
           <a:prstGeom prst="roundRect">
             <a:avLst>
@@ -4046,7 +4313,7 @@
                 <a:ea typeface="Calibri" pitchFamily="34" charset="-122"/>
                 <a:cs typeface="Calibri" pitchFamily="34" charset="-120"/>
               </a:rPr>
-              <a:t>Rop tilbudet ut til nettverket</a:t>
+              <a:t>Autoriteten ligger i en UTXO</a:t>
             </a:r>
             <a:endParaRPr lang="en-US" sz="1800" dirty="0"/>
           </a:p>
@@ -4061,7 +4328,7 @@
         <p:spPr>
           <a:xfrm>
             <a:off x="822960" y="3474720"/>
-            <a:ext cx="2966618" cy="1600200"/>
+            <a:ext cx="2966618" cy="2148840"/>
           </a:xfrm>
           <a:prstGeom prst="rect">
             <a:avLst/>
@@ -4088,7 +4355,7 @@
                 <a:ea typeface="Calibri" pitchFamily="34" charset="-122"/>
                 <a:cs typeface="Calibri" pitchFamily="34" charset="-120"/>
               </a:rPr>
-              <a:t>CAPD (Counterparty and Protocol Discovery) er en meldingsbuss som bæres av de samme nodene som videresender transaksjoner. Du kringkaster et halvsignert tilbud, si 100 tokens for 5 000 NEXA, og alle noder sender det videre, som en megler som roper ut en pris på gulvet.</a:t>
+              <a:t>En tokengruppes rettigheter, MINT, MELT, SUBGROUP, RESCRIPT og BATON, er flagg på et eget output. Å utstede tokens betyr å bruke en MINT-autoritet i en transaksjon som skaper de nye tokenene. Ingen admin-nøkkel inne i en kontrakt, ingen owner()-funksjon å hacke.</a:t>
             </a:r>
             <a:endParaRPr lang="en-US" sz="1500" dirty="0"/>
           </a:p>
@@ -4103,7 +4370,7 @@
         <p:spPr>
           <a:xfrm>
             <a:off x="4338218" y="1691640"/>
-            <a:ext cx="3515258" cy="3657600"/>
+            <a:ext cx="3515258" cy="4206240"/>
           </a:xfrm>
           <a:prstGeom prst="roundRect">
             <a:avLst>
@@ -4203,7 +4470,7 @@
                 <a:ea typeface="Calibri" pitchFamily="34" charset="-122"/>
                 <a:cs typeface="Calibri" pitchFamily="34" charset="-120"/>
               </a:rPr>
-              <a:t>Ingen børs, ingen ordrebok-server</a:t>
+              <a:t>Send batongen som en hvilken som helst mynt</a:t>
             </a:r>
             <a:endParaRPr lang="en-US" sz="1800" dirty="0"/>
           </a:p>
@@ -4218,7 +4485,7 @@
         <p:spPr>
           <a:xfrm>
             <a:off x="4612538" y="3474720"/>
-            <a:ext cx="2966618" cy="1600200"/>
+            <a:ext cx="2966618" cy="2148840"/>
           </a:xfrm>
           <a:prstGeom prst="rect">
             <a:avLst/>
@@ -4245,7 +4512,7 @@
                 <a:ea typeface="Calibri" pitchFamily="34" charset="-122"/>
                 <a:cs typeface="Calibri" pitchFamily="34" charset="-120"/>
               </a:rPr>
-              <a:t>Den som vil ha handelen, fullfører den halvsignerte transaksjonen og kringkaster den. Byttet gjøres opp på kjeden i én atomisk transaksjon, uten børs, noteringsgebyr eller matchingserver imellom. Bitcoin har ikke noe slikt lag; på Ethereum krever det en DEX-kontrakt og gass per handel.</a:t>
+              <a:t>BATON er retten til å lage nye autoriteter. Del batongen i en pool av rene MINT-autoriteter, gi en partner én som kan utstede men aldri destruere, og hold selve batongen kald. Brukt som read-only input gir en batong rettighetene sine uten å bli brukt opp.</a:t>
             </a:r>
             <a:endParaRPr lang="en-US" sz="1500" dirty="0"/>
           </a:p>
@@ -4260,7 +4527,7 @@
         <p:spPr>
           <a:xfrm>
             <a:off x="8127797" y="1691640"/>
-            <a:ext cx="3515258" cy="3657600"/>
+            <a:ext cx="3515258" cy="4206240"/>
           </a:xfrm>
           <a:prstGeom prst="roundRect">
             <a:avLst>
@@ -4360,7 +4627,7 @@
                 <a:ea typeface="Calibri" pitchFamily="34" charset="-122"/>
                 <a:cs typeface="Calibri" pitchFamily="34" charset="-120"/>
               </a:rPr>
-              <a:t>Proof of work i stedet for gebyr, så forsvinner det</a:t>
+              <a:t>Eller gi den til en smartkontrakt</a:t>
             </a:r>
             <a:endParaRPr lang="en-US" sz="1800" dirty="0"/>
           </a:p>
@@ -4375,7 +4642,7 @@
         <p:spPr>
           <a:xfrm>
             <a:off x="8402117" y="3474720"/>
-            <a:ext cx="2966618" cy="1600200"/>
+            <a:ext cx="2966618" cy="2148840"/>
           </a:xfrm>
           <a:prstGeom prst="rect">
             <a:avLst/>
@@ -4402,7 +4669,7 @@
                 <a:ea typeface="Calibri" pitchFamily="34" charset="-122"/>
                 <a:cs typeface="Calibri" pitchFamily="34" charset="-120"/>
               </a:rPr>
-              <a:t>Avsenderen løser et lite proof of work i stedet for å betale gebyr, og det holder spam ute. Tilbud er flyktige: de faller ut av videresendingen etter rundt ti minutter om de ikke sendes på nytt, kan trekkes tilbake tidlig, og rører aldri blokkjeden før noen tar dem.</a:t>
+              <a:t>Betal en autoritet inn i en skriptmal-kontrakt, så bestemmer kontraktens regler når tokens utstedes: mint-on-demand der NFT-en først skapes når kjøperen betaler, eller en covenant som bare lar autoriteten fortsette inne i samme kontrakt. Mister du kontrollen over et autoritets-output, mister du utstedelsen.</a:t>
             </a:r>
             <a:endParaRPr lang="en-US" sz="1500" dirty="0"/>
           </a:p>
@@ -4575,7 +4842,7 @@
                 <a:ea typeface="Calibri" pitchFamily="34" charset="-122"/>
                 <a:cs typeface="Calibri" pitchFamily="34" charset="-120"/>
               </a:rPr>
-              <a:t>Smartkontrakter uten EVM</a:t>
+              <a:t>Open outcry-handel over CAPD: rop ut et tilbud, hvem som helst kan ta det</a:t>
             </a:r>
             <a:endParaRPr lang="en-US" sz="3000" dirty="0"/>
           </a:p>
@@ -4690,7 +4957,7 @@
                 <a:ea typeface="Calibri" pitchFamily="34" charset="-122"/>
                 <a:cs typeface="Calibri" pitchFamily="34" charset="-120"/>
               </a:rPr>
-              <a:t>Skriptmaler</a:t>
+              <a:t>Rop tilbudet ut til nettverket</a:t>
             </a:r>
             <a:endParaRPr lang="en-US" sz="1800" dirty="0"/>
           </a:p>
@@ -4732,7 +4999,7 @@
                 <a:ea typeface="Calibri" pitchFamily="34" charset="-122"/>
                 <a:cs typeface="Calibri" pitchFamily="34" charset="-120"/>
               </a:rPr>
-              <a:t>Kontrakter er små, deterministiske skript knyttet til mynter og valideres parallelt som enhver annen transaksjon. Det finnes ingen global tilstandsmaskin å tette igjen.</a:t>
+              <a:t>CAPD (Counterparty and Protocol Discovery) er en meldingsbuss som bæres av de samme nodene som videresender transaksjoner. Du kringkaster et halvsignert tilbud, si 100 tokens for 5 000 NEXA, og alle noder sender det videre, som en megler som roper ut en pris på gulvet.</a:t>
             </a:r>
             <a:endParaRPr lang="en-US" sz="1500" dirty="0"/>
           </a:p>
@@ -4847,7 +5114,7 @@
                 <a:ea typeface="Calibri" pitchFamily="34" charset="-122"/>
                 <a:cs typeface="Calibri" pitchFamily="34" charset="-120"/>
               </a:rPr>
-              <a:t>Ingen EVM-overhead</a:t>
+              <a:t>Ingen børs, ingen ordrebok-server</a:t>
             </a:r>
             <a:endParaRPr lang="en-US" sz="1800" dirty="0"/>
           </a:p>
@@ -4889,7 +5156,7 @@
                 <a:ea typeface="Calibri" pitchFamily="34" charset="-122"/>
                 <a:cs typeface="Calibri" pitchFamily="34" charset="-120"/>
               </a:rPr>
-              <a:t>Intet gassmarked, ingen reentrancy-feilklasse, ingen gebyrhopp for alle når én app blir populær. Kontrakter kjører i de samme 42 000 TPS som vanlige betalinger.</a:t>
+              <a:t>Den som vil ha handelen, fullfører den halvsignerte transaksjonen og kringkaster den. Byttet gjøres opp på kjeden i én atomisk transaksjon, uten børs, noteringsgebyr eller matchingserver imellom. Bitcoin har ikke noe slikt lag; på Ethereum krever det en DEX-kontrakt og gass per handel.</a:t>
             </a:r>
             <a:endParaRPr lang="en-US" sz="1500" dirty="0"/>
           </a:p>
@@ -5004,7 +5271,7 @@
                 <a:ea typeface="Calibri" pitchFamily="34" charset="-122"/>
                 <a:cs typeface="Calibri" pitchFamily="34" charset="-120"/>
               </a:rPr>
-              <a:t>En hel plattform</a:t>
+              <a:t>Proof of work i stedet for gebyr, så forsvinner det</a:t>
             </a:r>
             <a:endParaRPr lang="en-US" sz="1800" dirty="0"/>
           </a:p>
@@ -5046,7 +5313,7 @@
                 <a:ea typeface="Calibri" pitchFamily="34" charset="-122"/>
                 <a:cs typeface="Calibri" pitchFamily="34" charset="-120"/>
               </a:rPr>
-              <a:t>Lommebokinnlogging med identitet på kjeden, betalingsforespørsler til brukerens lommebok og peer-to-peer-meldinger er del av stacken, med Kotlin- og JavaScript-biblioteker.</a:t>
+              <a:t>Avsenderen løser et lite proof of work i stedet for å betale gebyr, og det holder spam ute. Tilbud er flyktige: de faller ut av videresendingen etter rundt ti minutter om de ikke sendes på nytt, kan trekkes tilbake tidlig, og rører aldri blokkjeden før noen tar dem.</a:t>
             </a:r>
             <a:endParaRPr lang="en-US" sz="1500" dirty="0"/>
           </a:p>
@@ -5219,7 +5486,7 @@
                 <a:ea typeface="Calibri" pitchFamily="34" charset="-122"/>
                 <a:cs typeface="Calibri" pitchFamily="34" charset="-120"/>
               </a:rPr>
-              <a:t>Hvorfor dette betyr noe i Norge</a:t>
+              <a:t>Token Secrets: selg hemmeligheten sammen med tokenet</a:t>
             </a:r>
             <a:endParaRPr lang="en-US" sz="3000" dirty="0"/>
           </a:p>
@@ -5234,7 +5501,7 @@
         <p:spPr>
           <a:xfrm>
             <a:off x="548640" y="1691640"/>
-            <a:ext cx="3515258" cy="3657600"/>
+            <a:ext cx="3515258" cy="4206240"/>
           </a:xfrm>
           <a:prstGeom prst="roundRect">
             <a:avLst>
@@ -5334,7 +5601,7 @@
                 <a:ea typeface="Calibri" pitchFamily="34" charset="-122"/>
                 <a:cs typeface="Calibri" pitchFamily="34" charset="-120"/>
               </a:rPr>
-              <a:t>Et rent nett under press</a:t>
+              <a:t>En token som bærer en hemmelighet</a:t>
             </a:r>
             <a:endParaRPr lang="en-US" sz="1800" dirty="0"/>
           </a:p>
@@ -5349,7 +5616,7 @@
         <p:spPr>
           <a:xfrm>
             <a:off x="822960" y="3474720"/>
-            <a:ext cx="2966618" cy="1600200"/>
+            <a:ext cx="2966618" cy="2148840"/>
           </a:xfrm>
           <a:prstGeom prst="rect">
             <a:avLst/>
@@ -5376,7 +5643,7 @@
                 <a:ea typeface="Calibri" pitchFamily="34" charset="-122"/>
                 <a:cs typeface="Calibri" pitchFamily="34" charset="-120"/>
               </a:rPr>
-              <a:t>98 % av Norges strøm er vann og vind, likevel stanset regjeringen i 2025 nye proof-of-work-datasentre for å verne nettkapasiteten. Nexa-mining kjører på vanlige GPU-er og er ikke avhengig av datasentre.</a:t>
+              <a:t>Tokenet forplikter seg til den offentlige nøkkelen til en hemmelighet, en privat EC-nøkkel, ved utstedelse eller i selve gruppe-ID-en. Den som holder tokenet, holder hemmeligheten: en spillnøkkel, en billett, nøkkelen til kryptert innhold.</a:t>
             </a:r>
             <a:endParaRPr lang="en-US" sz="1500" dirty="0"/>
           </a:p>
@@ -5391,7 +5658,7 @@
         <p:spPr>
           <a:xfrm>
             <a:off x="4338218" y="1691640"/>
-            <a:ext cx="3515258" cy="3657600"/>
+            <a:ext cx="3515258" cy="4206240"/>
           </a:xfrm>
           <a:prstGeom prst="roundRect">
             <a:avLst>
@@ -5424,11 +5691,11 @@
             <a:avLst/>
           </a:prstGeom>
           <a:solidFill>
-            <a:srgbClr val="F7931A"/>
+            <a:srgbClr val="F2CD3A"/>
           </a:solidFill>
           <a:ln w="12700">
             <a:solidFill>
-              <a:srgbClr val="F7931A"/>
+              <a:srgbClr val="F2CD3A"/>
             </a:solidFill>
             <a:prstDash val="solid"/>
           </a:ln>
@@ -5491,7 +5758,7 @@
                 <a:ea typeface="Calibri" pitchFamily="34" charset="-122"/>
                 <a:cs typeface="Calibri" pitchFamily="34" charset="-120"/>
               </a:rPr>
-              <a:t>Bitcoin ≈ Norge</a:t>
+              <a:t>Avslørt for kjøperen, skjult for alle andre</a:t>
             </a:r>
             <a:endParaRPr lang="en-US" sz="1800" dirty="0"/>
           </a:p>
@@ -5506,7 +5773,7 @@
         <p:spPr>
           <a:xfrm>
             <a:off x="4612538" y="3474720"/>
-            <a:ext cx="2966618" cy="1600200"/>
+            <a:ext cx="2966618" cy="2148840"/>
           </a:xfrm>
           <a:prstGeom prst="rect">
             <a:avLst/>
@@ -5533,7 +5800,7 @@
                 <a:ea typeface="Calibri" pitchFamily="34" charset="-122"/>
                 <a:cs typeface="Calibri" pitchFamily="34" charset="-120"/>
               </a:rPr>
-              <a:t>Bitcoins rundt 140 TWh i året tilsvarer hele Norges strømforbruk, for 7 transaksjoner i sekundet. Samme strøm på Nexa ville båret tusenvis av ganger flere betalinger.</a:t>
+              <a:t>Overføringstransaksjonen gjør en Diffie-Hellman-nøkkelutveksling, så hemmeligheten leveres kryptert til kjøperen inne i transaksjonen. Den offentlige kjeden lekker ingenting, og kjeden verifiserer at det er den ekte hemmeligheten, så selgeren kan ikke bytte den ut med en falsk.</a:t>
             </a:r>
             <a:endParaRPr lang="en-US" sz="1500" dirty="0"/>
           </a:p>
@@ -5548,7 +5815,7 @@
         <p:spPr>
           <a:xfrm>
             <a:off x="8127797" y="1691640"/>
-            <a:ext cx="3515258" cy="3657600"/>
+            <a:ext cx="3515258" cy="4206240"/>
           </a:xfrm>
           <a:prstGeom prst="roundRect">
             <a:avLst>
@@ -5648,7 +5915,7 @@
                 <a:ea typeface="Calibri" pitchFamily="34" charset="-122"/>
                 <a:cs typeface="Calibri" pitchFamily="34" charset="-120"/>
               </a:rPr>
-              <a:t>Et kontantløst land</a:t>
+              <a:t>Atomisk bytte, ikke DRM</a:t>
             </a:r>
             <a:endParaRPr lang="en-US" sz="1800" dirty="0"/>
           </a:p>
@@ -5663,7 +5930,7 @@
         <p:spPr>
           <a:xfrm>
             <a:off x="8402117" y="3474720"/>
-            <a:ext cx="2966618" cy="1600200"/>
+            <a:ext cx="2966618" cy="2148840"/>
           </a:xfrm>
           <a:prstGeom prst="rect">
             <a:avLst/>
@@ -5690,7 +5957,7 @@
                 <a:ea typeface="Calibri" pitchFamily="34" charset="-122"/>
                 <a:cs typeface="Calibri" pitchFamily="34" charset="-120"/>
               </a:rPr>
-              <a:t>Nordmenn betaler allerede med mobilen på sekunder. En rail for energieffektive penger som gjør opp på to sekunder for en brøkdel av et øre passer slik folk her allerede lever.</a:t>
+              <a:t>Token og hemmelighet skifter eier i samme transaksjon, uten en betrodd mellommann. Selgeren kjenner fortsatt hemmeligheten etterpå, så dette sikrer byttet, ikke kopibeskyttelsen. Bitcoin og Ethereum har ingen tilsvarende primitiv.</a:t>
             </a:r>
             <a:endParaRPr lang="en-US" sz="1500" dirty="0"/>
           </a:p>
@@ -5863,6 +6130,1938 @@
                 <a:ea typeface="Calibri" pitchFamily="34" charset="-122"/>
                 <a:cs typeface="Calibri" pitchFamily="34" charset="-120"/>
               </a:rPr>
+              <a:t>Smartkontrakter uten EVM</a:t>
+            </a:r>
+            <a:endParaRPr lang="en-US" sz="3000" dirty="0"/>
+          </a:p>
+        </p:txBody>
+      </p:sp>
+      <p:sp>
+        <p:nvSpPr>
+          <p:cNvPr id="3" name="Shape 1"/>
+          <p:cNvSpPr/>
+          <p:nvPr/>
+        </p:nvSpPr>
+        <p:spPr>
+          <a:xfrm>
+            <a:off x="548640" y="1691640"/>
+            <a:ext cx="3515258" cy="3657600"/>
+          </a:xfrm>
+          <a:prstGeom prst="roundRect">
+            <a:avLst>
+              <a:gd name="adj" fmla="val 3121"/>
+            </a:avLst>
+          </a:prstGeom>
+          <a:solidFill>
+            <a:srgbClr val="18181B"/>
+          </a:solidFill>
+          <a:ln w="9525">
+            <a:solidFill>
+              <a:srgbClr val="2E2E35"/>
+            </a:solidFill>
+            <a:prstDash val="solid"/>
+          </a:ln>
+        </p:spPr>
+      </p:sp>
+      <p:sp>
+        <p:nvSpPr>
+          <p:cNvPr id="4" name="Shape 2"/>
+          <p:cNvSpPr/>
+          <p:nvPr/>
+        </p:nvSpPr>
+        <p:spPr>
+          <a:xfrm>
+            <a:off x="822960" y="1965960"/>
+            <a:ext cx="640080" cy="640080"/>
+          </a:xfrm>
+          <a:prstGeom prst="ellipse">
+            <a:avLst/>
+          </a:prstGeom>
+          <a:solidFill>
+            <a:srgbClr val="F2CD3A"/>
+          </a:solidFill>
+          <a:ln w="12700">
+            <a:solidFill>
+              <a:srgbClr val="F2CD3A"/>
+            </a:solidFill>
+            <a:prstDash val="solid"/>
+          </a:ln>
+        </p:spPr>
+      </p:sp>
+      <p:pic>
+        <p:nvPicPr>
+          <p:cNvPr id="5" name="Image 0" descr="preencoded.png">    </p:cNvPr>
+          <p:cNvPicPr>
+            <a:picLocks noChangeAspect="1"/>
+          </p:cNvPicPr>
+          <p:nvPr/>
+        </p:nvPicPr>
+        <p:blipFill>
+          <a:blip r:embed="rId1"/>
+          <a:stretch>
+            <a:fillRect/>
+          </a:stretch>
+        </p:blipFill>
+        <p:spPr>
+          <a:xfrm>
+            <a:off x="976579" y="2119579"/>
+            <a:ext cx="332842" cy="332842"/>
+          </a:xfrm>
+          <a:prstGeom prst="rect">
+            <a:avLst/>
+          </a:prstGeom>
+        </p:spPr>
+      </p:pic>
+      <p:sp>
+        <p:nvSpPr>
+          <p:cNvPr id="6" name="Text 3"/>
+          <p:cNvSpPr txBox="1"/>
+          <p:nvPr/>
+        </p:nvSpPr>
+        <p:spPr>
+          <a:xfrm>
+            <a:off x="822960" y="2788920"/>
+            <a:ext cx="2966618" cy="640080"/>
+          </a:xfrm>
+          <a:prstGeom prst="rect">
+            <a:avLst/>
+          </a:prstGeom>
+          <a:noFill/>
+          <a:ln/>
+        </p:spPr>
+        <p:txBody>
+          <a:bodyPr wrap="square" lIns="0" tIns="0" rIns="0" bIns="0" rtlCol="0" anchor="t"/>
+          <a:lstStyle/>
+          <a:p>
+            <a:pPr indent="0" marL="0">
+              <a:buNone/>
+            </a:pPr>
+            <a:r>
+              <a:rPr lang="en-US" sz="1800" b="1" dirty="0">
+                <a:solidFill>
+                  <a:srgbClr val="FFFFFF"/>
+                </a:solidFill>
+                <a:latin typeface="Calibri" pitchFamily="34" charset="0"/>
+                <a:ea typeface="Calibri" pitchFamily="34" charset="-122"/>
+                <a:cs typeface="Calibri" pitchFamily="34" charset="-120"/>
+              </a:rPr>
+              <a:t>Skriptmaler</a:t>
+            </a:r>
+            <a:endParaRPr lang="en-US" sz="1800" dirty="0"/>
+          </a:p>
+        </p:txBody>
+      </p:sp>
+      <p:sp>
+        <p:nvSpPr>
+          <p:cNvPr id="7" name="Text 4"/>
+          <p:cNvSpPr txBox="1"/>
+          <p:nvPr/>
+        </p:nvSpPr>
+        <p:spPr>
+          <a:xfrm>
+            <a:off x="822960" y="3474720"/>
+            <a:ext cx="2966618" cy="1600200"/>
+          </a:xfrm>
+          <a:prstGeom prst="rect">
+            <a:avLst/>
+          </a:prstGeom>
+          <a:noFill/>
+          <a:ln/>
+        </p:spPr>
+        <p:txBody>
+          <a:bodyPr wrap="square" lIns="0" tIns="0" rIns="0" bIns="0" rtlCol="0" anchor="t"/>
+          <a:lstStyle/>
+          <a:p>
+            <a:pPr indent="0" marL="0">
+              <a:spcAft>
+                <a:spcPts val="600"/>
+              </a:spcAft>
+              <a:buNone/>
+            </a:pPr>
+            <a:r>
+              <a:rPr lang="en-US" sz="1500" dirty="0">
+                <a:solidFill>
+                  <a:srgbClr val="E4E4E7"/>
+                </a:solidFill>
+                <a:latin typeface="Calibri" pitchFamily="34" charset="0"/>
+                <a:ea typeface="Calibri" pitchFamily="34" charset="-122"/>
+                <a:cs typeface="Calibri" pitchFamily="34" charset="-120"/>
+              </a:rPr>
+              <a:t>Kontrakter er små, deterministiske skript knyttet til mynter og valideres parallelt som enhver annen transaksjon. Det finnes ingen global tilstandsmaskin å tette igjen.</a:t>
+            </a:r>
+            <a:endParaRPr lang="en-US" sz="1500" dirty="0"/>
+          </a:p>
+        </p:txBody>
+      </p:sp>
+      <p:sp>
+        <p:nvSpPr>
+          <p:cNvPr id="8" name="Shape 5"/>
+          <p:cNvSpPr/>
+          <p:nvPr/>
+        </p:nvSpPr>
+        <p:spPr>
+          <a:xfrm>
+            <a:off x="4338218" y="1691640"/>
+            <a:ext cx="3515258" cy="3657600"/>
+          </a:xfrm>
+          <a:prstGeom prst="roundRect">
+            <a:avLst>
+              <a:gd name="adj" fmla="val 3121"/>
+            </a:avLst>
+          </a:prstGeom>
+          <a:solidFill>
+            <a:srgbClr val="18181B"/>
+          </a:solidFill>
+          <a:ln w="9525">
+            <a:solidFill>
+              <a:srgbClr val="2E2E35"/>
+            </a:solidFill>
+            <a:prstDash val="solid"/>
+          </a:ln>
+        </p:spPr>
+      </p:sp>
+      <p:sp>
+        <p:nvSpPr>
+          <p:cNvPr id="9" name="Shape 6"/>
+          <p:cNvSpPr/>
+          <p:nvPr/>
+        </p:nvSpPr>
+        <p:spPr>
+          <a:xfrm>
+            <a:off x="4612538" y="1965960"/>
+            <a:ext cx="640080" cy="640080"/>
+          </a:xfrm>
+          <a:prstGeom prst="ellipse">
+            <a:avLst/>
+          </a:prstGeom>
+          <a:solidFill>
+            <a:srgbClr val="F2CD3A"/>
+          </a:solidFill>
+          <a:ln w="12700">
+            <a:solidFill>
+              <a:srgbClr val="F2CD3A"/>
+            </a:solidFill>
+            <a:prstDash val="solid"/>
+          </a:ln>
+        </p:spPr>
+      </p:sp>
+      <p:pic>
+        <p:nvPicPr>
+          <p:cNvPr id="10" name="Image 1" descr="preencoded.png">    </p:cNvPr>
+          <p:cNvPicPr>
+            <a:picLocks noChangeAspect="1"/>
+          </p:cNvPicPr>
+          <p:nvPr/>
+        </p:nvPicPr>
+        <p:blipFill>
+          <a:blip r:embed="rId2"/>
+          <a:stretch>
+            <a:fillRect/>
+          </a:stretch>
+        </p:blipFill>
+        <p:spPr>
+          <a:xfrm>
+            <a:off x="4766158" y="2119579"/>
+            <a:ext cx="332842" cy="332842"/>
+          </a:xfrm>
+          <a:prstGeom prst="rect">
+            <a:avLst/>
+          </a:prstGeom>
+        </p:spPr>
+      </p:pic>
+      <p:sp>
+        <p:nvSpPr>
+          <p:cNvPr id="11" name="Text 7"/>
+          <p:cNvSpPr txBox="1"/>
+          <p:nvPr/>
+        </p:nvSpPr>
+        <p:spPr>
+          <a:xfrm>
+            <a:off x="4612538" y="2788920"/>
+            <a:ext cx="2966618" cy="640080"/>
+          </a:xfrm>
+          <a:prstGeom prst="rect">
+            <a:avLst/>
+          </a:prstGeom>
+          <a:noFill/>
+          <a:ln/>
+        </p:spPr>
+        <p:txBody>
+          <a:bodyPr wrap="square" lIns="0" tIns="0" rIns="0" bIns="0" rtlCol="0" anchor="t"/>
+          <a:lstStyle/>
+          <a:p>
+            <a:pPr indent="0" marL="0">
+              <a:buNone/>
+            </a:pPr>
+            <a:r>
+              <a:rPr lang="en-US" sz="1800" b="1" dirty="0">
+                <a:solidFill>
+                  <a:srgbClr val="FFFFFF"/>
+                </a:solidFill>
+                <a:latin typeface="Calibri" pitchFamily="34" charset="0"/>
+                <a:ea typeface="Calibri" pitchFamily="34" charset="-122"/>
+                <a:cs typeface="Calibri" pitchFamily="34" charset="-120"/>
+              </a:rPr>
+              <a:t>Ingen EVM-overhead</a:t>
+            </a:r>
+            <a:endParaRPr lang="en-US" sz="1800" dirty="0"/>
+          </a:p>
+        </p:txBody>
+      </p:sp>
+      <p:sp>
+        <p:nvSpPr>
+          <p:cNvPr id="12" name="Text 8"/>
+          <p:cNvSpPr txBox="1"/>
+          <p:nvPr/>
+        </p:nvSpPr>
+        <p:spPr>
+          <a:xfrm>
+            <a:off x="4612538" y="3474720"/>
+            <a:ext cx="2966618" cy="1600200"/>
+          </a:xfrm>
+          <a:prstGeom prst="rect">
+            <a:avLst/>
+          </a:prstGeom>
+          <a:noFill/>
+          <a:ln/>
+        </p:spPr>
+        <p:txBody>
+          <a:bodyPr wrap="square" lIns="0" tIns="0" rIns="0" bIns="0" rtlCol="0" anchor="t"/>
+          <a:lstStyle/>
+          <a:p>
+            <a:pPr indent="0" marL="0">
+              <a:spcAft>
+                <a:spcPts val="600"/>
+              </a:spcAft>
+              <a:buNone/>
+            </a:pPr>
+            <a:r>
+              <a:rPr lang="en-US" sz="1500" dirty="0">
+                <a:solidFill>
+                  <a:srgbClr val="E4E4E7"/>
+                </a:solidFill>
+                <a:latin typeface="Calibri" pitchFamily="34" charset="0"/>
+                <a:ea typeface="Calibri" pitchFamily="34" charset="-122"/>
+                <a:cs typeface="Calibri" pitchFamily="34" charset="-120"/>
+              </a:rPr>
+              <a:t>Intet gassmarked, ingen reentrancy-feilklasse, ingen gebyrhopp for alle når én app blir populær. Kontrakter kjører i de samme 42 000 TPS som vanlige betalinger.</a:t>
+            </a:r>
+            <a:endParaRPr lang="en-US" sz="1500" dirty="0"/>
+          </a:p>
+        </p:txBody>
+      </p:sp>
+      <p:sp>
+        <p:nvSpPr>
+          <p:cNvPr id="13" name="Shape 9"/>
+          <p:cNvSpPr/>
+          <p:nvPr/>
+        </p:nvSpPr>
+        <p:spPr>
+          <a:xfrm>
+            <a:off x="8127797" y="1691640"/>
+            <a:ext cx="3515258" cy="3657600"/>
+          </a:xfrm>
+          <a:prstGeom prst="roundRect">
+            <a:avLst>
+              <a:gd name="adj" fmla="val 3121"/>
+            </a:avLst>
+          </a:prstGeom>
+          <a:solidFill>
+            <a:srgbClr val="18181B"/>
+          </a:solidFill>
+          <a:ln w="9525">
+            <a:solidFill>
+              <a:srgbClr val="2E2E35"/>
+            </a:solidFill>
+            <a:prstDash val="solid"/>
+          </a:ln>
+        </p:spPr>
+      </p:sp>
+      <p:sp>
+        <p:nvSpPr>
+          <p:cNvPr id="14" name="Shape 10"/>
+          <p:cNvSpPr/>
+          <p:nvPr/>
+        </p:nvSpPr>
+        <p:spPr>
+          <a:xfrm>
+            <a:off x="8402117" y="1965960"/>
+            <a:ext cx="640080" cy="640080"/>
+          </a:xfrm>
+          <a:prstGeom prst="ellipse">
+            <a:avLst/>
+          </a:prstGeom>
+          <a:solidFill>
+            <a:srgbClr val="F2CD3A"/>
+          </a:solidFill>
+          <a:ln w="12700">
+            <a:solidFill>
+              <a:srgbClr val="F2CD3A"/>
+            </a:solidFill>
+            <a:prstDash val="solid"/>
+          </a:ln>
+        </p:spPr>
+      </p:sp>
+      <p:pic>
+        <p:nvPicPr>
+          <p:cNvPr id="15" name="Image 2" descr="preencoded.png">    </p:cNvPr>
+          <p:cNvPicPr>
+            <a:picLocks noChangeAspect="1"/>
+          </p:cNvPicPr>
+          <p:nvPr/>
+        </p:nvPicPr>
+        <p:blipFill>
+          <a:blip r:embed="rId3"/>
+          <a:stretch>
+            <a:fillRect/>
+          </a:stretch>
+        </p:blipFill>
+        <p:spPr>
+          <a:xfrm>
+            <a:off x="8555736" y="2119579"/>
+            <a:ext cx="332842" cy="332842"/>
+          </a:xfrm>
+          <a:prstGeom prst="rect">
+            <a:avLst/>
+          </a:prstGeom>
+        </p:spPr>
+      </p:pic>
+      <p:sp>
+        <p:nvSpPr>
+          <p:cNvPr id="16" name="Text 11"/>
+          <p:cNvSpPr txBox="1"/>
+          <p:nvPr/>
+        </p:nvSpPr>
+        <p:spPr>
+          <a:xfrm>
+            <a:off x="8402117" y="2788920"/>
+            <a:ext cx="2966618" cy="640080"/>
+          </a:xfrm>
+          <a:prstGeom prst="rect">
+            <a:avLst/>
+          </a:prstGeom>
+          <a:noFill/>
+          <a:ln/>
+        </p:spPr>
+        <p:txBody>
+          <a:bodyPr wrap="square" lIns="0" tIns="0" rIns="0" bIns="0" rtlCol="0" anchor="t"/>
+          <a:lstStyle/>
+          <a:p>
+            <a:pPr indent="0" marL="0">
+              <a:buNone/>
+            </a:pPr>
+            <a:r>
+              <a:rPr lang="en-US" sz="1800" b="1" dirty="0">
+                <a:solidFill>
+                  <a:srgbClr val="FFFFFF"/>
+                </a:solidFill>
+                <a:latin typeface="Calibri" pitchFamily="34" charset="0"/>
+                <a:ea typeface="Calibri" pitchFamily="34" charset="-122"/>
+                <a:cs typeface="Calibri" pitchFamily="34" charset="-120"/>
+              </a:rPr>
+              <a:t>En hel plattform</a:t>
+            </a:r>
+            <a:endParaRPr lang="en-US" sz="1800" dirty="0"/>
+          </a:p>
+        </p:txBody>
+      </p:sp>
+      <p:sp>
+        <p:nvSpPr>
+          <p:cNvPr id="17" name="Text 12"/>
+          <p:cNvSpPr txBox="1"/>
+          <p:nvPr/>
+        </p:nvSpPr>
+        <p:spPr>
+          <a:xfrm>
+            <a:off x="8402117" y="3474720"/>
+            <a:ext cx="2966618" cy="1600200"/>
+          </a:xfrm>
+          <a:prstGeom prst="rect">
+            <a:avLst/>
+          </a:prstGeom>
+          <a:noFill/>
+          <a:ln/>
+        </p:spPr>
+        <p:txBody>
+          <a:bodyPr wrap="square" lIns="0" tIns="0" rIns="0" bIns="0" rtlCol="0" anchor="t"/>
+          <a:lstStyle/>
+          <a:p>
+            <a:pPr indent="0" marL="0">
+              <a:spcAft>
+                <a:spcPts val="600"/>
+              </a:spcAft>
+              <a:buNone/>
+            </a:pPr>
+            <a:r>
+              <a:rPr lang="en-US" sz="1500" dirty="0">
+                <a:solidFill>
+                  <a:srgbClr val="E4E4E7"/>
+                </a:solidFill>
+                <a:latin typeface="Calibri" pitchFamily="34" charset="0"/>
+                <a:ea typeface="Calibri" pitchFamily="34" charset="-122"/>
+                <a:cs typeface="Calibri" pitchFamily="34" charset="-120"/>
+              </a:rPr>
+              <a:t>Lommebokinnlogging med identitet på kjeden, betalingsforespørsler til brukerens lommebok og peer-to-peer-meldinger er del av stacken, med Kotlin- og JavaScript-biblioteker.</a:t>
+            </a:r>
+            <a:endParaRPr lang="en-US" sz="1500" dirty="0"/>
+          </a:p>
+        </p:txBody>
+      </p:sp>
+      <p:pic>
+        <p:nvPicPr>
+          <p:cNvPr id="19" name="Image 3" descr="preencoded.png">    </p:cNvPr>
+          <p:cNvPicPr>
+            <a:picLocks noChangeAspect="1"/>
+          </p:cNvPicPr>
+          <p:nvPr/>
+        </p:nvPicPr>
+        <p:blipFill>
+          <a:blip r:embed="rId4"/>
+          <a:stretch>
+            <a:fillRect/>
+          </a:stretch>
+        </p:blipFill>
+        <p:spPr>
+          <a:xfrm>
+            <a:off x="548640" y="6355080"/>
+            <a:ext cx="256032" cy="246888"/>
+          </a:xfrm>
+          <a:prstGeom prst="rect">
+            <a:avLst/>
+          </a:prstGeom>
+        </p:spPr>
+      </p:pic>
+      <p:sp>
+        <p:nvSpPr>
+          <p:cNvPr id="20" name="Text 13"/>
+          <p:cNvSpPr txBox="1"/>
+          <p:nvPr/>
+        </p:nvSpPr>
+        <p:spPr>
+          <a:xfrm>
+            <a:off x="877824" y="6400800"/>
+            <a:ext cx="2743200" cy="274320"/>
+          </a:xfrm>
+          <a:prstGeom prst="rect">
+            <a:avLst/>
+          </a:prstGeom>
+          <a:noFill/>
+          <a:ln/>
+        </p:spPr>
+        <p:txBody>
+          <a:bodyPr wrap="square" lIns="0" tIns="0" rIns="0" bIns="0" rtlCol="0" anchor="ctr"/>
+          <a:lstStyle/>
+          <a:p>
+            <a:pPr algn="l" indent="0" marL="0">
+              <a:buNone/>
+            </a:pPr>
+            <a:r>
+              <a:rPr lang="en-US" sz="1000" dirty="0">
+                <a:solidFill>
+                  <a:srgbClr val="A1A1AA"/>
+                </a:solidFill>
+                <a:latin typeface="Calibri" pitchFamily="34" charset="0"/>
+                <a:ea typeface="Calibri" pitchFamily="34" charset="-122"/>
+                <a:cs typeface="Calibri" pitchFamily="34" charset="-120"/>
+              </a:rPr>
+              <a:t>Nexa · 2026</a:t>
+            </a:r>
+            <a:endParaRPr lang="en-US" sz="1000" dirty="0"/>
+          </a:p>
+        </p:txBody>
+      </p:sp>
+      <p:sp>
+        <p:nvSpPr>
+          <p:cNvPr id="21" name="Text 14"/>
+          <p:cNvSpPr txBox="1"/>
+          <p:nvPr/>
+        </p:nvSpPr>
+        <p:spPr>
+          <a:xfrm>
+            <a:off x="11094415" y="6400800"/>
+            <a:ext cx="548640" cy="274320"/>
+          </a:xfrm>
+          <a:prstGeom prst="rect">
+            <a:avLst/>
+          </a:prstGeom>
+          <a:noFill/>
+          <a:ln/>
+        </p:spPr>
+        <p:txBody>
+          <a:bodyPr wrap="square" lIns="0" tIns="0" rIns="0" bIns="0" rtlCol="0" anchor="ctr"/>
+          <a:lstStyle/>
+          <a:p>
+            <a:pPr algn="r" indent="0" marL="0">
+              <a:buNone/>
+            </a:pPr>
+            <a:r>
+              <a:rPr lang="en-US" sz="1000" dirty="0">
+                <a:solidFill>
+                  <a:srgbClr val="A1A1AA"/>
+                </a:solidFill>
+                <a:latin typeface="Calibri" pitchFamily="34" charset="0"/>
+                <a:ea typeface="Calibri" pitchFamily="34" charset="-122"/>
+                <a:cs typeface="Calibri" pitchFamily="34" charset="-120"/>
+              </a:rPr>
+              <a:t>15</a:t>
+            </a:r>
+            <a:endParaRPr lang="en-US" sz="1000" dirty="0"/>
+          </a:p>
+        </p:txBody>
+      </p:sp>
+    </p:spTree>
+  </p:cSld>
+  <p:clrMapOvr>
+    <a:masterClrMapping/>
+  </p:clrMapOvr>
+</p:sld>
+</file>
+
+<file path=ppt/slides/slide16.xml><?xml version="1.0" encoding="utf-8"?>
+<p:sld xmlns:a="http://schemas.openxmlformats.org/drawingml/2006/main" xmlns:r="http://schemas.openxmlformats.org/officeDocument/2006/relationships" xmlns:p="http://schemas.openxmlformats.org/presentationml/2006/main">
+  <p:cSld name="Slide 16">
+    <p:bg>
+      <p:bgPr>
+        <a:solidFill>
+          <a:srgbClr val="0A0A0F"/>
+        </a:solidFill>
+      </p:bgPr>
+    </p:bg>
+    <p:spTree>
+      <p:nvGrpSpPr>
+        <p:cNvPr id="1" name=""/>
+        <p:cNvGrpSpPr/>
+        <p:nvPr/>
+      </p:nvGrpSpPr>
+      <p:grpSpPr>
+        <a:xfrm>
+          <a:off x="0" y="0"/>
+          <a:ext cx="0" cy="0"/>
+          <a:chOff x="0" y="0"/>
+          <a:chExt cx="0" cy="0"/>
+        </a:xfrm>
+      </p:grpSpPr>
+      <p:sp>
+        <p:nvSpPr>
+          <p:cNvPr id="2" name="Text 0"/>
+          <p:cNvSpPr txBox="1"/>
+          <p:nvPr/>
+        </p:nvSpPr>
+        <p:spPr>
+          <a:xfrm>
+            <a:off x="548640" y="411480"/>
+            <a:ext cx="11094415" cy="1005840"/>
+          </a:xfrm>
+          <a:prstGeom prst="rect">
+            <a:avLst/>
+          </a:prstGeom>
+          <a:noFill/>
+          <a:ln/>
+        </p:spPr>
+        <p:txBody>
+          <a:bodyPr wrap="square" lIns="0" tIns="0" rIns="0" bIns="0" rtlCol="0" anchor="t"/>
+          <a:lstStyle/>
+          <a:p>
+            <a:pPr algn="l" indent="0" marL="0">
+              <a:buNone/>
+            </a:pPr>
+            <a:r>
+              <a:rPr lang="en-US" sz="3000" b="1" dirty="0">
+                <a:solidFill>
+                  <a:srgbClr val="FFFFFF"/>
+                </a:solidFill>
+                <a:latin typeface="Calibri" pitchFamily="34" charset="0"/>
+                <a:ea typeface="Calibri" pitchFamily="34" charset="-122"/>
+                <a:cs typeface="Calibri" pitchFamily="34" charset="-120"/>
+              </a:rPr>
+              <a:t>Identitet og betalinger bor i lommeboken, ikke hos butikken</a:t>
+            </a:r>
+            <a:endParaRPr lang="en-US" sz="3000" dirty="0"/>
+          </a:p>
+        </p:txBody>
+      </p:sp>
+      <p:sp>
+        <p:nvSpPr>
+          <p:cNvPr id="3" name="Shape 1"/>
+          <p:cNvSpPr/>
+          <p:nvPr/>
+        </p:nvSpPr>
+        <p:spPr>
+          <a:xfrm>
+            <a:off x="548640" y="1691640"/>
+            <a:ext cx="3515258" cy="4206240"/>
+          </a:xfrm>
+          <a:prstGeom prst="roundRect">
+            <a:avLst>
+              <a:gd name="adj" fmla="val 3121"/>
+            </a:avLst>
+          </a:prstGeom>
+          <a:solidFill>
+            <a:srgbClr val="18181B"/>
+          </a:solidFill>
+          <a:ln w="9525">
+            <a:solidFill>
+              <a:srgbClr val="2E2E35"/>
+            </a:solidFill>
+            <a:prstDash val="solid"/>
+          </a:ln>
+        </p:spPr>
+      </p:sp>
+      <p:sp>
+        <p:nvSpPr>
+          <p:cNvPr id="4" name="Shape 2"/>
+          <p:cNvSpPr/>
+          <p:nvPr/>
+        </p:nvSpPr>
+        <p:spPr>
+          <a:xfrm>
+            <a:off x="822960" y="1965960"/>
+            <a:ext cx="640080" cy="640080"/>
+          </a:xfrm>
+          <a:prstGeom prst="ellipse">
+            <a:avLst/>
+          </a:prstGeom>
+          <a:solidFill>
+            <a:srgbClr val="F2CD3A"/>
+          </a:solidFill>
+          <a:ln w="12700">
+            <a:solidFill>
+              <a:srgbClr val="F2CD3A"/>
+            </a:solidFill>
+            <a:prstDash val="solid"/>
+          </a:ln>
+        </p:spPr>
+      </p:sp>
+      <p:pic>
+        <p:nvPicPr>
+          <p:cNvPr id="5" name="Image 0" descr="preencoded.png">    </p:cNvPr>
+          <p:cNvPicPr>
+            <a:picLocks noChangeAspect="1"/>
+          </p:cNvPicPr>
+          <p:nvPr/>
+        </p:nvPicPr>
+        <p:blipFill>
+          <a:blip r:embed="rId1"/>
+          <a:stretch>
+            <a:fillRect/>
+          </a:stretch>
+        </p:blipFill>
+        <p:spPr>
+          <a:xfrm>
+            <a:off x="976579" y="2119579"/>
+            <a:ext cx="332842" cy="332842"/>
+          </a:xfrm>
+          <a:prstGeom prst="rect">
+            <a:avLst/>
+          </a:prstGeom>
+        </p:spPr>
+      </p:pic>
+      <p:sp>
+        <p:nvSpPr>
+          <p:cNvPr id="6" name="Text 3"/>
+          <p:cNvSpPr txBox="1"/>
+          <p:nvPr/>
+        </p:nvSpPr>
+        <p:spPr>
+          <a:xfrm>
+            <a:off x="822960" y="2788920"/>
+            <a:ext cx="2966618" cy="640080"/>
+          </a:xfrm>
+          <a:prstGeom prst="rect">
+            <a:avLst/>
+          </a:prstGeom>
+          <a:noFill/>
+          <a:ln/>
+        </p:spPr>
+        <p:txBody>
+          <a:bodyPr wrap="square" lIns="0" tIns="0" rIns="0" bIns="0" rtlCol="0" anchor="t"/>
+          <a:lstStyle/>
+          <a:p>
+            <a:pPr indent="0" marL="0">
+              <a:buNone/>
+            </a:pPr>
+            <a:r>
+              <a:rPr lang="en-US" sz="1800" b="1" dirty="0">
+                <a:solidFill>
+                  <a:srgbClr val="FFFFFF"/>
+                </a:solidFill>
+                <a:latin typeface="Calibri" pitchFamily="34" charset="0"/>
+                <a:ea typeface="Calibri" pitchFamily="34" charset="-122"/>
+                <a:cs typeface="Calibri" pitchFamily="34" charset="-120"/>
+              </a:rPr>
+              <a:t>Logg inn med mobilen, uten passord (nexid)</a:t>
+            </a:r>
+            <a:endParaRPr lang="en-US" sz="1800" dirty="0"/>
+          </a:p>
+        </p:txBody>
+      </p:sp>
+      <p:sp>
+        <p:nvSpPr>
+          <p:cNvPr id="7" name="Text 4"/>
+          <p:cNvSpPr txBox="1"/>
+          <p:nvPr/>
+        </p:nvSpPr>
+        <p:spPr>
+          <a:xfrm>
+            <a:off x="822960" y="3474720"/>
+            <a:ext cx="2966618" cy="2148840"/>
+          </a:xfrm>
+          <a:prstGeom prst="rect">
+            <a:avLst/>
+          </a:prstGeom>
+          <a:noFill/>
+          <a:ln/>
+        </p:spPr>
+        <p:txBody>
+          <a:bodyPr wrap="square" lIns="0" tIns="0" rIns="0" bIns="0" rtlCol="0" anchor="t"/>
+          <a:lstStyle/>
+          <a:p>
+            <a:pPr indent="0" marL="0">
+              <a:spcAft>
+                <a:spcPts val="600"/>
+              </a:spcAft>
+              <a:buNone/>
+            </a:pPr>
+            <a:r>
+              <a:rPr lang="en-US" sz="1500" dirty="0">
+                <a:solidFill>
+                  <a:srgbClr val="E4E4E7"/>
+                </a:solidFill>
+                <a:latin typeface="Calibri" pitchFamily="34" charset="0"/>
+                <a:ea typeface="Calibri" pitchFamily="34" charset="-122"/>
+                <a:cs typeface="Calibri" pitchFamily="34" charset="-120"/>
+              </a:rPr>
+              <a:t>Nettstedet viser en utfordring i en QR-kode, mobilen signerer den med en nøkkel avledet per nettsted, og svaret går rett fra mobilen til serveren. Nøkkelen forlater aldri telefonen, hvert nettsted får sin egen identitet, og lookalike-domener feiler. BankID-opplevelsen uten bank.</a:t>
+            </a:r>
+            <a:endParaRPr lang="en-US" sz="1500" dirty="0"/>
+          </a:p>
+        </p:txBody>
+      </p:sp>
+      <p:sp>
+        <p:nvSpPr>
+          <p:cNvPr id="8" name="Shape 5"/>
+          <p:cNvSpPr/>
+          <p:nvPr/>
+        </p:nvSpPr>
+        <p:spPr>
+          <a:xfrm>
+            <a:off x="4338218" y="1691640"/>
+            <a:ext cx="3515258" cy="4206240"/>
+          </a:xfrm>
+          <a:prstGeom prst="roundRect">
+            <a:avLst>
+              <a:gd name="adj" fmla="val 3121"/>
+            </a:avLst>
+          </a:prstGeom>
+          <a:solidFill>
+            <a:srgbClr val="18181B"/>
+          </a:solidFill>
+          <a:ln w="9525">
+            <a:solidFill>
+              <a:srgbClr val="2E2E35"/>
+            </a:solidFill>
+            <a:prstDash val="solid"/>
+          </a:ln>
+        </p:spPr>
+      </p:sp>
+      <p:sp>
+        <p:nvSpPr>
+          <p:cNvPr id="9" name="Shape 6"/>
+          <p:cNvSpPr/>
+          <p:nvPr/>
+        </p:nvSpPr>
+        <p:spPr>
+          <a:xfrm>
+            <a:off x="4612538" y="1965960"/>
+            <a:ext cx="640080" cy="640080"/>
+          </a:xfrm>
+          <a:prstGeom prst="ellipse">
+            <a:avLst/>
+          </a:prstGeom>
+          <a:solidFill>
+            <a:srgbClr val="F2CD3A"/>
+          </a:solidFill>
+          <a:ln w="12700">
+            <a:solidFill>
+              <a:srgbClr val="F2CD3A"/>
+            </a:solidFill>
+            <a:prstDash val="solid"/>
+          </a:ln>
+        </p:spPr>
+      </p:sp>
+      <p:pic>
+        <p:nvPicPr>
+          <p:cNvPr id="10" name="Image 1" descr="preencoded.png">    </p:cNvPr>
+          <p:cNvPicPr>
+            <a:picLocks noChangeAspect="1"/>
+          </p:cNvPicPr>
+          <p:nvPr/>
+        </p:nvPicPr>
+        <p:blipFill>
+          <a:blip r:embed="rId2"/>
+          <a:stretch>
+            <a:fillRect/>
+          </a:stretch>
+        </p:blipFill>
+        <p:spPr>
+          <a:xfrm>
+            <a:off x="4766158" y="2119579"/>
+            <a:ext cx="332842" cy="332842"/>
+          </a:xfrm>
+          <a:prstGeom prst="rect">
+            <a:avLst/>
+          </a:prstGeom>
+        </p:spPr>
+      </p:pic>
+      <p:sp>
+        <p:nvSpPr>
+          <p:cNvPr id="11" name="Text 7"/>
+          <p:cNvSpPr txBox="1"/>
+          <p:nvPr/>
+        </p:nvSpPr>
+        <p:spPr>
+          <a:xfrm>
+            <a:off x="4612538" y="2788920"/>
+            <a:ext cx="2966618" cy="640080"/>
+          </a:xfrm>
+          <a:prstGeom prst="rect">
+            <a:avLst/>
+          </a:prstGeom>
+          <a:noFill/>
+          <a:ln/>
+        </p:spPr>
+        <p:txBody>
+          <a:bodyPr wrap="square" lIns="0" tIns="0" rIns="0" bIns="0" rtlCol="0" anchor="t"/>
+          <a:lstStyle/>
+          <a:p>
+            <a:pPr indent="0" marL="0">
+              <a:buNone/>
+            </a:pPr>
+            <a:r>
+              <a:rPr lang="en-US" sz="1800" b="1" dirty="0">
+                <a:solidFill>
+                  <a:srgbClr val="FFFFFF"/>
+                </a:solidFill>
+                <a:latin typeface="Calibri" pitchFamily="34" charset="0"/>
+                <a:ea typeface="Calibri" pitchFamily="34" charset="-122"/>
+                <a:cs typeface="Calibri" pitchFamily="34" charset="-120"/>
+              </a:rPr>
+              <a:t>Bevis eierskap uten å bruke noe</a:t>
+            </a:r>
+            <a:endParaRPr lang="en-US" sz="1800" dirty="0"/>
+          </a:p>
+        </p:txBody>
+      </p:sp>
+      <p:sp>
+        <p:nvSpPr>
+          <p:cNvPr id="12" name="Text 8"/>
+          <p:cNvSpPr txBox="1"/>
+          <p:nvPr/>
+        </p:nvSpPr>
+        <p:spPr>
+          <a:xfrm>
+            <a:off x="4612538" y="3474720"/>
+            <a:ext cx="2966618" cy="2148840"/>
+          </a:xfrm>
+          <a:prstGeom prst="rect">
+            <a:avLst/>
+          </a:prstGeom>
+          <a:noFill/>
+          <a:ln/>
+        </p:spPr>
+        <p:txBody>
+          <a:bodyPr wrap="square" lIns="0" tIns="0" rIns="0" bIns="0" rtlCol="0" anchor="t"/>
+          <a:lstStyle/>
+          <a:p>
+            <a:pPr indent="0" marL="0">
+              <a:spcAft>
+                <a:spcPts val="600"/>
+              </a:spcAft>
+              <a:buNone/>
+            </a:pPr>
+            <a:r>
+              <a:rPr lang="en-US" sz="1500" dirty="0">
+                <a:solidFill>
+                  <a:srgbClr val="E4E4E7"/>
+                </a:solidFill>
+                <a:latin typeface="Calibri" pitchFamily="34" charset="0"/>
+                <a:ea typeface="Calibri" pitchFamily="34" charset="-122"/>
+                <a:cs typeface="Calibri" pitchFamily="34" charset="-120"/>
+              </a:rPr>
+              <a:t>Challenge transactions: du signerer en bevisst ugyldig transaksjon som aldri sendes. Det beviser kontroll over mynter, NFT-er eller en multisig under et hvilket som helst skript, og er det som gjør tokenstyrt tilgang mulig.</a:t>
+            </a:r>
+            <a:endParaRPr lang="en-US" sz="1500" dirty="0"/>
+          </a:p>
+        </p:txBody>
+      </p:sp>
+      <p:sp>
+        <p:nvSpPr>
+          <p:cNvPr id="13" name="Shape 9"/>
+          <p:cNvSpPr/>
+          <p:nvPr/>
+        </p:nvSpPr>
+        <p:spPr>
+          <a:xfrm>
+            <a:off x="8127797" y="1691640"/>
+            <a:ext cx="3515258" cy="4206240"/>
+          </a:xfrm>
+          <a:prstGeom prst="roundRect">
+            <a:avLst>
+              <a:gd name="adj" fmla="val 3121"/>
+            </a:avLst>
+          </a:prstGeom>
+          <a:solidFill>
+            <a:srgbClr val="18181B"/>
+          </a:solidFill>
+          <a:ln w="9525">
+            <a:solidFill>
+              <a:srgbClr val="2E2E35"/>
+            </a:solidFill>
+            <a:prstDash val="solid"/>
+          </a:ln>
+        </p:spPr>
+      </p:sp>
+      <p:sp>
+        <p:nvSpPr>
+          <p:cNvPr id="14" name="Shape 10"/>
+          <p:cNvSpPr/>
+          <p:nvPr/>
+        </p:nvSpPr>
+        <p:spPr>
+          <a:xfrm>
+            <a:off x="8402117" y="1965960"/>
+            <a:ext cx="640080" cy="640080"/>
+          </a:xfrm>
+          <a:prstGeom prst="ellipse">
+            <a:avLst/>
+          </a:prstGeom>
+          <a:solidFill>
+            <a:srgbClr val="F2CD3A"/>
+          </a:solidFill>
+          <a:ln w="12700">
+            <a:solidFill>
+              <a:srgbClr val="F2CD3A"/>
+            </a:solidFill>
+            <a:prstDash val="solid"/>
+          </a:ln>
+        </p:spPr>
+      </p:sp>
+      <p:pic>
+        <p:nvPicPr>
+          <p:cNvPr id="15" name="Image 2" descr="preencoded.png">    </p:cNvPr>
+          <p:cNvPicPr>
+            <a:picLocks noChangeAspect="1"/>
+          </p:cNvPicPr>
+          <p:nvPr/>
+        </p:nvPicPr>
+        <p:blipFill>
+          <a:blip r:embed="rId3"/>
+          <a:stretch>
+            <a:fillRect/>
+          </a:stretch>
+        </p:blipFill>
+        <p:spPr>
+          <a:xfrm>
+            <a:off x="8555736" y="2119579"/>
+            <a:ext cx="332842" cy="332842"/>
+          </a:xfrm>
+          <a:prstGeom prst="rect">
+            <a:avLst/>
+          </a:prstGeom>
+        </p:spPr>
+      </p:pic>
+      <p:sp>
+        <p:nvSpPr>
+          <p:cNvPr id="16" name="Text 11"/>
+          <p:cNvSpPr txBox="1"/>
+          <p:nvPr/>
+        </p:nvSpPr>
+        <p:spPr>
+          <a:xfrm>
+            <a:off x="8402117" y="2788920"/>
+            <a:ext cx="2966618" cy="640080"/>
+          </a:xfrm>
+          <a:prstGeom prst="rect">
+            <a:avLst/>
+          </a:prstGeom>
+          <a:noFill/>
+          <a:ln/>
+        </p:spPr>
+        <p:txBody>
+          <a:bodyPr wrap="square" lIns="0" tIns="0" rIns="0" bIns="0" rtlCol="0" anchor="t"/>
+          <a:lstStyle/>
+          <a:p>
+            <a:pPr indent="0" marL="0">
+              <a:buNone/>
+            </a:pPr>
+            <a:r>
+              <a:rPr lang="en-US" sz="1800" b="1" dirty="0">
+                <a:solidFill>
+                  <a:srgbClr val="FFFFFF"/>
+                </a:solidFill>
+                <a:latin typeface="Calibri" pitchFamily="34" charset="0"/>
+                <a:ea typeface="Calibri" pitchFamily="34" charset="-122"/>
+                <a:cs typeface="Calibri" pitchFamily="34" charset="-120"/>
+              </a:rPr>
+              <a:t>Abonnement som lommeboken styrer (DPP)</a:t>
+            </a:r>
+            <a:endParaRPr lang="en-US" sz="1800" dirty="0"/>
+          </a:p>
+        </p:txBody>
+      </p:sp>
+      <p:sp>
+        <p:nvSpPr>
+          <p:cNvPr id="17" name="Text 12"/>
+          <p:cNvSpPr txBox="1"/>
+          <p:nvPr/>
+        </p:nvSpPr>
+        <p:spPr>
+          <a:xfrm>
+            <a:off x="8402117" y="3474720"/>
+            <a:ext cx="2966618" cy="2148840"/>
+          </a:xfrm>
+          <a:prstGeom prst="rect">
+            <a:avLst/>
+          </a:prstGeom>
+          <a:noFill/>
+          <a:ln/>
+        </p:spPr>
+        <p:txBody>
+          <a:bodyPr wrap="square" lIns="0" tIns="0" rIns="0" bIns="0" rtlCol="0" anchor="t"/>
+          <a:lstStyle/>
+          <a:p>
+            <a:pPr indent="0" marL="0">
+              <a:spcAft>
+                <a:spcPts val="600"/>
+              </a:spcAft>
+              <a:buNone/>
+            </a:pPr>
+            <a:r>
+              <a:rPr lang="en-US" sz="1500" dirty="0">
+                <a:solidFill>
+                  <a:srgbClr val="E4E4E7"/>
+                </a:solidFill>
+                <a:latin typeface="Calibri" pitchFamily="34" charset="0"/>
+                <a:ea typeface="Calibri" pitchFamily="34" charset="-122"/>
+                <a:cs typeface="Calibri" pitchFamily="34" charset="-120"/>
+              </a:rPr>
+              <a:t>Butikken registrerer seg hos lommeboken din og foreslår grenser per betaling, dag, uke og måned. Lommeboken bestemmer om en betaling går automatisk eller spør deg; butikken kan ikke tvinge den gjennom, og du sier opp alt ett sted. Det motsatte av kort på fil.</a:t>
+            </a:r>
+            <a:endParaRPr lang="en-US" sz="1500" dirty="0"/>
+          </a:p>
+        </p:txBody>
+      </p:sp>
+      <p:pic>
+        <p:nvPicPr>
+          <p:cNvPr id="19" name="Image 3" descr="preencoded.png">    </p:cNvPr>
+          <p:cNvPicPr>
+            <a:picLocks noChangeAspect="1"/>
+          </p:cNvPicPr>
+          <p:nvPr/>
+        </p:nvPicPr>
+        <p:blipFill>
+          <a:blip r:embed="rId4"/>
+          <a:stretch>
+            <a:fillRect/>
+          </a:stretch>
+        </p:blipFill>
+        <p:spPr>
+          <a:xfrm>
+            <a:off x="548640" y="6355080"/>
+            <a:ext cx="256032" cy="246888"/>
+          </a:xfrm>
+          <a:prstGeom prst="rect">
+            <a:avLst/>
+          </a:prstGeom>
+        </p:spPr>
+      </p:pic>
+      <p:sp>
+        <p:nvSpPr>
+          <p:cNvPr id="20" name="Text 13"/>
+          <p:cNvSpPr txBox="1"/>
+          <p:nvPr/>
+        </p:nvSpPr>
+        <p:spPr>
+          <a:xfrm>
+            <a:off x="877824" y="6400800"/>
+            <a:ext cx="2743200" cy="274320"/>
+          </a:xfrm>
+          <a:prstGeom prst="rect">
+            <a:avLst/>
+          </a:prstGeom>
+          <a:noFill/>
+          <a:ln/>
+        </p:spPr>
+        <p:txBody>
+          <a:bodyPr wrap="square" lIns="0" tIns="0" rIns="0" bIns="0" rtlCol="0" anchor="ctr"/>
+          <a:lstStyle/>
+          <a:p>
+            <a:pPr algn="l" indent="0" marL="0">
+              <a:buNone/>
+            </a:pPr>
+            <a:r>
+              <a:rPr lang="en-US" sz="1000" dirty="0">
+                <a:solidFill>
+                  <a:srgbClr val="A1A1AA"/>
+                </a:solidFill>
+                <a:latin typeface="Calibri" pitchFamily="34" charset="0"/>
+                <a:ea typeface="Calibri" pitchFamily="34" charset="-122"/>
+                <a:cs typeface="Calibri" pitchFamily="34" charset="-120"/>
+              </a:rPr>
+              <a:t>Nexa · 2026</a:t>
+            </a:r>
+            <a:endParaRPr lang="en-US" sz="1000" dirty="0"/>
+          </a:p>
+        </p:txBody>
+      </p:sp>
+      <p:sp>
+        <p:nvSpPr>
+          <p:cNvPr id="21" name="Text 14"/>
+          <p:cNvSpPr txBox="1"/>
+          <p:nvPr/>
+        </p:nvSpPr>
+        <p:spPr>
+          <a:xfrm>
+            <a:off x="11094415" y="6400800"/>
+            <a:ext cx="548640" cy="274320"/>
+          </a:xfrm>
+          <a:prstGeom prst="rect">
+            <a:avLst/>
+          </a:prstGeom>
+          <a:noFill/>
+          <a:ln/>
+        </p:spPr>
+        <p:txBody>
+          <a:bodyPr wrap="square" lIns="0" tIns="0" rIns="0" bIns="0" rtlCol="0" anchor="ctr"/>
+          <a:lstStyle/>
+          <a:p>
+            <a:pPr algn="r" indent="0" marL="0">
+              <a:buNone/>
+            </a:pPr>
+            <a:r>
+              <a:rPr lang="en-US" sz="1000" dirty="0">
+                <a:solidFill>
+                  <a:srgbClr val="A1A1AA"/>
+                </a:solidFill>
+                <a:latin typeface="Calibri" pitchFamily="34" charset="0"/>
+                <a:ea typeface="Calibri" pitchFamily="34" charset="-122"/>
+                <a:cs typeface="Calibri" pitchFamily="34" charset="-120"/>
+              </a:rPr>
+              <a:t>16</a:t>
+            </a:r>
+            <a:endParaRPr lang="en-US" sz="1000" dirty="0"/>
+          </a:p>
+        </p:txBody>
+      </p:sp>
+    </p:spTree>
+  </p:cSld>
+  <p:clrMapOvr>
+    <a:masterClrMapping/>
+  </p:clrMapOvr>
+</p:sld>
+</file>
+
+<file path=ppt/slides/slide17.xml><?xml version="1.0" encoding="utf-8"?>
+<p:sld xmlns:a="http://schemas.openxmlformats.org/drawingml/2006/main" xmlns:r="http://schemas.openxmlformats.org/officeDocument/2006/relationships" xmlns:p="http://schemas.openxmlformats.org/presentationml/2006/main">
+  <p:cSld name="Slide 17">
+    <p:bg>
+      <p:bgPr>
+        <a:solidFill>
+          <a:srgbClr val="0A0A0F"/>
+        </a:solidFill>
+      </p:bgPr>
+    </p:bg>
+    <p:spTree>
+      <p:nvGrpSpPr>
+        <p:cNvPr id="1" name=""/>
+        <p:cNvGrpSpPr/>
+        <p:nvPr/>
+      </p:nvGrpSpPr>
+      <p:grpSpPr>
+        <a:xfrm>
+          <a:off x="0" y="0"/>
+          <a:ext cx="0" cy="0"/>
+          <a:chOff x="0" y="0"/>
+          <a:chExt cx="0" cy="0"/>
+        </a:xfrm>
+      </p:grpSpPr>
+      <p:sp>
+        <p:nvSpPr>
+          <p:cNvPr id="2" name="Text 0"/>
+          <p:cNvSpPr txBox="1"/>
+          <p:nvPr/>
+        </p:nvSpPr>
+        <p:spPr>
+          <a:xfrm>
+            <a:off x="548640" y="411480"/>
+            <a:ext cx="11094415" cy="1005840"/>
+          </a:xfrm>
+          <a:prstGeom prst="rect">
+            <a:avLst/>
+          </a:prstGeom>
+          <a:noFill/>
+          <a:ln/>
+        </p:spPr>
+        <p:txBody>
+          <a:bodyPr wrap="square" lIns="0" tIns="0" rIns="0" bIns="0" rtlCol="0" anchor="t"/>
+          <a:lstStyle/>
+          <a:p>
+            <a:pPr algn="l" indent="0" marL="0">
+              <a:buNone/>
+            </a:pPr>
+            <a:r>
+              <a:rPr lang="en-US" sz="3000" b="1" dirty="0">
+                <a:solidFill>
+                  <a:srgbClr val="FFFFFF"/>
+                </a:solidFill>
+                <a:latin typeface="Calibri" pitchFamily="34" charset="0"/>
+                <a:ea typeface="Calibri" pitchFamily="34" charset="-122"/>
+                <a:cs typeface="Calibri" pitchFamily="34" charset="-120"/>
+              </a:rPr>
+              <a:t>Hvorfor dette betyr noe i Norge</a:t>
+            </a:r>
+            <a:endParaRPr lang="en-US" sz="3000" dirty="0"/>
+          </a:p>
+        </p:txBody>
+      </p:sp>
+      <p:sp>
+        <p:nvSpPr>
+          <p:cNvPr id="3" name="Shape 1"/>
+          <p:cNvSpPr/>
+          <p:nvPr/>
+        </p:nvSpPr>
+        <p:spPr>
+          <a:xfrm>
+            <a:off x="548640" y="1691640"/>
+            <a:ext cx="3515258" cy="3657600"/>
+          </a:xfrm>
+          <a:prstGeom prst="roundRect">
+            <a:avLst>
+              <a:gd name="adj" fmla="val 3121"/>
+            </a:avLst>
+          </a:prstGeom>
+          <a:solidFill>
+            <a:srgbClr val="18181B"/>
+          </a:solidFill>
+          <a:ln w="9525">
+            <a:solidFill>
+              <a:srgbClr val="2E2E35"/>
+            </a:solidFill>
+            <a:prstDash val="solid"/>
+          </a:ln>
+        </p:spPr>
+      </p:sp>
+      <p:sp>
+        <p:nvSpPr>
+          <p:cNvPr id="4" name="Shape 2"/>
+          <p:cNvSpPr/>
+          <p:nvPr/>
+        </p:nvSpPr>
+        <p:spPr>
+          <a:xfrm>
+            <a:off x="822960" y="1965960"/>
+            <a:ext cx="640080" cy="640080"/>
+          </a:xfrm>
+          <a:prstGeom prst="ellipse">
+            <a:avLst/>
+          </a:prstGeom>
+          <a:solidFill>
+            <a:srgbClr val="F2CD3A"/>
+          </a:solidFill>
+          <a:ln w="12700">
+            <a:solidFill>
+              <a:srgbClr val="F2CD3A"/>
+            </a:solidFill>
+            <a:prstDash val="solid"/>
+          </a:ln>
+        </p:spPr>
+      </p:sp>
+      <p:pic>
+        <p:nvPicPr>
+          <p:cNvPr id="5" name="Image 0" descr="preencoded.png">    </p:cNvPr>
+          <p:cNvPicPr>
+            <a:picLocks noChangeAspect="1"/>
+          </p:cNvPicPr>
+          <p:nvPr/>
+        </p:nvPicPr>
+        <p:blipFill>
+          <a:blip r:embed="rId1"/>
+          <a:stretch>
+            <a:fillRect/>
+          </a:stretch>
+        </p:blipFill>
+        <p:spPr>
+          <a:xfrm>
+            <a:off x="976579" y="2119579"/>
+            <a:ext cx="332842" cy="332842"/>
+          </a:xfrm>
+          <a:prstGeom prst="rect">
+            <a:avLst/>
+          </a:prstGeom>
+        </p:spPr>
+      </p:pic>
+      <p:sp>
+        <p:nvSpPr>
+          <p:cNvPr id="6" name="Text 3"/>
+          <p:cNvSpPr txBox="1"/>
+          <p:nvPr/>
+        </p:nvSpPr>
+        <p:spPr>
+          <a:xfrm>
+            <a:off x="822960" y="2788920"/>
+            <a:ext cx="2966618" cy="640080"/>
+          </a:xfrm>
+          <a:prstGeom prst="rect">
+            <a:avLst/>
+          </a:prstGeom>
+          <a:noFill/>
+          <a:ln/>
+        </p:spPr>
+        <p:txBody>
+          <a:bodyPr wrap="square" lIns="0" tIns="0" rIns="0" bIns="0" rtlCol="0" anchor="t"/>
+          <a:lstStyle/>
+          <a:p>
+            <a:pPr indent="0" marL="0">
+              <a:buNone/>
+            </a:pPr>
+            <a:r>
+              <a:rPr lang="en-US" sz="1800" b="1" dirty="0">
+                <a:solidFill>
+                  <a:srgbClr val="FFFFFF"/>
+                </a:solidFill>
+                <a:latin typeface="Calibri" pitchFamily="34" charset="0"/>
+                <a:ea typeface="Calibri" pitchFamily="34" charset="-122"/>
+                <a:cs typeface="Calibri" pitchFamily="34" charset="-120"/>
+              </a:rPr>
+              <a:t>Et rent nett under press</a:t>
+            </a:r>
+            <a:endParaRPr lang="en-US" sz="1800" dirty="0"/>
+          </a:p>
+        </p:txBody>
+      </p:sp>
+      <p:sp>
+        <p:nvSpPr>
+          <p:cNvPr id="7" name="Text 4"/>
+          <p:cNvSpPr txBox="1"/>
+          <p:nvPr/>
+        </p:nvSpPr>
+        <p:spPr>
+          <a:xfrm>
+            <a:off x="822960" y="3474720"/>
+            <a:ext cx="2966618" cy="1600200"/>
+          </a:xfrm>
+          <a:prstGeom prst="rect">
+            <a:avLst/>
+          </a:prstGeom>
+          <a:noFill/>
+          <a:ln/>
+        </p:spPr>
+        <p:txBody>
+          <a:bodyPr wrap="square" lIns="0" tIns="0" rIns="0" bIns="0" rtlCol="0" anchor="t"/>
+          <a:lstStyle/>
+          <a:p>
+            <a:pPr indent="0" marL="0">
+              <a:spcAft>
+                <a:spcPts val="600"/>
+              </a:spcAft>
+              <a:buNone/>
+            </a:pPr>
+            <a:r>
+              <a:rPr lang="en-US" sz="1500" dirty="0">
+                <a:solidFill>
+                  <a:srgbClr val="E4E4E7"/>
+                </a:solidFill>
+                <a:latin typeface="Calibri" pitchFamily="34" charset="0"/>
+                <a:ea typeface="Calibri" pitchFamily="34" charset="-122"/>
+                <a:cs typeface="Calibri" pitchFamily="34" charset="-120"/>
+              </a:rPr>
+              <a:t>98 % av Norges strøm er vann og vind, likevel stanset regjeringen i 2025 nye proof-of-work-datasentre for å verne nettkapasiteten. Nexa-mining kjører på vanlige GPU-er og er ikke avhengig av datasentre.</a:t>
+            </a:r>
+            <a:endParaRPr lang="en-US" sz="1500" dirty="0"/>
+          </a:p>
+        </p:txBody>
+      </p:sp>
+      <p:sp>
+        <p:nvSpPr>
+          <p:cNvPr id="8" name="Shape 5"/>
+          <p:cNvSpPr/>
+          <p:nvPr/>
+        </p:nvSpPr>
+        <p:spPr>
+          <a:xfrm>
+            <a:off x="4338218" y="1691640"/>
+            <a:ext cx="3515258" cy="3657600"/>
+          </a:xfrm>
+          <a:prstGeom prst="roundRect">
+            <a:avLst>
+              <a:gd name="adj" fmla="val 3121"/>
+            </a:avLst>
+          </a:prstGeom>
+          <a:solidFill>
+            <a:srgbClr val="18181B"/>
+          </a:solidFill>
+          <a:ln w="9525">
+            <a:solidFill>
+              <a:srgbClr val="2E2E35"/>
+            </a:solidFill>
+            <a:prstDash val="solid"/>
+          </a:ln>
+        </p:spPr>
+      </p:sp>
+      <p:sp>
+        <p:nvSpPr>
+          <p:cNvPr id="9" name="Shape 6"/>
+          <p:cNvSpPr/>
+          <p:nvPr/>
+        </p:nvSpPr>
+        <p:spPr>
+          <a:xfrm>
+            <a:off x="4612538" y="1965960"/>
+            <a:ext cx="640080" cy="640080"/>
+          </a:xfrm>
+          <a:prstGeom prst="ellipse">
+            <a:avLst/>
+          </a:prstGeom>
+          <a:solidFill>
+            <a:srgbClr val="F7931A"/>
+          </a:solidFill>
+          <a:ln w="12700">
+            <a:solidFill>
+              <a:srgbClr val="F7931A"/>
+            </a:solidFill>
+            <a:prstDash val="solid"/>
+          </a:ln>
+        </p:spPr>
+      </p:sp>
+      <p:pic>
+        <p:nvPicPr>
+          <p:cNvPr id="10" name="Image 1" descr="preencoded.png">    </p:cNvPr>
+          <p:cNvPicPr>
+            <a:picLocks noChangeAspect="1"/>
+          </p:cNvPicPr>
+          <p:nvPr/>
+        </p:nvPicPr>
+        <p:blipFill>
+          <a:blip r:embed="rId2"/>
+          <a:stretch>
+            <a:fillRect/>
+          </a:stretch>
+        </p:blipFill>
+        <p:spPr>
+          <a:xfrm>
+            <a:off x="4766158" y="2119579"/>
+            <a:ext cx="332842" cy="332842"/>
+          </a:xfrm>
+          <a:prstGeom prst="rect">
+            <a:avLst/>
+          </a:prstGeom>
+        </p:spPr>
+      </p:pic>
+      <p:sp>
+        <p:nvSpPr>
+          <p:cNvPr id="11" name="Text 7"/>
+          <p:cNvSpPr txBox="1"/>
+          <p:nvPr/>
+        </p:nvSpPr>
+        <p:spPr>
+          <a:xfrm>
+            <a:off x="4612538" y="2788920"/>
+            <a:ext cx="2966618" cy="640080"/>
+          </a:xfrm>
+          <a:prstGeom prst="rect">
+            <a:avLst/>
+          </a:prstGeom>
+          <a:noFill/>
+          <a:ln/>
+        </p:spPr>
+        <p:txBody>
+          <a:bodyPr wrap="square" lIns="0" tIns="0" rIns="0" bIns="0" rtlCol="0" anchor="t"/>
+          <a:lstStyle/>
+          <a:p>
+            <a:pPr indent="0" marL="0">
+              <a:buNone/>
+            </a:pPr>
+            <a:r>
+              <a:rPr lang="en-US" sz="1800" b="1" dirty="0">
+                <a:solidFill>
+                  <a:srgbClr val="FFFFFF"/>
+                </a:solidFill>
+                <a:latin typeface="Calibri" pitchFamily="34" charset="0"/>
+                <a:ea typeface="Calibri" pitchFamily="34" charset="-122"/>
+                <a:cs typeface="Calibri" pitchFamily="34" charset="-120"/>
+              </a:rPr>
+              <a:t>Bitcoin ≈ Norge</a:t>
+            </a:r>
+            <a:endParaRPr lang="en-US" sz="1800" dirty="0"/>
+          </a:p>
+        </p:txBody>
+      </p:sp>
+      <p:sp>
+        <p:nvSpPr>
+          <p:cNvPr id="12" name="Text 8"/>
+          <p:cNvSpPr txBox="1"/>
+          <p:nvPr/>
+        </p:nvSpPr>
+        <p:spPr>
+          <a:xfrm>
+            <a:off x="4612538" y="3474720"/>
+            <a:ext cx="2966618" cy="1600200"/>
+          </a:xfrm>
+          <a:prstGeom prst="rect">
+            <a:avLst/>
+          </a:prstGeom>
+          <a:noFill/>
+          <a:ln/>
+        </p:spPr>
+        <p:txBody>
+          <a:bodyPr wrap="square" lIns="0" tIns="0" rIns="0" bIns="0" rtlCol="0" anchor="t"/>
+          <a:lstStyle/>
+          <a:p>
+            <a:pPr indent="0" marL="0">
+              <a:spcAft>
+                <a:spcPts val="600"/>
+              </a:spcAft>
+              <a:buNone/>
+            </a:pPr>
+            <a:r>
+              <a:rPr lang="en-US" sz="1500" dirty="0">
+                <a:solidFill>
+                  <a:srgbClr val="E4E4E7"/>
+                </a:solidFill>
+                <a:latin typeface="Calibri" pitchFamily="34" charset="0"/>
+                <a:ea typeface="Calibri" pitchFamily="34" charset="-122"/>
+                <a:cs typeface="Calibri" pitchFamily="34" charset="-120"/>
+              </a:rPr>
+              <a:t>Bitcoins rundt 140 TWh i året tilsvarer hele Norges strømforbruk, for 7 transaksjoner i sekundet. Samme strøm på Nexa ville båret tusenvis av ganger flere betalinger.</a:t>
+            </a:r>
+            <a:endParaRPr lang="en-US" sz="1500" dirty="0"/>
+          </a:p>
+        </p:txBody>
+      </p:sp>
+      <p:sp>
+        <p:nvSpPr>
+          <p:cNvPr id="13" name="Shape 9"/>
+          <p:cNvSpPr/>
+          <p:nvPr/>
+        </p:nvSpPr>
+        <p:spPr>
+          <a:xfrm>
+            <a:off x="8127797" y="1691640"/>
+            <a:ext cx="3515258" cy="3657600"/>
+          </a:xfrm>
+          <a:prstGeom prst="roundRect">
+            <a:avLst>
+              <a:gd name="adj" fmla="val 3121"/>
+            </a:avLst>
+          </a:prstGeom>
+          <a:solidFill>
+            <a:srgbClr val="18181B"/>
+          </a:solidFill>
+          <a:ln w="9525">
+            <a:solidFill>
+              <a:srgbClr val="2E2E35"/>
+            </a:solidFill>
+            <a:prstDash val="solid"/>
+          </a:ln>
+        </p:spPr>
+      </p:sp>
+      <p:sp>
+        <p:nvSpPr>
+          <p:cNvPr id="14" name="Shape 10"/>
+          <p:cNvSpPr/>
+          <p:nvPr/>
+        </p:nvSpPr>
+        <p:spPr>
+          <a:xfrm>
+            <a:off x="8402117" y="1965960"/>
+            <a:ext cx="640080" cy="640080"/>
+          </a:xfrm>
+          <a:prstGeom prst="ellipse">
+            <a:avLst/>
+          </a:prstGeom>
+          <a:solidFill>
+            <a:srgbClr val="F2CD3A"/>
+          </a:solidFill>
+          <a:ln w="12700">
+            <a:solidFill>
+              <a:srgbClr val="F2CD3A"/>
+            </a:solidFill>
+            <a:prstDash val="solid"/>
+          </a:ln>
+        </p:spPr>
+      </p:sp>
+      <p:pic>
+        <p:nvPicPr>
+          <p:cNvPr id="15" name="Image 2" descr="preencoded.png">    </p:cNvPr>
+          <p:cNvPicPr>
+            <a:picLocks noChangeAspect="1"/>
+          </p:cNvPicPr>
+          <p:nvPr/>
+        </p:nvPicPr>
+        <p:blipFill>
+          <a:blip r:embed="rId3"/>
+          <a:stretch>
+            <a:fillRect/>
+          </a:stretch>
+        </p:blipFill>
+        <p:spPr>
+          <a:xfrm>
+            <a:off x="8555736" y="2119579"/>
+            <a:ext cx="332842" cy="332842"/>
+          </a:xfrm>
+          <a:prstGeom prst="rect">
+            <a:avLst/>
+          </a:prstGeom>
+        </p:spPr>
+      </p:pic>
+      <p:sp>
+        <p:nvSpPr>
+          <p:cNvPr id="16" name="Text 11"/>
+          <p:cNvSpPr txBox="1"/>
+          <p:nvPr/>
+        </p:nvSpPr>
+        <p:spPr>
+          <a:xfrm>
+            <a:off x="8402117" y="2788920"/>
+            <a:ext cx="2966618" cy="640080"/>
+          </a:xfrm>
+          <a:prstGeom prst="rect">
+            <a:avLst/>
+          </a:prstGeom>
+          <a:noFill/>
+          <a:ln/>
+        </p:spPr>
+        <p:txBody>
+          <a:bodyPr wrap="square" lIns="0" tIns="0" rIns="0" bIns="0" rtlCol="0" anchor="t"/>
+          <a:lstStyle/>
+          <a:p>
+            <a:pPr indent="0" marL="0">
+              <a:buNone/>
+            </a:pPr>
+            <a:r>
+              <a:rPr lang="en-US" sz="1800" b="1" dirty="0">
+                <a:solidFill>
+                  <a:srgbClr val="FFFFFF"/>
+                </a:solidFill>
+                <a:latin typeface="Calibri" pitchFamily="34" charset="0"/>
+                <a:ea typeface="Calibri" pitchFamily="34" charset="-122"/>
+                <a:cs typeface="Calibri" pitchFamily="34" charset="-120"/>
+              </a:rPr>
+              <a:t>Et kontantløst land</a:t>
+            </a:r>
+            <a:endParaRPr lang="en-US" sz="1800" dirty="0"/>
+          </a:p>
+        </p:txBody>
+      </p:sp>
+      <p:sp>
+        <p:nvSpPr>
+          <p:cNvPr id="17" name="Text 12"/>
+          <p:cNvSpPr txBox="1"/>
+          <p:nvPr/>
+        </p:nvSpPr>
+        <p:spPr>
+          <a:xfrm>
+            <a:off x="8402117" y="3474720"/>
+            <a:ext cx="2966618" cy="1600200"/>
+          </a:xfrm>
+          <a:prstGeom prst="rect">
+            <a:avLst/>
+          </a:prstGeom>
+          <a:noFill/>
+          <a:ln/>
+        </p:spPr>
+        <p:txBody>
+          <a:bodyPr wrap="square" lIns="0" tIns="0" rIns="0" bIns="0" rtlCol="0" anchor="t"/>
+          <a:lstStyle/>
+          <a:p>
+            <a:pPr indent="0" marL="0">
+              <a:spcAft>
+                <a:spcPts val="600"/>
+              </a:spcAft>
+              <a:buNone/>
+            </a:pPr>
+            <a:r>
+              <a:rPr lang="en-US" sz="1500" dirty="0">
+                <a:solidFill>
+                  <a:srgbClr val="E4E4E7"/>
+                </a:solidFill>
+                <a:latin typeface="Calibri" pitchFamily="34" charset="0"/>
+                <a:ea typeface="Calibri" pitchFamily="34" charset="-122"/>
+                <a:cs typeface="Calibri" pitchFamily="34" charset="-120"/>
+              </a:rPr>
+              <a:t>Nordmenn betaler allerede med mobilen på sekunder. En rail for energieffektive penger som gjør opp på to sekunder for en brøkdel av et øre passer slik folk her allerede lever.</a:t>
+            </a:r>
+            <a:endParaRPr lang="en-US" sz="1500" dirty="0"/>
+          </a:p>
+        </p:txBody>
+      </p:sp>
+      <p:pic>
+        <p:nvPicPr>
+          <p:cNvPr id="19" name="Image 3" descr="preencoded.png">    </p:cNvPr>
+          <p:cNvPicPr>
+            <a:picLocks noChangeAspect="1"/>
+          </p:cNvPicPr>
+          <p:nvPr/>
+        </p:nvPicPr>
+        <p:blipFill>
+          <a:blip r:embed="rId4"/>
+          <a:stretch>
+            <a:fillRect/>
+          </a:stretch>
+        </p:blipFill>
+        <p:spPr>
+          <a:xfrm>
+            <a:off x="548640" y="6355080"/>
+            <a:ext cx="256032" cy="246888"/>
+          </a:xfrm>
+          <a:prstGeom prst="rect">
+            <a:avLst/>
+          </a:prstGeom>
+        </p:spPr>
+      </p:pic>
+      <p:sp>
+        <p:nvSpPr>
+          <p:cNvPr id="20" name="Text 13"/>
+          <p:cNvSpPr txBox="1"/>
+          <p:nvPr/>
+        </p:nvSpPr>
+        <p:spPr>
+          <a:xfrm>
+            <a:off x="877824" y="6400800"/>
+            <a:ext cx="2743200" cy="274320"/>
+          </a:xfrm>
+          <a:prstGeom prst="rect">
+            <a:avLst/>
+          </a:prstGeom>
+          <a:noFill/>
+          <a:ln/>
+        </p:spPr>
+        <p:txBody>
+          <a:bodyPr wrap="square" lIns="0" tIns="0" rIns="0" bIns="0" rtlCol="0" anchor="ctr"/>
+          <a:lstStyle/>
+          <a:p>
+            <a:pPr algn="l" indent="0" marL="0">
+              <a:buNone/>
+            </a:pPr>
+            <a:r>
+              <a:rPr lang="en-US" sz="1000" dirty="0">
+                <a:solidFill>
+                  <a:srgbClr val="A1A1AA"/>
+                </a:solidFill>
+                <a:latin typeface="Calibri" pitchFamily="34" charset="0"/>
+                <a:ea typeface="Calibri" pitchFamily="34" charset="-122"/>
+                <a:cs typeface="Calibri" pitchFamily="34" charset="-120"/>
+              </a:rPr>
+              <a:t>Nexa · 2026</a:t>
+            </a:r>
+            <a:endParaRPr lang="en-US" sz="1000" dirty="0"/>
+          </a:p>
+        </p:txBody>
+      </p:sp>
+      <p:sp>
+        <p:nvSpPr>
+          <p:cNvPr id="21" name="Text 14"/>
+          <p:cNvSpPr txBox="1"/>
+          <p:nvPr/>
+        </p:nvSpPr>
+        <p:spPr>
+          <a:xfrm>
+            <a:off x="11094415" y="6400800"/>
+            <a:ext cx="548640" cy="274320"/>
+          </a:xfrm>
+          <a:prstGeom prst="rect">
+            <a:avLst/>
+          </a:prstGeom>
+          <a:noFill/>
+          <a:ln/>
+        </p:spPr>
+        <p:txBody>
+          <a:bodyPr wrap="square" lIns="0" tIns="0" rIns="0" bIns="0" rtlCol="0" anchor="ctr"/>
+          <a:lstStyle/>
+          <a:p>
+            <a:pPr algn="r" indent="0" marL="0">
+              <a:buNone/>
+            </a:pPr>
+            <a:r>
+              <a:rPr lang="en-US" sz="1000" dirty="0">
+                <a:solidFill>
+                  <a:srgbClr val="A1A1AA"/>
+                </a:solidFill>
+                <a:latin typeface="Calibri" pitchFamily="34" charset="0"/>
+                <a:ea typeface="Calibri" pitchFamily="34" charset="-122"/>
+                <a:cs typeface="Calibri" pitchFamily="34" charset="-120"/>
+              </a:rPr>
+              <a:t>17</a:t>
+            </a:r>
+            <a:endParaRPr lang="en-US" sz="1000" dirty="0"/>
+          </a:p>
+        </p:txBody>
+      </p:sp>
+    </p:spTree>
+  </p:cSld>
+  <p:clrMapOvr>
+    <a:masterClrMapping/>
+  </p:clrMapOvr>
+</p:sld>
+</file>
+
+<file path=ppt/slides/slide18.xml><?xml version="1.0" encoding="utf-8"?>
+<p:sld xmlns:a="http://schemas.openxmlformats.org/drawingml/2006/main" xmlns:r="http://schemas.openxmlformats.org/officeDocument/2006/relationships" xmlns:p="http://schemas.openxmlformats.org/presentationml/2006/main">
+  <p:cSld name="Slide 18">
+    <p:bg>
+      <p:bgPr>
+        <a:solidFill>
+          <a:srgbClr val="0A0A0F"/>
+        </a:solidFill>
+      </p:bgPr>
+    </p:bg>
+    <p:spTree>
+      <p:nvGrpSpPr>
+        <p:cNvPr id="1" name=""/>
+        <p:cNvGrpSpPr/>
+        <p:nvPr/>
+      </p:nvGrpSpPr>
+      <p:grpSpPr>
+        <a:xfrm>
+          <a:off x="0" y="0"/>
+          <a:ext cx="0" cy="0"/>
+          <a:chOff x="0" y="0"/>
+          <a:chExt cx="0" cy="0"/>
+        </a:xfrm>
+      </p:grpSpPr>
+      <p:sp>
+        <p:nvSpPr>
+          <p:cNvPr id="2" name="Text 0"/>
+          <p:cNvSpPr txBox="1"/>
+          <p:nvPr/>
+        </p:nvSpPr>
+        <p:spPr>
+          <a:xfrm>
+            <a:off x="548640" y="411480"/>
+            <a:ext cx="11094415" cy="1005840"/>
+          </a:xfrm>
+          <a:prstGeom prst="rect">
+            <a:avLst/>
+          </a:prstGeom>
+          <a:noFill/>
+          <a:ln/>
+        </p:spPr>
+        <p:txBody>
+          <a:bodyPr wrap="square" lIns="0" tIns="0" rIns="0" bIns="0" rtlCol="0" anchor="t"/>
+          <a:lstStyle/>
+          <a:p>
+            <a:pPr algn="l" indent="0" marL="0">
+              <a:buNone/>
+            </a:pPr>
+            <a:r>
+              <a:rPr lang="en-US" sz="3000" b="1" dirty="0">
+                <a:solidFill>
+                  <a:srgbClr val="FFFFFF"/>
+                </a:solidFill>
+                <a:latin typeface="Calibri" pitchFamily="34" charset="0"/>
+                <a:ea typeface="Calibri" pitchFamily="34" charset="-122"/>
+                <a:cs typeface="Calibri" pitchFamily="34" charset="-120"/>
+              </a:rPr>
               <a:t>Sammenligning i oversikt</a:t>
             </a:r>
             <a:endParaRPr lang="en-US" sz="3000" dirty="0"/>
@@ -5871,7 +8070,7 @@
       </p:sp>
       <p:graphicFrame>
         <p:nvGraphicFramePr>
-          <p:cNvPr id="16" name="Table 0"/>
+          <p:cNvPr id="19" name="Table 0"/>
           <p:cNvGraphicFramePr>
             <a:graphicFrameLocks noGrp="1"/>
           </p:cNvGraphicFramePr>
@@ -7367,7 +9566,7 @@
                 <a:ea typeface="Calibri" pitchFamily="34" charset="-122"/>
                 <a:cs typeface="Calibri" pitchFamily="34" charset="-120"/>
               </a:rPr>
-              <a:t>15</a:t>
+              <a:t>18</a:t>
             </a:r>
             <a:endParaRPr lang="en-US" sz="1000" dirty="0"/>
           </a:p>
@@ -7381,9 +9580,9 @@
 </p:sld>
 </file>
 
-<file path=ppt/slides/slide16.xml><?xml version="1.0" encoding="utf-8"?>
+<file path=ppt/slides/slide19.xml><?xml version="1.0" encoding="utf-8"?>
 <p:sld xmlns:a="http://schemas.openxmlformats.org/drawingml/2006/main" xmlns:r="http://schemas.openxmlformats.org/officeDocument/2006/relationships" xmlns:p="http://schemas.openxmlformats.org/presentationml/2006/main">
-  <p:cSld name="Slide 16">
+  <p:cSld name="Slide 19">
     <p:bg>
       <p:bgPr>
         <a:solidFill>
@@ -8041,7 +10240,7 @@
                 <a:ea typeface="Calibri" pitchFamily="34" charset="-122"/>
                 <a:cs typeface="Calibri" pitchFamily="34" charset="-120"/>
               </a:rPr>
-              <a:t>16</a:t>
+              <a:t>19</a:t>
             </a:r>
             <a:endParaRPr lang="en-US" sz="1000" dirty="0"/>
           </a:p>

</xml_diff>

<commit_message>
Nexa deck: practical use cases slide (20 slides)
</commit_message>
<xml_diff>
--- a/docs/nexa-vs-bitcoin-ethereum/Nexa-vs-Bitcoin-Ethereum-NO.pptx
+++ b/docs/nexa-vs-bitcoin-ethereum/Nexa-vs-Bitcoin-Ethereum-NO.pptx
@@ -24,9 +24,10 @@
     <p:sldId id="272" r:id="rId18"/>
     <p:sldId id="273" r:id="rId19"/>
     <p:sldId id="274" r:id="rId20"/>
+    <p:sldId id="275" r:id="rId21"/>
   </p:sldIdLst>
   <p:notesMasterIdLst>
-    <p:notesMasterId r:id="rId21"/>
+    <p:notesMasterId r:id="rId22"/>
   </p:notesMasterIdLst>
   <p:sldSz cx="12192000" cy="6858000"/>
   <p:notesSz cx="6858000" cy="12192000"/>
@@ -1048,7 +1049,7 @@
           <a:p>
             <a:r>
               <a:rPr lang="en-US" dirty="0"/>
-              <a:t>nexa.org: «Native on-chain programmability without EVM complexity», «No EVM overhead». Utviklerstacken: Wally-lommebok, TDPP-betalingsprotokoll, nexid-identitet, CAPD-meldinger, NexaJS og libnexakotlin. Hold denne sliden kort for et ikke-teknisk publikum; utdyp bare hvis noen spør.</a:t>
+              <a:t>Dette er designmønstre, ikke produkter; hvert av dem bygger på en primitiv fra de forrige slidene. Tokens og batonger: native gruppetokens (spec.nexa.org/tokens/grouptokens), rene MINT-autoriteter delt fra batongen, mint-on-demand som en halvsignert transaksjon kjøperen finansierer, undergrupper for sesonger eller utgaver, MELT for å avvikle dem. CAPD: halvsignerte tilbud kringkastet på meldingsbussen og fullført av den som tar dem (spec.nexa.org/network/capd); tak på videresalg er en covenant i tokenets skriptmal. Token Secrets: tokenet forplikter seg til en hemmelighets offentlige nøkkel, og overføringen avslører den for kjøperen via ECDH (spec.nexa.org/tokensecret). Dette er svaret på arrangørenes bekymring for finansialisering: hvert eksempel er noe folk bruker, priset i brøkdeler av et øre, uten børs, markedsplassoperatør eller gassmarked imellom.</a:t>
             </a:r>
             <a:endParaRPr lang="en-US" dirty="0"/>
           </a:p>
@@ -1136,7 +1137,7 @@
           <a:p>
             <a:r>
               <a:rPr lang="en-US" dirty="0"/>
-              <a:t>Kilder: spec.nexa.org/nexid (Nexa Identity Protocol), spec.nexa.org/transactions/challengeTransaction, spec.nexa.org/dpp (Delegated Payment Protocol). nexid: nettstedet presenterer et innloggingstilbud med en tilfeldig utfordring via QR eller nettleserutvidelse; lommeboken avleder en nettstedsspesifikk privat nøkkel fra hovednøkkelen pluss et valgfritt nettstedspassord, signerer og sender den signerte meldingen direkte til serveren utenom den ubetrodde datamaskinen; sikkerhetskopi er de 12 ordene. Challenge transactions: en transaksjon med høyeste bit i versjonsfeltet satt er ugyldig for alltid; ett data-output bærer utfordrerens identitet og en tilfeldig utfordring; å signere den beviser kontroll over de refererte UTXO-ene under et hvilket som helst skript, noe vanlig meldingssignering ikke kan for multisig eller kontrakter. DPP: aktøren registrerer seg med foreslåtte grenser og sender signerte betalingsforespørsler; lommeboken, ikke butikken, avgjør automatisk eller godkjent utførelse. For et norsk publikum: BankID for innlogging, AvtaleGiro og kort på fil for betalinger er de kjente sammenligningene.</a:t>
+              <a:t>nexa.org: «Native on-chain programmability without EVM complexity», «No EVM overhead». Utviklerstacken: Wally-lommebok, TDPP-betalingsprotokoll, nexid-identitet, CAPD-meldinger, NexaJS og libnexakotlin. Hold denne sliden kort for et ikke-teknisk publikum; utdyp bare hvis noen spør.</a:t>
             </a:r>
             <a:endParaRPr lang="en-US" dirty="0"/>
           </a:p>
@@ -1224,7 +1225,7 @@
           <a:p>
             <a:r>
               <a:rPr lang="en-US" dirty="0"/>
-              <a:t>SSB: 98 % av Norges strøm fra vann og vind (sent 2025); normal årsproduksjon ~157 TWh, forbruk ~140 TWh. Juni 2025: regjeringen varslet et midlertidig forbud mot nye proof-of-work-datasentre for mining, med obligatorisk datasenterregister; myndighetene har antydet at det kan bli permanent. Vær ærlig: forbudet gjelder PoW-mining generelt, så en Nexa-farm ville også vært omfattet. Poenget er at Nexas nettverk ikke er avhengig av farmer noe sted.</a:t>
+              <a:t>Kilder: spec.nexa.org/nexid (Nexa Identity Protocol), spec.nexa.org/transactions/challengeTransaction, spec.nexa.org/dpp (Delegated Payment Protocol). nexid: nettstedet presenterer et innloggingstilbud med en tilfeldig utfordring via QR eller nettleserutvidelse; lommeboken avleder en nettstedsspesifikk privat nøkkel fra hovednøkkelen pluss et valgfritt nettstedspassord, signerer og sender den signerte meldingen direkte til serveren utenom den ubetrodde datamaskinen; sikkerhetskopi er de 12 ordene. Challenge transactions: en transaksjon med høyeste bit i versjonsfeltet satt er ugyldig for alltid; ett data-output bærer utfordrerens identitet og en tilfeldig utfordring; å signere den beviser kontroll over de refererte UTXO-ene under et hvilket som helst skript, noe vanlig meldingssignering ikke kan for multisig eller kontrakter. DPP: aktøren registrerer seg med foreslåtte grenser og sender signerte betalingsforespørsler; lommeboken, ikke butikken, avgjør automatisk eller godkjent utførelse. For et norsk publikum: BankID for innlogging, AvtaleGiro og kort på fil for betalinger er de kjente sammenligningene.</a:t>
             </a:r>
             <a:endParaRPr lang="en-US" dirty="0"/>
           </a:p>
@@ -1312,7 +1313,7 @@
           <a:p>
             <a:r>
               <a:rPr lang="en-US" dirty="0"/>
-              <a:t>Ett-slides svar på arrangørenes tre temaer: energi og e-avfall, hvem som tjener på det, og NFT-spekulasjon. Hvert tall står tidligere i presentasjonen med kilde.</a:t>
+              <a:t>SSB: 98 % av Norges strøm fra vann og vind (sent 2025); normal årsproduksjon ~157 TWh, forbruk ~140 TWh. Juni 2025: regjeringen varslet et midlertidig forbud mot nye proof-of-work-datasentre for mining, med obligatorisk datasenterregister; myndighetene har antydet at det kan bli permanent. Vær ærlig: forbudet gjelder PoW-mining generelt, så en Nexa-farm ville også vært omfattet. Poenget er at Nexas nettverk ikke er avhengig av farmer noe sted.</a:t>
             </a:r>
             <a:endParaRPr lang="en-US" dirty="0"/>
           </a:p>
@@ -1400,7 +1401,7 @@
           <a:p>
             <a:r>
               <a:rPr lang="en-US" dirty="0"/>
-              <a:t>Avslutt med de tre svarene på de tre bekymringene. Hvis 13 000×-tallet utfordres: det er en kapasitetssammenligning ved lik nettverkseffekt, 5 600× på dagens benchmark og 13 000× med Blitz; gulvet er 1 000× fordi Bitcoin ikke kan overstige ~14 TPS.</a:t>
+              <a:t>Ett-slides svar på arrangørenes tre temaer: energi og e-avfall, hvem som tjener på det, og NFT-spekulasjon. Hvert tall står tidligere i presentasjonen med kilde.</a:t>
             </a:r>
             <a:endParaRPr lang="en-US" dirty="0"/>
           </a:p>
@@ -1512,6 +1513,94 @@
             <a:fld id="{F7021451-1387-4CA6-816F-3879F97B5CBC}" type="slidenum">
               <a:rPr lang="en-US"/>
               <a:t>2</a:t>
+            </a:fld>
+            <a:endParaRPr lang="en-US"/>
+          </a:p>
+        </p:txBody>
+      </p:sp>
+    </p:spTree>
+    <p:extLst>
+      <p:ext uri="{BB962C8B-B14F-4D97-AF65-F5344CB8AC3E}">
+        <p14:creationId xmlns:p14="http://schemas.microsoft.com/office/powerpoint/2010/main" val="1024086991"/>
+      </p:ext>
+    </p:extLst>
+  </p:cSld>
+  <p:clrMapOvr>
+    <a:masterClrMapping/>
+  </p:clrMapOvr>
+</p:notes>
+</file>
+
+<file path=ppt/notesSlides/notesSlide20.xml><?xml version="1.0" encoding="utf-8"?>
+<p:notes xmlns:a="http://schemas.openxmlformats.org/drawingml/2006/main" xmlns:r="http://schemas.openxmlformats.org/officeDocument/2006/relationships" xmlns:p="http://schemas.openxmlformats.org/presentationml/2006/main">
+  <p:cSld>
+    <p:spTree>
+      <p:nvGrpSpPr>
+        <p:cNvPr id="1" name=""/>
+        <p:cNvGrpSpPr/>
+        <p:nvPr/>
+      </p:nvGrpSpPr>
+      <p:grpSpPr>
+        <a:xfrm>
+          <a:off x="0" y="0"/>
+          <a:ext cx="0" cy="0"/>
+          <a:chOff x="0" y="0"/>
+          <a:chExt cx="0" cy="0"/>
+        </a:xfrm>
+      </p:grpSpPr>
+      <p:sp>
+        <p:nvSpPr>
+          <p:cNvPr id="2" name="Slide Image Placeholder 1"/>
+          <p:cNvSpPr>
+            <a:spLocks noGrp="1" noRot="1" noChangeAspect="1"/>
+          </p:cNvSpPr>
+          <p:nvPr>
+            <p:ph type="sldImg"/>
+          </p:nvPr>
+        </p:nvSpPr>
+        <p:spPr/>
+      </p:sp>
+      <p:sp>
+        <p:nvSpPr>
+          <p:cNvPr id="3" name="Notes Placeholder 2"/>
+          <p:cNvSpPr>
+            <a:spLocks noGrp="1"/>
+          </p:cNvSpPr>
+          <p:nvPr>
+            <p:ph type="body" idx="1"/>
+          </p:nvPr>
+        </p:nvSpPr>
+        <p:spPr/>
+        <p:txBody>
+          <a:bodyPr/>
+          <a:lstStyle/>
+          <a:p>
+            <a:r>
+              <a:rPr lang="en-US" dirty="0"/>
+              <a:t>Avslutt med de tre svarene på de tre bekymringene. Hvis 13 000×-tallet utfordres: det er en kapasitetssammenligning ved lik nettverkseffekt, 5 600× på dagens benchmark og 13 000× med Blitz; gulvet er 1 000× fordi Bitcoin ikke kan overstige ~14 TPS.</a:t>
+            </a:r>
+            <a:endParaRPr lang="en-US" dirty="0"/>
+          </a:p>
+        </p:txBody>
+      </p:sp>
+      <p:sp>
+        <p:nvSpPr>
+          <p:cNvPr id="4" name="Slide Number Placeholder 3"/>
+          <p:cNvSpPr>
+            <a:spLocks noGrp="1"/>
+          </p:cNvSpPr>
+          <p:nvPr>
+            <p:ph type="sldNum" sz="quarter" idx="10"/>
+          </p:nvPr>
+        </p:nvSpPr>
+        <p:spPr/>
+        <p:txBody>
+          <a:bodyPr/>
+          <a:lstStyle/>
+          <a:p>
+            <a:fld id="{F7021451-1387-4CA6-816F-3879F97B5CBC}" type="slidenum">
+              <a:rPr lang="en-US"/>
+              <a:t>20</a:t>
             </a:fld>
             <a:endParaRPr lang="en-US"/>
           </a:p>
@@ -6130,7 +6219,7 @@
                 <a:ea typeface="Calibri" pitchFamily="34" charset="-122"/>
                 <a:cs typeface="Calibri" pitchFamily="34" charset="-120"/>
               </a:rPr>
-              <a:t>Smartkontrakter uten EVM</a:t>
+              <a:t>Hva du kan bygge med det: praktiske bruksområder</a:t>
             </a:r>
             <a:endParaRPr lang="en-US" sz="3000" dirty="0"/>
           </a:p>
@@ -6145,7 +6234,7 @@
         <p:spPr>
           <a:xfrm>
             <a:off x="548640" y="1691640"/>
-            <a:ext cx="3515258" cy="3657600"/>
+            <a:ext cx="3515258" cy="4480560"/>
           </a:xfrm>
           <a:prstGeom prst="roundRect">
             <a:avLst>
@@ -6245,7 +6334,7 @@
                 <a:ea typeface="Calibri" pitchFamily="34" charset="-122"/>
                 <a:cs typeface="Calibri" pitchFamily="34" charset="-120"/>
               </a:rPr>
-              <a:t>Skriptmaler</a:t>
+              <a:t>Tokens og batonger</a:t>
             </a:r>
             <a:endParaRPr lang="en-US" sz="1800" dirty="0"/>
           </a:p>
@@ -6260,7 +6349,7 @@
         <p:spPr>
           <a:xfrm>
             <a:off x="822960" y="3474720"/>
-            <a:ext cx="2966618" cy="1600200"/>
+            <a:ext cx="2966618" cy="2423160"/>
           </a:xfrm>
           <a:prstGeom prst="rect">
             <a:avLst/>
@@ -6287,7 +6376,7 @@
                 <a:ea typeface="Calibri" pitchFamily="34" charset="-122"/>
                 <a:cs typeface="Calibri" pitchFamily="34" charset="-120"/>
               </a:rPr>
-              <a:t>Kontrakter er små, deterministiske skript knyttet til mynter og valideres parallelt som enhver annen transaksjon. Det finnes ingen global tilstandsmaskin å tette igjen.</a:t>
+              <a:t>Et spillstudio utsteder gjenstandene sine som native tokens og holder batongen kald. Butikken i spillet holder en ren MINT-autoritet i en mint-on-demand-kontrakt, så sverdet finnes først når spilleren har betalt. Et sesongpass er en undergruppe som destrueres etter sesongen; en festival gir et partnersted en MINT-autoritet for sin egen billettkvote.</a:t>
             </a:r>
             <a:endParaRPr lang="en-US" sz="1500" dirty="0"/>
           </a:p>
@@ -6302,7 +6391,7 @@
         <p:spPr>
           <a:xfrm>
             <a:off x="4338218" y="1691640"/>
-            <a:ext cx="3515258" cy="3657600"/>
+            <a:ext cx="3515258" cy="4480560"/>
           </a:xfrm>
           <a:prstGeom prst="roundRect">
             <a:avLst>
@@ -6402,7 +6491,7 @@
                 <a:ea typeface="Calibri" pitchFamily="34" charset="-122"/>
                 <a:cs typeface="Calibri" pitchFamily="34" charset="-120"/>
               </a:rPr>
-              <a:t>Ingen EVM-overhead</a:t>
+              <a:t>CAPD open outcry</a:t>
             </a:r>
             <a:endParaRPr lang="en-US" sz="1800" dirty="0"/>
           </a:p>
@@ -6417,7 +6506,7 @@
         <p:spPr>
           <a:xfrm>
             <a:off x="4612538" y="3474720"/>
-            <a:ext cx="2966618" cy="1600200"/>
+            <a:ext cx="2966618" cy="2423160"/>
           </a:xfrm>
           <a:prstGeom prst="rect">
             <a:avLst/>
@@ -6444,7 +6533,7 @@
                 <a:ea typeface="Calibri" pitchFamily="34" charset="-122"/>
                 <a:cs typeface="Calibri" pitchFamily="34" charset="-120"/>
               </a:rPr>
-              <a:t>Intet gassmarked, ingen reentrancy-feilklasse, ingen gebyrhopp for alle når én app blir populær. Kontrakter kjører i de samme 42 000 TPS som vanlige betalinger.</a:t>
+              <a:t>Et spiller-til-spiller-marked for gjenstander uten markedsplassoperatør: selgere kringkaster halvsignerte tilbud, kjøpere tar dem, og byttet gjøres opp atomisk. En billettbørs der en covenant setter tak på videresalg til pålydende. En lokal tavle for NEXA mot tokens på en meetup eller et LAN, som bare trenger nodene.</a:t>
             </a:r>
             <a:endParaRPr lang="en-US" sz="1500" dirty="0"/>
           </a:p>
@@ -6459,7 +6548,7 @@
         <p:spPr>
           <a:xfrm>
             <a:off x="8127797" y="1691640"/>
-            <a:ext cx="3515258" cy="3657600"/>
+            <a:ext cx="3515258" cy="4480560"/>
           </a:xfrm>
           <a:prstGeom prst="roundRect">
             <a:avLst>
@@ -6559,7 +6648,7 @@
                 <a:ea typeface="Calibri" pitchFamily="34" charset="-122"/>
                 <a:cs typeface="Calibri" pitchFamily="34" charset="-120"/>
               </a:rPr>
-              <a:t>En hel plattform</a:t>
+              <a:t>Token Secrets</a:t>
             </a:r>
             <a:endParaRPr lang="en-US" sz="1800" dirty="0"/>
           </a:p>
@@ -6574,7 +6663,7 @@
         <p:spPr>
           <a:xfrm>
             <a:off x="8402117" y="3474720"/>
-            <a:ext cx="2966618" cy="1600200"/>
+            <a:ext cx="2966618" cy="2423160"/>
           </a:xfrm>
           <a:prstGeom prst="rect">
             <a:avLst/>
@@ -6601,7 +6690,7 @@
                 <a:ea typeface="Calibri" pitchFamily="34" charset="-122"/>
                 <a:cs typeface="Calibri" pitchFamily="34" charset="-120"/>
               </a:rPr>
-              <a:t>Lommebokinnlogging med identitet på kjeden, betalingsforespørsler til brukerens lommebok og peer-to-peer-meldinger er del av stacken, med Kotlin- og JavaScript-biblioteker.</a:t>
+              <a:t>En spillnøkkel levert inne i kjøpstransaksjonen: kjøperen får tokenet og lisensnøkkelen i ett steg, og ingen andre kan lese den. Kryptert DLC eller en artikkel bak betalingsmur der tokenet bærer dekrypteringsnøkkelen. En konsertbillett som bærer dørkoden, avslørt bare for innehaveren.</a:t>
             </a:r>
             <a:endParaRPr lang="en-US" sz="1500" dirty="0"/>
           </a:p>
@@ -6774,7 +6863,7 @@
                 <a:ea typeface="Calibri" pitchFamily="34" charset="-122"/>
                 <a:cs typeface="Calibri" pitchFamily="34" charset="-120"/>
               </a:rPr>
-              <a:t>Identitet og betalinger bor i lommeboken, ikke hos butikken</a:t>
+              <a:t>Smartkontrakter uten EVM</a:t>
             </a:r>
             <a:endParaRPr lang="en-US" sz="3000" dirty="0"/>
           </a:p>
@@ -6789,7 +6878,7 @@
         <p:spPr>
           <a:xfrm>
             <a:off x="548640" y="1691640"/>
-            <a:ext cx="3515258" cy="4206240"/>
+            <a:ext cx="3515258" cy="3657600"/>
           </a:xfrm>
           <a:prstGeom prst="roundRect">
             <a:avLst>
@@ -6889,7 +6978,7 @@
                 <a:ea typeface="Calibri" pitchFamily="34" charset="-122"/>
                 <a:cs typeface="Calibri" pitchFamily="34" charset="-120"/>
               </a:rPr>
-              <a:t>Logg inn med mobilen, uten passord (nexid)</a:t>
+              <a:t>Skriptmaler</a:t>
             </a:r>
             <a:endParaRPr lang="en-US" sz="1800" dirty="0"/>
           </a:p>
@@ -6904,7 +6993,7 @@
         <p:spPr>
           <a:xfrm>
             <a:off x="822960" y="3474720"/>
-            <a:ext cx="2966618" cy="2148840"/>
+            <a:ext cx="2966618" cy="1600200"/>
           </a:xfrm>
           <a:prstGeom prst="rect">
             <a:avLst/>
@@ -6931,7 +7020,7 @@
                 <a:ea typeface="Calibri" pitchFamily="34" charset="-122"/>
                 <a:cs typeface="Calibri" pitchFamily="34" charset="-120"/>
               </a:rPr>
-              <a:t>Nettstedet viser en utfordring i en QR-kode, mobilen signerer den med en nøkkel avledet per nettsted, og svaret går rett fra mobilen til serveren. Nøkkelen forlater aldri telefonen, hvert nettsted får sin egen identitet, og lookalike-domener feiler. BankID-opplevelsen uten bank.</a:t>
+              <a:t>Kontrakter er små, deterministiske skript knyttet til mynter og valideres parallelt som enhver annen transaksjon. Det finnes ingen global tilstandsmaskin å tette igjen.</a:t>
             </a:r>
             <a:endParaRPr lang="en-US" sz="1500" dirty="0"/>
           </a:p>
@@ -6946,7 +7035,7 @@
         <p:spPr>
           <a:xfrm>
             <a:off x="4338218" y="1691640"/>
-            <a:ext cx="3515258" cy="4206240"/>
+            <a:ext cx="3515258" cy="3657600"/>
           </a:xfrm>
           <a:prstGeom prst="roundRect">
             <a:avLst>
@@ -7046,7 +7135,7 @@
                 <a:ea typeface="Calibri" pitchFamily="34" charset="-122"/>
                 <a:cs typeface="Calibri" pitchFamily="34" charset="-120"/>
               </a:rPr>
-              <a:t>Bevis eierskap uten å bruke noe</a:t>
+              <a:t>Ingen EVM-overhead</a:t>
             </a:r>
             <a:endParaRPr lang="en-US" sz="1800" dirty="0"/>
           </a:p>
@@ -7061,7 +7150,7 @@
         <p:spPr>
           <a:xfrm>
             <a:off x="4612538" y="3474720"/>
-            <a:ext cx="2966618" cy="2148840"/>
+            <a:ext cx="2966618" cy="1600200"/>
           </a:xfrm>
           <a:prstGeom prst="rect">
             <a:avLst/>
@@ -7088,7 +7177,7 @@
                 <a:ea typeface="Calibri" pitchFamily="34" charset="-122"/>
                 <a:cs typeface="Calibri" pitchFamily="34" charset="-120"/>
               </a:rPr>
-              <a:t>Challenge transactions: du signerer en bevisst ugyldig transaksjon som aldri sendes. Det beviser kontroll over mynter, NFT-er eller en multisig under et hvilket som helst skript, og er det som gjør tokenstyrt tilgang mulig.</a:t>
+              <a:t>Intet gassmarked, ingen reentrancy-feilklasse, ingen gebyrhopp for alle når én app blir populær. Kontrakter kjører i de samme 42 000 TPS som vanlige betalinger.</a:t>
             </a:r>
             <a:endParaRPr lang="en-US" sz="1500" dirty="0"/>
           </a:p>
@@ -7103,7 +7192,7 @@
         <p:spPr>
           <a:xfrm>
             <a:off x="8127797" y="1691640"/>
-            <a:ext cx="3515258" cy="4206240"/>
+            <a:ext cx="3515258" cy="3657600"/>
           </a:xfrm>
           <a:prstGeom prst="roundRect">
             <a:avLst>
@@ -7203,7 +7292,7 @@
                 <a:ea typeface="Calibri" pitchFamily="34" charset="-122"/>
                 <a:cs typeface="Calibri" pitchFamily="34" charset="-120"/>
               </a:rPr>
-              <a:t>Abonnement som lommeboken styrer (DPP)</a:t>
+              <a:t>En hel plattform</a:t>
             </a:r>
             <a:endParaRPr lang="en-US" sz="1800" dirty="0"/>
           </a:p>
@@ -7218,7 +7307,7 @@
         <p:spPr>
           <a:xfrm>
             <a:off x="8402117" y="3474720"/>
-            <a:ext cx="2966618" cy="2148840"/>
+            <a:ext cx="2966618" cy="1600200"/>
           </a:xfrm>
           <a:prstGeom prst="rect">
             <a:avLst/>
@@ -7245,7 +7334,7 @@
                 <a:ea typeface="Calibri" pitchFamily="34" charset="-122"/>
                 <a:cs typeface="Calibri" pitchFamily="34" charset="-120"/>
               </a:rPr>
-              <a:t>Butikken registrerer seg hos lommeboken din og foreslår grenser per betaling, dag, uke og måned. Lommeboken bestemmer om en betaling går automatisk eller spør deg; butikken kan ikke tvinge den gjennom, og du sier opp alt ett sted. Det motsatte av kort på fil.</a:t>
+              <a:t>Lommebokinnlogging med identitet på kjeden, betalingsforespørsler til brukerens lommebok og peer-to-peer-meldinger er del av stacken, med Kotlin- og JavaScript-biblioteker.</a:t>
             </a:r>
             <a:endParaRPr lang="en-US" sz="1500" dirty="0"/>
           </a:p>
@@ -7418,7 +7507,7 @@
                 <a:ea typeface="Calibri" pitchFamily="34" charset="-122"/>
                 <a:cs typeface="Calibri" pitchFamily="34" charset="-120"/>
               </a:rPr>
-              <a:t>Hvorfor dette betyr noe i Norge</a:t>
+              <a:t>Identitet og betalinger bor i lommeboken, ikke hos butikken</a:t>
             </a:r>
             <a:endParaRPr lang="en-US" sz="3000" dirty="0"/>
           </a:p>
@@ -7433,7 +7522,7 @@
         <p:spPr>
           <a:xfrm>
             <a:off x="548640" y="1691640"/>
-            <a:ext cx="3515258" cy="3657600"/>
+            <a:ext cx="3515258" cy="4206240"/>
           </a:xfrm>
           <a:prstGeom prst="roundRect">
             <a:avLst>
@@ -7533,7 +7622,7 @@
                 <a:ea typeface="Calibri" pitchFamily="34" charset="-122"/>
                 <a:cs typeface="Calibri" pitchFamily="34" charset="-120"/>
               </a:rPr>
-              <a:t>Et rent nett under press</a:t>
+              <a:t>Logg inn med mobilen, uten passord (nexid)</a:t>
             </a:r>
             <a:endParaRPr lang="en-US" sz="1800" dirty="0"/>
           </a:p>
@@ -7548,7 +7637,7 @@
         <p:spPr>
           <a:xfrm>
             <a:off x="822960" y="3474720"/>
-            <a:ext cx="2966618" cy="1600200"/>
+            <a:ext cx="2966618" cy="2148840"/>
           </a:xfrm>
           <a:prstGeom prst="rect">
             <a:avLst/>
@@ -7575,7 +7664,7 @@
                 <a:ea typeface="Calibri" pitchFamily="34" charset="-122"/>
                 <a:cs typeface="Calibri" pitchFamily="34" charset="-120"/>
               </a:rPr>
-              <a:t>98 % av Norges strøm er vann og vind, likevel stanset regjeringen i 2025 nye proof-of-work-datasentre for å verne nettkapasiteten. Nexa-mining kjører på vanlige GPU-er og er ikke avhengig av datasentre.</a:t>
+              <a:t>Nettstedet viser en utfordring i en QR-kode, mobilen signerer den med en nøkkel avledet per nettsted, og svaret går rett fra mobilen til serveren. Nøkkelen forlater aldri telefonen, hvert nettsted får sin egen identitet, og lookalike-domener feiler. BankID-opplevelsen uten bank.</a:t>
             </a:r>
             <a:endParaRPr lang="en-US" sz="1500" dirty="0"/>
           </a:p>
@@ -7590,7 +7679,7 @@
         <p:spPr>
           <a:xfrm>
             <a:off x="4338218" y="1691640"/>
-            <a:ext cx="3515258" cy="3657600"/>
+            <a:ext cx="3515258" cy="4206240"/>
           </a:xfrm>
           <a:prstGeom prst="roundRect">
             <a:avLst>
@@ -7623,11 +7712,11 @@
             <a:avLst/>
           </a:prstGeom>
           <a:solidFill>
-            <a:srgbClr val="F7931A"/>
+            <a:srgbClr val="F2CD3A"/>
           </a:solidFill>
           <a:ln w="12700">
             <a:solidFill>
-              <a:srgbClr val="F7931A"/>
+              <a:srgbClr val="F2CD3A"/>
             </a:solidFill>
             <a:prstDash val="solid"/>
           </a:ln>
@@ -7690,7 +7779,7 @@
                 <a:ea typeface="Calibri" pitchFamily="34" charset="-122"/>
                 <a:cs typeface="Calibri" pitchFamily="34" charset="-120"/>
               </a:rPr>
-              <a:t>Bitcoin ≈ Norge</a:t>
+              <a:t>Bevis eierskap uten å bruke noe</a:t>
             </a:r>
             <a:endParaRPr lang="en-US" sz="1800" dirty="0"/>
           </a:p>
@@ -7705,7 +7794,7 @@
         <p:spPr>
           <a:xfrm>
             <a:off x="4612538" y="3474720"/>
-            <a:ext cx="2966618" cy="1600200"/>
+            <a:ext cx="2966618" cy="2148840"/>
           </a:xfrm>
           <a:prstGeom prst="rect">
             <a:avLst/>
@@ -7732,7 +7821,7 @@
                 <a:ea typeface="Calibri" pitchFamily="34" charset="-122"/>
                 <a:cs typeface="Calibri" pitchFamily="34" charset="-120"/>
               </a:rPr>
-              <a:t>Bitcoins rundt 140 TWh i året tilsvarer hele Norges strømforbruk, for 7 transaksjoner i sekundet. Samme strøm på Nexa ville båret tusenvis av ganger flere betalinger.</a:t>
+              <a:t>Challenge transactions: du signerer en bevisst ugyldig transaksjon som aldri sendes. Det beviser kontroll over mynter, NFT-er eller en multisig under et hvilket som helst skript, og er det som gjør tokenstyrt tilgang mulig.</a:t>
             </a:r>
             <a:endParaRPr lang="en-US" sz="1500" dirty="0"/>
           </a:p>
@@ -7747,7 +7836,7 @@
         <p:spPr>
           <a:xfrm>
             <a:off x="8127797" y="1691640"/>
-            <a:ext cx="3515258" cy="3657600"/>
+            <a:ext cx="3515258" cy="4206240"/>
           </a:xfrm>
           <a:prstGeom prst="roundRect">
             <a:avLst>
@@ -7847,7 +7936,7 @@
                 <a:ea typeface="Calibri" pitchFamily="34" charset="-122"/>
                 <a:cs typeface="Calibri" pitchFamily="34" charset="-120"/>
               </a:rPr>
-              <a:t>Et kontantløst land</a:t>
+              <a:t>Abonnement som lommeboken styrer (DPP)</a:t>
             </a:r>
             <a:endParaRPr lang="en-US" sz="1800" dirty="0"/>
           </a:p>
@@ -7862,7 +7951,7 @@
         <p:spPr>
           <a:xfrm>
             <a:off x="8402117" y="3474720"/>
-            <a:ext cx="2966618" cy="1600200"/>
+            <a:ext cx="2966618" cy="2148840"/>
           </a:xfrm>
           <a:prstGeom prst="rect">
             <a:avLst/>
@@ -7889,7 +7978,7 @@
                 <a:ea typeface="Calibri" pitchFamily="34" charset="-122"/>
                 <a:cs typeface="Calibri" pitchFamily="34" charset="-120"/>
               </a:rPr>
-              <a:t>Nordmenn betaler allerede med mobilen på sekunder. En rail for energieffektive penger som gjør opp på to sekunder for en brøkdel av et øre passer slik folk her allerede lever.</a:t>
+              <a:t>Butikken registrerer seg hos lommeboken din og foreslår grenser per betaling, dag, uke og måned. Lommeboken bestemmer om en betaling går automatisk eller spør deg; butikken kan ikke tvinge den gjennom, og du sier opp alt ett sted. Det motsatte av kort på fil.</a:t>
             </a:r>
             <a:endParaRPr lang="en-US" sz="1500" dirty="0"/>
           </a:p>
@@ -8062,6 +8151,650 @@
                 <a:ea typeface="Calibri" pitchFamily="34" charset="-122"/>
                 <a:cs typeface="Calibri" pitchFamily="34" charset="-120"/>
               </a:rPr>
+              <a:t>Hvorfor dette betyr noe i Norge</a:t>
+            </a:r>
+            <a:endParaRPr lang="en-US" sz="3000" dirty="0"/>
+          </a:p>
+        </p:txBody>
+      </p:sp>
+      <p:sp>
+        <p:nvSpPr>
+          <p:cNvPr id="3" name="Shape 1"/>
+          <p:cNvSpPr/>
+          <p:nvPr/>
+        </p:nvSpPr>
+        <p:spPr>
+          <a:xfrm>
+            <a:off x="548640" y="1691640"/>
+            <a:ext cx="3515258" cy="3657600"/>
+          </a:xfrm>
+          <a:prstGeom prst="roundRect">
+            <a:avLst>
+              <a:gd name="adj" fmla="val 3121"/>
+            </a:avLst>
+          </a:prstGeom>
+          <a:solidFill>
+            <a:srgbClr val="18181B"/>
+          </a:solidFill>
+          <a:ln w="9525">
+            <a:solidFill>
+              <a:srgbClr val="2E2E35"/>
+            </a:solidFill>
+            <a:prstDash val="solid"/>
+          </a:ln>
+        </p:spPr>
+      </p:sp>
+      <p:sp>
+        <p:nvSpPr>
+          <p:cNvPr id="4" name="Shape 2"/>
+          <p:cNvSpPr/>
+          <p:nvPr/>
+        </p:nvSpPr>
+        <p:spPr>
+          <a:xfrm>
+            <a:off x="822960" y="1965960"/>
+            <a:ext cx="640080" cy="640080"/>
+          </a:xfrm>
+          <a:prstGeom prst="ellipse">
+            <a:avLst/>
+          </a:prstGeom>
+          <a:solidFill>
+            <a:srgbClr val="F2CD3A"/>
+          </a:solidFill>
+          <a:ln w="12700">
+            <a:solidFill>
+              <a:srgbClr val="F2CD3A"/>
+            </a:solidFill>
+            <a:prstDash val="solid"/>
+          </a:ln>
+        </p:spPr>
+      </p:sp>
+      <p:pic>
+        <p:nvPicPr>
+          <p:cNvPr id="5" name="Image 0" descr="preencoded.png">    </p:cNvPr>
+          <p:cNvPicPr>
+            <a:picLocks noChangeAspect="1"/>
+          </p:cNvPicPr>
+          <p:nvPr/>
+        </p:nvPicPr>
+        <p:blipFill>
+          <a:blip r:embed="rId1"/>
+          <a:stretch>
+            <a:fillRect/>
+          </a:stretch>
+        </p:blipFill>
+        <p:spPr>
+          <a:xfrm>
+            <a:off x="976579" y="2119579"/>
+            <a:ext cx="332842" cy="332842"/>
+          </a:xfrm>
+          <a:prstGeom prst="rect">
+            <a:avLst/>
+          </a:prstGeom>
+        </p:spPr>
+      </p:pic>
+      <p:sp>
+        <p:nvSpPr>
+          <p:cNvPr id="6" name="Text 3"/>
+          <p:cNvSpPr txBox="1"/>
+          <p:nvPr/>
+        </p:nvSpPr>
+        <p:spPr>
+          <a:xfrm>
+            <a:off x="822960" y="2788920"/>
+            <a:ext cx="2966618" cy="640080"/>
+          </a:xfrm>
+          <a:prstGeom prst="rect">
+            <a:avLst/>
+          </a:prstGeom>
+          <a:noFill/>
+          <a:ln/>
+        </p:spPr>
+        <p:txBody>
+          <a:bodyPr wrap="square" lIns="0" tIns="0" rIns="0" bIns="0" rtlCol="0" anchor="t"/>
+          <a:lstStyle/>
+          <a:p>
+            <a:pPr indent="0" marL="0">
+              <a:buNone/>
+            </a:pPr>
+            <a:r>
+              <a:rPr lang="en-US" sz="1800" b="1" dirty="0">
+                <a:solidFill>
+                  <a:srgbClr val="FFFFFF"/>
+                </a:solidFill>
+                <a:latin typeface="Calibri" pitchFamily="34" charset="0"/>
+                <a:ea typeface="Calibri" pitchFamily="34" charset="-122"/>
+                <a:cs typeface="Calibri" pitchFamily="34" charset="-120"/>
+              </a:rPr>
+              <a:t>Et rent nett under press</a:t>
+            </a:r>
+            <a:endParaRPr lang="en-US" sz="1800" dirty="0"/>
+          </a:p>
+        </p:txBody>
+      </p:sp>
+      <p:sp>
+        <p:nvSpPr>
+          <p:cNvPr id="7" name="Text 4"/>
+          <p:cNvSpPr txBox="1"/>
+          <p:nvPr/>
+        </p:nvSpPr>
+        <p:spPr>
+          <a:xfrm>
+            <a:off x="822960" y="3474720"/>
+            <a:ext cx="2966618" cy="1600200"/>
+          </a:xfrm>
+          <a:prstGeom prst="rect">
+            <a:avLst/>
+          </a:prstGeom>
+          <a:noFill/>
+          <a:ln/>
+        </p:spPr>
+        <p:txBody>
+          <a:bodyPr wrap="square" lIns="0" tIns="0" rIns="0" bIns="0" rtlCol="0" anchor="t"/>
+          <a:lstStyle/>
+          <a:p>
+            <a:pPr indent="0" marL="0">
+              <a:spcAft>
+                <a:spcPts val="600"/>
+              </a:spcAft>
+              <a:buNone/>
+            </a:pPr>
+            <a:r>
+              <a:rPr lang="en-US" sz="1500" dirty="0">
+                <a:solidFill>
+                  <a:srgbClr val="E4E4E7"/>
+                </a:solidFill>
+                <a:latin typeface="Calibri" pitchFamily="34" charset="0"/>
+                <a:ea typeface="Calibri" pitchFamily="34" charset="-122"/>
+                <a:cs typeface="Calibri" pitchFamily="34" charset="-120"/>
+              </a:rPr>
+              <a:t>98 % av Norges strøm er vann og vind, likevel stanset regjeringen i 2025 nye proof-of-work-datasentre for å verne nettkapasiteten. Nexa-mining kjører på vanlige GPU-er og er ikke avhengig av datasentre.</a:t>
+            </a:r>
+            <a:endParaRPr lang="en-US" sz="1500" dirty="0"/>
+          </a:p>
+        </p:txBody>
+      </p:sp>
+      <p:sp>
+        <p:nvSpPr>
+          <p:cNvPr id="8" name="Shape 5"/>
+          <p:cNvSpPr/>
+          <p:nvPr/>
+        </p:nvSpPr>
+        <p:spPr>
+          <a:xfrm>
+            <a:off x="4338218" y="1691640"/>
+            <a:ext cx="3515258" cy="3657600"/>
+          </a:xfrm>
+          <a:prstGeom prst="roundRect">
+            <a:avLst>
+              <a:gd name="adj" fmla="val 3121"/>
+            </a:avLst>
+          </a:prstGeom>
+          <a:solidFill>
+            <a:srgbClr val="18181B"/>
+          </a:solidFill>
+          <a:ln w="9525">
+            <a:solidFill>
+              <a:srgbClr val="2E2E35"/>
+            </a:solidFill>
+            <a:prstDash val="solid"/>
+          </a:ln>
+        </p:spPr>
+      </p:sp>
+      <p:sp>
+        <p:nvSpPr>
+          <p:cNvPr id="9" name="Shape 6"/>
+          <p:cNvSpPr/>
+          <p:nvPr/>
+        </p:nvSpPr>
+        <p:spPr>
+          <a:xfrm>
+            <a:off x="4612538" y="1965960"/>
+            <a:ext cx="640080" cy="640080"/>
+          </a:xfrm>
+          <a:prstGeom prst="ellipse">
+            <a:avLst/>
+          </a:prstGeom>
+          <a:solidFill>
+            <a:srgbClr val="F7931A"/>
+          </a:solidFill>
+          <a:ln w="12700">
+            <a:solidFill>
+              <a:srgbClr val="F7931A"/>
+            </a:solidFill>
+            <a:prstDash val="solid"/>
+          </a:ln>
+        </p:spPr>
+      </p:sp>
+      <p:pic>
+        <p:nvPicPr>
+          <p:cNvPr id="10" name="Image 1" descr="preencoded.png">    </p:cNvPr>
+          <p:cNvPicPr>
+            <a:picLocks noChangeAspect="1"/>
+          </p:cNvPicPr>
+          <p:nvPr/>
+        </p:nvPicPr>
+        <p:blipFill>
+          <a:blip r:embed="rId2"/>
+          <a:stretch>
+            <a:fillRect/>
+          </a:stretch>
+        </p:blipFill>
+        <p:spPr>
+          <a:xfrm>
+            <a:off x="4766158" y="2119579"/>
+            <a:ext cx="332842" cy="332842"/>
+          </a:xfrm>
+          <a:prstGeom prst="rect">
+            <a:avLst/>
+          </a:prstGeom>
+        </p:spPr>
+      </p:pic>
+      <p:sp>
+        <p:nvSpPr>
+          <p:cNvPr id="11" name="Text 7"/>
+          <p:cNvSpPr txBox="1"/>
+          <p:nvPr/>
+        </p:nvSpPr>
+        <p:spPr>
+          <a:xfrm>
+            <a:off x="4612538" y="2788920"/>
+            <a:ext cx="2966618" cy="640080"/>
+          </a:xfrm>
+          <a:prstGeom prst="rect">
+            <a:avLst/>
+          </a:prstGeom>
+          <a:noFill/>
+          <a:ln/>
+        </p:spPr>
+        <p:txBody>
+          <a:bodyPr wrap="square" lIns="0" tIns="0" rIns="0" bIns="0" rtlCol="0" anchor="t"/>
+          <a:lstStyle/>
+          <a:p>
+            <a:pPr indent="0" marL="0">
+              <a:buNone/>
+            </a:pPr>
+            <a:r>
+              <a:rPr lang="en-US" sz="1800" b="1" dirty="0">
+                <a:solidFill>
+                  <a:srgbClr val="FFFFFF"/>
+                </a:solidFill>
+                <a:latin typeface="Calibri" pitchFamily="34" charset="0"/>
+                <a:ea typeface="Calibri" pitchFamily="34" charset="-122"/>
+                <a:cs typeface="Calibri" pitchFamily="34" charset="-120"/>
+              </a:rPr>
+              <a:t>Bitcoin ≈ Norge</a:t>
+            </a:r>
+            <a:endParaRPr lang="en-US" sz="1800" dirty="0"/>
+          </a:p>
+        </p:txBody>
+      </p:sp>
+      <p:sp>
+        <p:nvSpPr>
+          <p:cNvPr id="12" name="Text 8"/>
+          <p:cNvSpPr txBox="1"/>
+          <p:nvPr/>
+        </p:nvSpPr>
+        <p:spPr>
+          <a:xfrm>
+            <a:off x="4612538" y="3474720"/>
+            <a:ext cx="2966618" cy="1600200"/>
+          </a:xfrm>
+          <a:prstGeom prst="rect">
+            <a:avLst/>
+          </a:prstGeom>
+          <a:noFill/>
+          <a:ln/>
+        </p:spPr>
+        <p:txBody>
+          <a:bodyPr wrap="square" lIns="0" tIns="0" rIns="0" bIns="0" rtlCol="0" anchor="t"/>
+          <a:lstStyle/>
+          <a:p>
+            <a:pPr indent="0" marL="0">
+              <a:spcAft>
+                <a:spcPts val="600"/>
+              </a:spcAft>
+              <a:buNone/>
+            </a:pPr>
+            <a:r>
+              <a:rPr lang="en-US" sz="1500" dirty="0">
+                <a:solidFill>
+                  <a:srgbClr val="E4E4E7"/>
+                </a:solidFill>
+                <a:latin typeface="Calibri" pitchFamily="34" charset="0"/>
+                <a:ea typeface="Calibri" pitchFamily="34" charset="-122"/>
+                <a:cs typeface="Calibri" pitchFamily="34" charset="-120"/>
+              </a:rPr>
+              <a:t>Bitcoins rundt 140 TWh i året tilsvarer hele Norges strømforbruk, for 7 transaksjoner i sekundet. Samme strøm på Nexa ville båret tusenvis av ganger flere betalinger.</a:t>
+            </a:r>
+            <a:endParaRPr lang="en-US" sz="1500" dirty="0"/>
+          </a:p>
+        </p:txBody>
+      </p:sp>
+      <p:sp>
+        <p:nvSpPr>
+          <p:cNvPr id="13" name="Shape 9"/>
+          <p:cNvSpPr/>
+          <p:nvPr/>
+        </p:nvSpPr>
+        <p:spPr>
+          <a:xfrm>
+            <a:off x="8127797" y="1691640"/>
+            <a:ext cx="3515258" cy="3657600"/>
+          </a:xfrm>
+          <a:prstGeom prst="roundRect">
+            <a:avLst>
+              <a:gd name="adj" fmla="val 3121"/>
+            </a:avLst>
+          </a:prstGeom>
+          <a:solidFill>
+            <a:srgbClr val="18181B"/>
+          </a:solidFill>
+          <a:ln w="9525">
+            <a:solidFill>
+              <a:srgbClr val="2E2E35"/>
+            </a:solidFill>
+            <a:prstDash val="solid"/>
+          </a:ln>
+        </p:spPr>
+      </p:sp>
+      <p:sp>
+        <p:nvSpPr>
+          <p:cNvPr id="14" name="Shape 10"/>
+          <p:cNvSpPr/>
+          <p:nvPr/>
+        </p:nvSpPr>
+        <p:spPr>
+          <a:xfrm>
+            <a:off x="8402117" y="1965960"/>
+            <a:ext cx="640080" cy="640080"/>
+          </a:xfrm>
+          <a:prstGeom prst="ellipse">
+            <a:avLst/>
+          </a:prstGeom>
+          <a:solidFill>
+            <a:srgbClr val="F2CD3A"/>
+          </a:solidFill>
+          <a:ln w="12700">
+            <a:solidFill>
+              <a:srgbClr val="F2CD3A"/>
+            </a:solidFill>
+            <a:prstDash val="solid"/>
+          </a:ln>
+        </p:spPr>
+      </p:sp>
+      <p:pic>
+        <p:nvPicPr>
+          <p:cNvPr id="15" name="Image 2" descr="preencoded.png">    </p:cNvPr>
+          <p:cNvPicPr>
+            <a:picLocks noChangeAspect="1"/>
+          </p:cNvPicPr>
+          <p:nvPr/>
+        </p:nvPicPr>
+        <p:blipFill>
+          <a:blip r:embed="rId3"/>
+          <a:stretch>
+            <a:fillRect/>
+          </a:stretch>
+        </p:blipFill>
+        <p:spPr>
+          <a:xfrm>
+            <a:off x="8555736" y="2119579"/>
+            <a:ext cx="332842" cy="332842"/>
+          </a:xfrm>
+          <a:prstGeom prst="rect">
+            <a:avLst/>
+          </a:prstGeom>
+        </p:spPr>
+      </p:pic>
+      <p:sp>
+        <p:nvSpPr>
+          <p:cNvPr id="16" name="Text 11"/>
+          <p:cNvSpPr txBox="1"/>
+          <p:nvPr/>
+        </p:nvSpPr>
+        <p:spPr>
+          <a:xfrm>
+            <a:off x="8402117" y="2788920"/>
+            <a:ext cx="2966618" cy="640080"/>
+          </a:xfrm>
+          <a:prstGeom prst="rect">
+            <a:avLst/>
+          </a:prstGeom>
+          <a:noFill/>
+          <a:ln/>
+        </p:spPr>
+        <p:txBody>
+          <a:bodyPr wrap="square" lIns="0" tIns="0" rIns="0" bIns="0" rtlCol="0" anchor="t"/>
+          <a:lstStyle/>
+          <a:p>
+            <a:pPr indent="0" marL="0">
+              <a:buNone/>
+            </a:pPr>
+            <a:r>
+              <a:rPr lang="en-US" sz="1800" b="1" dirty="0">
+                <a:solidFill>
+                  <a:srgbClr val="FFFFFF"/>
+                </a:solidFill>
+                <a:latin typeface="Calibri" pitchFamily="34" charset="0"/>
+                <a:ea typeface="Calibri" pitchFamily="34" charset="-122"/>
+                <a:cs typeface="Calibri" pitchFamily="34" charset="-120"/>
+              </a:rPr>
+              <a:t>Et kontantløst land</a:t>
+            </a:r>
+            <a:endParaRPr lang="en-US" sz="1800" dirty="0"/>
+          </a:p>
+        </p:txBody>
+      </p:sp>
+      <p:sp>
+        <p:nvSpPr>
+          <p:cNvPr id="17" name="Text 12"/>
+          <p:cNvSpPr txBox="1"/>
+          <p:nvPr/>
+        </p:nvSpPr>
+        <p:spPr>
+          <a:xfrm>
+            <a:off x="8402117" y="3474720"/>
+            <a:ext cx="2966618" cy="1600200"/>
+          </a:xfrm>
+          <a:prstGeom prst="rect">
+            <a:avLst/>
+          </a:prstGeom>
+          <a:noFill/>
+          <a:ln/>
+        </p:spPr>
+        <p:txBody>
+          <a:bodyPr wrap="square" lIns="0" tIns="0" rIns="0" bIns="0" rtlCol="0" anchor="t"/>
+          <a:lstStyle/>
+          <a:p>
+            <a:pPr indent="0" marL="0">
+              <a:spcAft>
+                <a:spcPts val="600"/>
+              </a:spcAft>
+              <a:buNone/>
+            </a:pPr>
+            <a:r>
+              <a:rPr lang="en-US" sz="1500" dirty="0">
+                <a:solidFill>
+                  <a:srgbClr val="E4E4E7"/>
+                </a:solidFill>
+                <a:latin typeface="Calibri" pitchFamily="34" charset="0"/>
+                <a:ea typeface="Calibri" pitchFamily="34" charset="-122"/>
+                <a:cs typeface="Calibri" pitchFamily="34" charset="-120"/>
+              </a:rPr>
+              <a:t>Nordmenn betaler allerede med mobilen på sekunder. En rail for energieffektive penger som gjør opp på to sekunder for en brøkdel av et øre passer slik folk her allerede lever.</a:t>
+            </a:r>
+            <a:endParaRPr lang="en-US" sz="1500" dirty="0"/>
+          </a:p>
+        </p:txBody>
+      </p:sp>
+      <p:pic>
+        <p:nvPicPr>
+          <p:cNvPr id="19" name="Image 3" descr="preencoded.png">    </p:cNvPr>
+          <p:cNvPicPr>
+            <a:picLocks noChangeAspect="1"/>
+          </p:cNvPicPr>
+          <p:nvPr/>
+        </p:nvPicPr>
+        <p:blipFill>
+          <a:blip r:embed="rId4"/>
+          <a:stretch>
+            <a:fillRect/>
+          </a:stretch>
+        </p:blipFill>
+        <p:spPr>
+          <a:xfrm>
+            <a:off x="548640" y="6355080"/>
+            <a:ext cx="256032" cy="246888"/>
+          </a:xfrm>
+          <a:prstGeom prst="rect">
+            <a:avLst/>
+          </a:prstGeom>
+        </p:spPr>
+      </p:pic>
+      <p:sp>
+        <p:nvSpPr>
+          <p:cNvPr id="20" name="Text 13"/>
+          <p:cNvSpPr txBox="1"/>
+          <p:nvPr/>
+        </p:nvSpPr>
+        <p:spPr>
+          <a:xfrm>
+            <a:off x="877824" y="6400800"/>
+            <a:ext cx="2743200" cy="274320"/>
+          </a:xfrm>
+          <a:prstGeom prst="rect">
+            <a:avLst/>
+          </a:prstGeom>
+          <a:noFill/>
+          <a:ln/>
+        </p:spPr>
+        <p:txBody>
+          <a:bodyPr wrap="square" lIns="0" tIns="0" rIns="0" bIns="0" rtlCol="0" anchor="ctr"/>
+          <a:lstStyle/>
+          <a:p>
+            <a:pPr algn="l" indent="0" marL="0">
+              <a:buNone/>
+            </a:pPr>
+            <a:r>
+              <a:rPr lang="en-US" sz="1000" dirty="0">
+                <a:solidFill>
+                  <a:srgbClr val="A1A1AA"/>
+                </a:solidFill>
+                <a:latin typeface="Calibri" pitchFamily="34" charset="0"/>
+                <a:ea typeface="Calibri" pitchFamily="34" charset="-122"/>
+                <a:cs typeface="Calibri" pitchFamily="34" charset="-120"/>
+              </a:rPr>
+              <a:t>Nexa · 2026</a:t>
+            </a:r>
+            <a:endParaRPr lang="en-US" sz="1000" dirty="0"/>
+          </a:p>
+        </p:txBody>
+      </p:sp>
+      <p:sp>
+        <p:nvSpPr>
+          <p:cNvPr id="21" name="Text 14"/>
+          <p:cNvSpPr txBox="1"/>
+          <p:nvPr/>
+        </p:nvSpPr>
+        <p:spPr>
+          <a:xfrm>
+            <a:off x="11094415" y="6400800"/>
+            <a:ext cx="548640" cy="274320"/>
+          </a:xfrm>
+          <a:prstGeom prst="rect">
+            <a:avLst/>
+          </a:prstGeom>
+          <a:noFill/>
+          <a:ln/>
+        </p:spPr>
+        <p:txBody>
+          <a:bodyPr wrap="square" lIns="0" tIns="0" rIns="0" bIns="0" rtlCol="0" anchor="ctr"/>
+          <a:lstStyle/>
+          <a:p>
+            <a:pPr algn="r" indent="0" marL="0">
+              <a:buNone/>
+            </a:pPr>
+            <a:r>
+              <a:rPr lang="en-US" sz="1000" dirty="0">
+                <a:solidFill>
+                  <a:srgbClr val="A1A1AA"/>
+                </a:solidFill>
+                <a:latin typeface="Calibri" pitchFamily="34" charset="0"/>
+                <a:ea typeface="Calibri" pitchFamily="34" charset="-122"/>
+                <a:cs typeface="Calibri" pitchFamily="34" charset="-120"/>
+              </a:rPr>
+              <a:t>18</a:t>
+            </a:r>
+            <a:endParaRPr lang="en-US" sz="1000" dirty="0"/>
+          </a:p>
+        </p:txBody>
+      </p:sp>
+    </p:spTree>
+  </p:cSld>
+  <p:clrMapOvr>
+    <a:masterClrMapping/>
+  </p:clrMapOvr>
+</p:sld>
+</file>
+
+<file path=ppt/slides/slide19.xml><?xml version="1.0" encoding="utf-8"?>
+<p:sld xmlns:a="http://schemas.openxmlformats.org/drawingml/2006/main" xmlns:r="http://schemas.openxmlformats.org/officeDocument/2006/relationships" xmlns:p="http://schemas.openxmlformats.org/presentationml/2006/main">
+  <p:cSld name="Slide 19">
+    <p:bg>
+      <p:bgPr>
+        <a:solidFill>
+          <a:srgbClr val="0A0A0F"/>
+        </a:solidFill>
+      </p:bgPr>
+    </p:bg>
+    <p:spTree>
+      <p:nvGrpSpPr>
+        <p:cNvPr id="1" name=""/>
+        <p:cNvGrpSpPr/>
+        <p:nvPr/>
+      </p:nvGrpSpPr>
+      <p:grpSpPr>
+        <a:xfrm>
+          <a:off x="0" y="0"/>
+          <a:ext cx="0" cy="0"/>
+          <a:chOff x="0" y="0"/>
+          <a:chExt cx="0" cy="0"/>
+        </a:xfrm>
+      </p:grpSpPr>
+      <p:sp>
+        <p:nvSpPr>
+          <p:cNvPr id="2" name="Text 0"/>
+          <p:cNvSpPr txBox="1"/>
+          <p:nvPr/>
+        </p:nvSpPr>
+        <p:spPr>
+          <a:xfrm>
+            <a:off x="548640" y="411480"/>
+            <a:ext cx="11094415" cy="1005840"/>
+          </a:xfrm>
+          <a:prstGeom prst="rect">
+            <a:avLst/>
+          </a:prstGeom>
+          <a:noFill/>
+          <a:ln/>
+        </p:spPr>
+        <p:txBody>
+          <a:bodyPr wrap="square" lIns="0" tIns="0" rIns="0" bIns="0" rtlCol="0" anchor="t"/>
+          <a:lstStyle/>
+          <a:p>
+            <a:pPr algn="l" indent="0" marL="0">
+              <a:buNone/>
+            </a:pPr>
+            <a:r>
+              <a:rPr lang="en-US" sz="3000" b="1" dirty="0">
+                <a:solidFill>
+                  <a:srgbClr val="FFFFFF"/>
+                </a:solidFill>
+                <a:latin typeface="Calibri" pitchFamily="34" charset="0"/>
+                <a:ea typeface="Calibri" pitchFamily="34" charset="-122"/>
+                <a:cs typeface="Calibri" pitchFamily="34" charset="-120"/>
+              </a:rPr>
               <a:t>Sammenligning i oversikt</a:t>
             </a:r>
             <a:endParaRPr lang="en-US" sz="3000" dirty="0"/>
@@ -8070,7 +8803,7 @@
       </p:sp>
       <p:graphicFrame>
         <p:nvGraphicFramePr>
-          <p:cNvPr id="19" name="Table 0"/>
+          <p:cNvPr id="20" name="Table 0"/>
           <p:cNvGraphicFramePr>
             <a:graphicFrameLocks noGrp="1"/>
           </p:cNvGraphicFramePr>
@@ -9566,680 +10299,6 @@
                 <a:ea typeface="Calibri" pitchFamily="34" charset="-122"/>
                 <a:cs typeface="Calibri" pitchFamily="34" charset="-120"/>
               </a:rPr>
-              <a:t>18</a:t>
-            </a:r>
-            <a:endParaRPr lang="en-US" sz="1000" dirty="0"/>
-          </a:p>
-        </p:txBody>
-      </p:sp>
-    </p:spTree>
-  </p:cSld>
-  <p:clrMapOvr>
-    <a:masterClrMapping/>
-  </p:clrMapOvr>
-</p:sld>
-</file>
-
-<file path=ppt/slides/slide19.xml><?xml version="1.0" encoding="utf-8"?>
-<p:sld xmlns:a="http://schemas.openxmlformats.org/drawingml/2006/main" xmlns:r="http://schemas.openxmlformats.org/officeDocument/2006/relationships" xmlns:p="http://schemas.openxmlformats.org/presentationml/2006/main">
-  <p:cSld name="Slide 19">
-    <p:bg>
-      <p:bgPr>
-        <a:solidFill>
-          <a:srgbClr val="0A0A0F"/>
-        </a:solidFill>
-      </p:bgPr>
-    </p:bg>
-    <p:spTree>
-      <p:nvGrpSpPr>
-        <p:cNvPr id="1" name=""/>
-        <p:cNvGrpSpPr/>
-        <p:nvPr/>
-      </p:nvGrpSpPr>
-      <p:grpSpPr>
-        <a:xfrm>
-          <a:off x="0" y="0"/>
-          <a:ext cx="0" cy="0"/>
-          <a:chOff x="0" y="0"/>
-          <a:chExt cx="0" cy="0"/>
-        </a:xfrm>
-      </p:grpSpPr>
-      <p:sp>
-        <p:nvSpPr>
-          <p:cNvPr id="2" name="Text 0"/>
-          <p:cNvSpPr txBox="1"/>
-          <p:nvPr/>
-        </p:nvSpPr>
-        <p:spPr>
-          <a:xfrm>
-            <a:off x="548640" y="411480"/>
-            <a:ext cx="11094415" cy="1005840"/>
-          </a:xfrm>
-          <a:prstGeom prst="rect">
-            <a:avLst/>
-          </a:prstGeom>
-          <a:noFill/>
-          <a:ln/>
-        </p:spPr>
-        <p:txBody>
-          <a:bodyPr wrap="square" lIns="0" tIns="0" rIns="0" bIns="0" rtlCol="0" anchor="t"/>
-          <a:lstStyle/>
-          <a:p>
-            <a:pPr algn="l" indent="0" marL="0">
-              <a:buNone/>
-            </a:pPr>
-            <a:r>
-              <a:rPr lang="en-US" sz="3000" b="1" dirty="0">
-                <a:solidFill>
-                  <a:srgbClr val="FFFFFF"/>
-                </a:solidFill>
-                <a:latin typeface="Calibri" pitchFamily="34" charset="0"/>
-                <a:ea typeface="Calibri" pitchFamily="34" charset="-122"/>
-                <a:cs typeface="Calibri" pitchFamily="34" charset="-120"/>
-              </a:rPr>
-              <a:t>Tre ting å huske</a:t>
-            </a:r>
-            <a:endParaRPr lang="en-US" sz="3000" dirty="0"/>
-          </a:p>
-        </p:txBody>
-      </p:sp>
-      <p:sp>
-        <p:nvSpPr>
-          <p:cNvPr id="3" name="Shape 1"/>
-          <p:cNvSpPr/>
-          <p:nvPr/>
-        </p:nvSpPr>
-        <p:spPr>
-          <a:xfrm>
-            <a:off x="548640" y="1691640"/>
-            <a:ext cx="3515258" cy="3566160"/>
-          </a:xfrm>
-          <a:prstGeom prst="roundRect">
-            <a:avLst>
-              <a:gd name="adj" fmla="val 3121"/>
-            </a:avLst>
-          </a:prstGeom>
-          <a:solidFill>
-            <a:srgbClr val="18181B"/>
-          </a:solidFill>
-          <a:ln w="9525">
-            <a:solidFill>
-              <a:srgbClr val="2E2E35"/>
-            </a:solidFill>
-            <a:prstDash val="solid"/>
-          </a:ln>
-        </p:spPr>
-      </p:sp>
-      <p:sp>
-        <p:nvSpPr>
-          <p:cNvPr id="4" name="Shape 2"/>
-          <p:cNvSpPr/>
-          <p:nvPr/>
-        </p:nvSpPr>
-        <p:spPr>
-          <a:xfrm>
-            <a:off x="822960" y="1965960"/>
-            <a:ext cx="640080" cy="640080"/>
-          </a:xfrm>
-          <a:prstGeom prst="ellipse">
-            <a:avLst/>
-          </a:prstGeom>
-          <a:solidFill>
-            <a:srgbClr val="F2CD3A"/>
-          </a:solidFill>
-          <a:ln w="12700">
-            <a:solidFill>
-              <a:srgbClr val="F2CD3A"/>
-            </a:solidFill>
-            <a:prstDash val="solid"/>
-          </a:ln>
-        </p:spPr>
-      </p:sp>
-      <p:pic>
-        <p:nvPicPr>
-          <p:cNvPr id="5" name="Image 0" descr="preencoded.png">    </p:cNvPr>
-          <p:cNvPicPr>
-            <a:picLocks noChangeAspect="1"/>
-          </p:cNvPicPr>
-          <p:nvPr/>
-        </p:nvPicPr>
-        <p:blipFill>
-          <a:blip r:embed="rId1"/>
-          <a:stretch>
-            <a:fillRect/>
-          </a:stretch>
-        </p:blipFill>
-        <p:spPr>
-          <a:xfrm>
-            <a:off x="976579" y="2119579"/>
-            <a:ext cx="332842" cy="332842"/>
-          </a:xfrm>
-          <a:prstGeom prst="rect">
-            <a:avLst/>
-          </a:prstGeom>
-        </p:spPr>
-      </p:pic>
-      <p:sp>
-        <p:nvSpPr>
-          <p:cNvPr id="6" name="Text 3"/>
-          <p:cNvSpPr txBox="1"/>
-          <p:nvPr/>
-        </p:nvSpPr>
-        <p:spPr>
-          <a:xfrm>
-            <a:off x="822960" y="2788920"/>
-            <a:ext cx="2966618" cy="457200"/>
-          </a:xfrm>
-          <a:prstGeom prst="rect">
-            <a:avLst/>
-          </a:prstGeom>
-          <a:noFill/>
-          <a:ln/>
-        </p:spPr>
-        <p:txBody>
-          <a:bodyPr wrap="square" lIns="0" tIns="0" rIns="0" bIns="0" rtlCol="0" anchor="t"/>
-          <a:lstStyle/>
-          <a:p>
-            <a:pPr indent="0" marL="0">
-              <a:buNone/>
-            </a:pPr>
-            <a:r>
-              <a:rPr lang="en-US" sz="2000" b="1" dirty="0">
-                <a:solidFill>
-                  <a:srgbClr val="F2CD3A"/>
-                </a:solidFill>
-                <a:latin typeface="Calibri" pitchFamily="34" charset="0"/>
-                <a:ea typeface="Calibri" pitchFamily="34" charset="-122"/>
-                <a:cs typeface="Calibri" pitchFamily="34" charset="-120"/>
-              </a:rPr>
-              <a:t>Energi</a:t>
-            </a:r>
-            <a:endParaRPr lang="en-US" sz="2000" dirty="0"/>
-          </a:p>
-        </p:txBody>
-      </p:sp>
-      <p:sp>
-        <p:nvSpPr>
-          <p:cNvPr id="7" name="Text 4"/>
-          <p:cNvSpPr txBox="1"/>
-          <p:nvPr/>
-        </p:nvSpPr>
-        <p:spPr>
-          <a:xfrm>
-            <a:off x="822960" y="3337560"/>
-            <a:ext cx="2966618" cy="1645920"/>
-          </a:xfrm>
-          <a:prstGeom prst="rect">
-            <a:avLst/>
-          </a:prstGeom>
-          <a:noFill/>
-          <a:ln/>
-        </p:spPr>
-        <p:txBody>
-          <a:bodyPr wrap="square" lIns="0" tIns="0" rIns="0" bIns="0" rtlCol="0" anchor="t"/>
-          <a:lstStyle/>
-          <a:p>
-            <a:pPr indent="0" marL="0">
-              <a:buNone/>
-            </a:pPr>
-            <a:r>
-              <a:rPr lang="en-US" sz="1500" dirty="0">
-                <a:solidFill>
-                  <a:srgbClr val="E4E4E7"/>
-                </a:solidFill>
-                <a:latin typeface="Calibri" pitchFamily="34" charset="0"/>
-                <a:ea typeface="Calibri" pitchFamily="34" charset="-122"/>
-                <a:cs typeface="Calibri" pitchFamily="34" charset="-120"/>
-              </a:rPr>
-              <a:t>Proof of work koster det minerne får betalt, på enhver kjede. I stor skala får Nexa inntil 13 000× flere transaksjoner ut av hver kilowattime enn Bitcoin, på gjenbrukbare GPU-er, ikke ASIC-er som kastes.</a:t>
-            </a:r>
-            <a:endParaRPr lang="en-US" sz="1500" dirty="0"/>
-          </a:p>
-        </p:txBody>
-      </p:sp>
-      <p:sp>
-        <p:nvSpPr>
-          <p:cNvPr id="8" name="Shape 5"/>
-          <p:cNvSpPr/>
-          <p:nvPr/>
-        </p:nvSpPr>
-        <p:spPr>
-          <a:xfrm>
-            <a:off x="4338218" y="1691640"/>
-            <a:ext cx="3515258" cy="3566160"/>
-          </a:xfrm>
-          <a:prstGeom prst="roundRect">
-            <a:avLst>
-              <a:gd name="adj" fmla="val 3121"/>
-            </a:avLst>
-          </a:prstGeom>
-          <a:solidFill>
-            <a:srgbClr val="18181B"/>
-          </a:solidFill>
-          <a:ln w="9525">
-            <a:solidFill>
-              <a:srgbClr val="2E2E35"/>
-            </a:solidFill>
-            <a:prstDash val="solid"/>
-          </a:ln>
-        </p:spPr>
-      </p:sp>
-      <p:sp>
-        <p:nvSpPr>
-          <p:cNvPr id="9" name="Shape 6"/>
-          <p:cNvSpPr/>
-          <p:nvPr/>
-        </p:nvSpPr>
-        <p:spPr>
-          <a:xfrm>
-            <a:off x="4612538" y="1965960"/>
-            <a:ext cx="640080" cy="640080"/>
-          </a:xfrm>
-          <a:prstGeom prst="ellipse">
-            <a:avLst/>
-          </a:prstGeom>
-          <a:solidFill>
-            <a:srgbClr val="F2CD3A"/>
-          </a:solidFill>
-          <a:ln w="12700">
-            <a:solidFill>
-              <a:srgbClr val="F2CD3A"/>
-            </a:solidFill>
-            <a:prstDash val="solid"/>
-          </a:ln>
-        </p:spPr>
-      </p:sp>
-      <p:pic>
-        <p:nvPicPr>
-          <p:cNvPr id="10" name="Image 1" descr="preencoded.png">    </p:cNvPr>
-          <p:cNvPicPr>
-            <a:picLocks noChangeAspect="1"/>
-          </p:cNvPicPr>
-          <p:nvPr/>
-        </p:nvPicPr>
-        <p:blipFill>
-          <a:blip r:embed="rId2"/>
-          <a:stretch>
-            <a:fillRect/>
-          </a:stretch>
-        </p:blipFill>
-        <p:spPr>
-          <a:xfrm>
-            <a:off x="4766158" y="2119579"/>
-            <a:ext cx="332842" cy="332842"/>
-          </a:xfrm>
-          <a:prstGeom prst="rect">
-            <a:avLst/>
-          </a:prstGeom>
-        </p:spPr>
-      </p:pic>
-      <p:sp>
-        <p:nvSpPr>
-          <p:cNvPr id="11" name="Text 7"/>
-          <p:cNvSpPr txBox="1"/>
-          <p:nvPr/>
-        </p:nvSpPr>
-        <p:spPr>
-          <a:xfrm>
-            <a:off x="4612538" y="2788920"/>
-            <a:ext cx="2966618" cy="457200"/>
-          </a:xfrm>
-          <a:prstGeom prst="rect">
-            <a:avLst/>
-          </a:prstGeom>
-          <a:noFill/>
-          <a:ln/>
-        </p:spPr>
-        <p:txBody>
-          <a:bodyPr wrap="square" lIns="0" tIns="0" rIns="0" bIns="0" rtlCol="0" anchor="t"/>
-          <a:lstStyle/>
-          <a:p>
-            <a:pPr indent="0" marL="0">
-              <a:buNone/>
-            </a:pPr>
-            <a:r>
-              <a:rPr lang="en-US" sz="2000" b="1" dirty="0">
-                <a:solidFill>
-                  <a:srgbClr val="F2CD3A"/>
-                </a:solidFill>
-                <a:latin typeface="Calibri" pitchFamily="34" charset="0"/>
-                <a:ea typeface="Calibri" pitchFamily="34" charset="-122"/>
-                <a:cs typeface="Calibri" pitchFamily="34" charset="-120"/>
-              </a:rPr>
-              <a:t>Rettferdighet</a:t>
-            </a:r>
-            <a:endParaRPr lang="en-US" sz="2000" dirty="0"/>
-          </a:p>
-        </p:txBody>
-      </p:sp>
-      <p:sp>
-        <p:nvSpPr>
-          <p:cNvPr id="12" name="Text 8"/>
-          <p:cNvSpPr txBox="1"/>
-          <p:nvPr/>
-        </p:nvSpPr>
-        <p:spPr>
-          <a:xfrm>
-            <a:off x="4612538" y="3337560"/>
-            <a:ext cx="2966618" cy="1645920"/>
-          </a:xfrm>
-          <a:prstGeom prst="rect">
-            <a:avLst/>
-          </a:prstGeom>
-          <a:noFill/>
-          <a:ln/>
-        </p:spPr>
-        <p:txBody>
-          <a:bodyPr wrap="square" lIns="0" tIns="0" rIns="0" bIns="0" rtlCol="0" anchor="t"/>
-          <a:lstStyle/>
-          <a:p>
-            <a:pPr indent="0" marL="0">
-              <a:buNone/>
-            </a:pPr>
-            <a:r>
-              <a:rPr lang="en-US" sz="1500" dirty="0">
-                <a:solidFill>
-                  <a:srgbClr val="E4E4E7"/>
-                </a:solidFill>
-                <a:latin typeface="Calibri" pitchFamily="34" charset="0"/>
-                <a:ea typeface="Calibri" pitchFamily="34" charset="-122"/>
-                <a:cs typeface="Calibri" pitchFamily="34" charset="-120"/>
-              </a:rPr>
-              <a:t>Ingen premine, ingen ICO, ingen venturekapital. 100 % av tilbudet utvunnet offentlig siden 2022, åpent for alle med et skjermkort.</a:t>
-            </a:r>
-            <a:endParaRPr lang="en-US" sz="1500" dirty="0"/>
-          </a:p>
-        </p:txBody>
-      </p:sp>
-      <p:sp>
-        <p:nvSpPr>
-          <p:cNvPr id="13" name="Shape 9"/>
-          <p:cNvSpPr/>
-          <p:nvPr/>
-        </p:nvSpPr>
-        <p:spPr>
-          <a:xfrm>
-            <a:off x="8127797" y="1691640"/>
-            <a:ext cx="3515258" cy="3566160"/>
-          </a:xfrm>
-          <a:prstGeom prst="roundRect">
-            <a:avLst>
-              <a:gd name="adj" fmla="val 3121"/>
-            </a:avLst>
-          </a:prstGeom>
-          <a:solidFill>
-            <a:srgbClr val="18181B"/>
-          </a:solidFill>
-          <a:ln w="9525">
-            <a:solidFill>
-              <a:srgbClr val="2E2E35"/>
-            </a:solidFill>
-            <a:prstDash val="solid"/>
-          </a:ln>
-        </p:spPr>
-      </p:sp>
-      <p:sp>
-        <p:nvSpPr>
-          <p:cNvPr id="14" name="Shape 10"/>
-          <p:cNvSpPr/>
-          <p:nvPr/>
-        </p:nvSpPr>
-        <p:spPr>
-          <a:xfrm>
-            <a:off x="8402117" y="1965960"/>
-            <a:ext cx="640080" cy="640080"/>
-          </a:xfrm>
-          <a:prstGeom prst="ellipse">
-            <a:avLst/>
-          </a:prstGeom>
-          <a:solidFill>
-            <a:srgbClr val="F2CD3A"/>
-          </a:solidFill>
-          <a:ln w="12700">
-            <a:solidFill>
-              <a:srgbClr val="F2CD3A"/>
-            </a:solidFill>
-            <a:prstDash val="solid"/>
-          </a:ln>
-        </p:spPr>
-      </p:sp>
-      <p:pic>
-        <p:nvPicPr>
-          <p:cNvPr id="15" name="Image 2" descr="preencoded.png">    </p:cNvPr>
-          <p:cNvPicPr>
-            <a:picLocks noChangeAspect="1"/>
-          </p:cNvPicPr>
-          <p:nvPr/>
-        </p:nvPicPr>
-        <p:blipFill>
-          <a:blip r:embed="rId3"/>
-          <a:stretch>
-            <a:fillRect/>
-          </a:stretch>
-        </p:blipFill>
-        <p:spPr>
-          <a:xfrm>
-            <a:off x="8555736" y="2119579"/>
-            <a:ext cx="332842" cy="332842"/>
-          </a:xfrm>
-          <a:prstGeom prst="rect">
-            <a:avLst/>
-          </a:prstGeom>
-        </p:spPr>
-      </p:pic>
-      <p:sp>
-        <p:nvSpPr>
-          <p:cNvPr id="16" name="Text 11"/>
-          <p:cNvSpPr txBox="1"/>
-          <p:nvPr/>
-        </p:nvSpPr>
-        <p:spPr>
-          <a:xfrm>
-            <a:off x="8402117" y="2788920"/>
-            <a:ext cx="2966618" cy="457200"/>
-          </a:xfrm>
-          <a:prstGeom prst="rect">
-            <a:avLst/>
-          </a:prstGeom>
-          <a:noFill/>
-          <a:ln/>
-        </p:spPr>
-        <p:txBody>
-          <a:bodyPr wrap="square" lIns="0" tIns="0" rIns="0" bIns="0" rtlCol="0" anchor="t"/>
-          <a:lstStyle/>
-          <a:p>
-            <a:pPr indent="0" marL="0">
-              <a:buNone/>
-            </a:pPr>
-            <a:r>
-              <a:rPr lang="en-US" sz="2000" b="1" dirty="0">
-                <a:solidFill>
-                  <a:srgbClr val="F2CD3A"/>
-                </a:solidFill>
-                <a:latin typeface="Calibri" pitchFamily="34" charset="0"/>
-                <a:ea typeface="Calibri" pitchFamily="34" charset="-122"/>
-                <a:cs typeface="Calibri" pitchFamily="34" charset="-120"/>
-              </a:rPr>
-              <a:t>Nytte</a:t>
-            </a:r>
-            <a:endParaRPr lang="en-US" sz="2000" dirty="0"/>
-          </a:p>
-        </p:txBody>
-      </p:sp>
-      <p:sp>
-        <p:nvSpPr>
-          <p:cNvPr id="17" name="Text 12"/>
-          <p:cNvSpPr txBox="1"/>
-          <p:nvPr/>
-        </p:nvSpPr>
-        <p:spPr>
-          <a:xfrm>
-            <a:off x="8402117" y="3337560"/>
-            <a:ext cx="2966618" cy="1645920"/>
-          </a:xfrm>
-          <a:prstGeom prst="rect">
-            <a:avLst/>
-          </a:prstGeom>
-          <a:noFill/>
-          <a:ln/>
-        </p:spPr>
-        <p:txBody>
-          <a:bodyPr wrap="square" lIns="0" tIns="0" rIns="0" bIns="0" rtlCol="0" anchor="t"/>
-          <a:lstStyle/>
-          <a:p>
-            <a:pPr indent="0" marL="0">
-              <a:buNone/>
-            </a:pPr>
-            <a:r>
-              <a:rPr lang="en-US" sz="1500" dirty="0">
-                <a:solidFill>
-                  <a:srgbClr val="E4E4E7"/>
-                </a:solidFill>
-                <a:latin typeface="Calibri" pitchFamily="34" charset="0"/>
-                <a:ea typeface="Calibri" pitchFamily="34" charset="-122"/>
-                <a:cs typeface="Calibri" pitchFamily="34" charset="-120"/>
-              </a:rPr>
-              <a:t>Betalinger på to sekunder for under et øre, protokoll-innebygde tokens for spill, billetter og identitet, og open outcry-handel over CAPD. Bygget for bruk, ikke for spekulasjon.</a:t>
-            </a:r>
-            <a:endParaRPr lang="en-US" sz="1500" dirty="0"/>
-          </a:p>
-        </p:txBody>
-      </p:sp>
-      <p:sp>
-        <p:nvSpPr>
-          <p:cNvPr id="18" name="Text 13"/>
-          <p:cNvSpPr txBox="1"/>
-          <p:nvPr/>
-        </p:nvSpPr>
-        <p:spPr>
-          <a:xfrm>
-            <a:off x="548640" y="5486400"/>
-            <a:ext cx="11094415" cy="731520"/>
-          </a:xfrm>
-          <a:prstGeom prst="rect">
-            <a:avLst/>
-          </a:prstGeom>
-          <a:noFill/>
-          <a:ln/>
-        </p:spPr>
-        <p:txBody>
-          <a:bodyPr wrap="square" lIns="0" tIns="0" rIns="0" bIns="0" rtlCol="0" anchor="ctr"/>
-          <a:lstStyle/>
-          <a:p>
-            <a:pPr indent="0" marL="0">
-              <a:buNone/>
-            </a:pPr>
-            <a:r>
-              <a:rPr lang="en-US" sz="1100" dirty="0">
-                <a:solidFill>
-                  <a:srgbClr val="A1A1AA"/>
-                </a:solidFill>
-                <a:latin typeface="Calibri" pitchFamily="34" charset="0"/>
-                <a:ea typeface="Calibri" pitchFamily="34" charset="-122"/>
-                <a:cs typeface="Calibri" pitchFamily="34" charset="-120"/>
-              </a:rPr>
-              <a:t>Kilder: Cambridge CBECI (2026) · de Vries &amp; Stoll, Bitcoin's growing e-waste problem (2021) · ethereum.org · nexa.org og spec.nexa.org · Statistisk sentralbyrå (SSB) · Regjeringens datasenterregulering (juni 2025) · NTNU: Borgelt m.fl. (2026), Hertwich m.fl. (2014), HighEFF (2024) · jqrgen.medium.com (sept. 2026)</a:t>
-            </a:r>
-            <a:endParaRPr lang="en-US" sz="1100" dirty="0"/>
-          </a:p>
-        </p:txBody>
-      </p:sp>
-      <p:pic>
-        <p:nvPicPr>
-          <p:cNvPr id="20" name="Image 3" descr="preencoded.png">    </p:cNvPr>
-          <p:cNvPicPr>
-            <a:picLocks noChangeAspect="1"/>
-          </p:cNvPicPr>
-          <p:nvPr/>
-        </p:nvPicPr>
-        <p:blipFill>
-          <a:blip r:embed="rId4"/>
-          <a:stretch>
-            <a:fillRect/>
-          </a:stretch>
-        </p:blipFill>
-        <p:spPr>
-          <a:xfrm>
-            <a:off x="548640" y="6355080"/>
-            <a:ext cx="256032" cy="246888"/>
-          </a:xfrm>
-          <a:prstGeom prst="rect">
-            <a:avLst/>
-          </a:prstGeom>
-        </p:spPr>
-      </p:pic>
-      <p:sp>
-        <p:nvSpPr>
-          <p:cNvPr id="21" name="Text 14"/>
-          <p:cNvSpPr txBox="1"/>
-          <p:nvPr/>
-        </p:nvSpPr>
-        <p:spPr>
-          <a:xfrm>
-            <a:off x="877824" y="6400800"/>
-            <a:ext cx="2743200" cy="274320"/>
-          </a:xfrm>
-          <a:prstGeom prst="rect">
-            <a:avLst/>
-          </a:prstGeom>
-          <a:noFill/>
-          <a:ln/>
-        </p:spPr>
-        <p:txBody>
-          <a:bodyPr wrap="square" lIns="0" tIns="0" rIns="0" bIns="0" rtlCol="0" anchor="ctr"/>
-          <a:lstStyle/>
-          <a:p>
-            <a:pPr algn="l" indent="0" marL="0">
-              <a:buNone/>
-            </a:pPr>
-            <a:r>
-              <a:rPr lang="en-US" sz="1000" dirty="0">
-                <a:solidFill>
-                  <a:srgbClr val="A1A1AA"/>
-                </a:solidFill>
-                <a:latin typeface="Calibri" pitchFamily="34" charset="0"/>
-                <a:ea typeface="Calibri" pitchFamily="34" charset="-122"/>
-                <a:cs typeface="Calibri" pitchFamily="34" charset="-120"/>
-              </a:rPr>
-              <a:t>Nexa · 2026</a:t>
-            </a:r>
-            <a:endParaRPr lang="en-US" sz="1000" dirty="0"/>
-          </a:p>
-        </p:txBody>
-      </p:sp>
-      <p:sp>
-        <p:nvSpPr>
-          <p:cNvPr id="22" name="Text 15"/>
-          <p:cNvSpPr txBox="1"/>
-          <p:nvPr/>
-        </p:nvSpPr>
-        <p:spPr>
-          <a:xfrm>
-            <a:off x="11094415" y="6400800"/>
-            <a:ext cx="548640" cy="274320"/>
-          </a:xfrm>
-          <a:prstGeom prst="rect">
-            <a:avLst/>
-          </a:prstGeom>
-          <a:noFill/>
-          <a:ln/>
-        </p:spPr>
-        <p:txBody>
-          <a:bodyPr wrap="square" lIns="0" tIns="0" rIns="0" bIns="0" rtlCol="0" anchor="ctr"/>
-          <a:lstStyle/>
-          <a:p>
-            <a:pPr algn="r" indent="0" marL="0">
-              <a:buNone/>
-            </a:pPr>
-            <a:r>
-              <a:rPr lang="en-US" sz="1000" dirty="0">
-                <a:solidFill>
-                  <a:srgbClr val="A1A1AA"/>
-                </a:solidFill>
-                <a:latin typeface="Calibri" pitchFamily="34" charset="0"/>
-                <a:ea typeface="Calibri" pitchFamily="34" charset="-122"/>
-                <a:cs typeface="Calibri" pitchFamily="34" charset="-120"/>
-              </a:rPr>
               <a:t>19</a:t>
             </a:r>
             <a:endParaRPr lang="en-US" sz="1000" dirty="0"/>
@@ -10924,6 +10983,680 @@
                 <a:cs typeface="Calibri" pitchFamily="34" charset="-120"/>
               </a:rPr>
               <a:t>2</a:t>
+            </a:r>
+            <a:endParaRPr lang="en-US" sz="1000" dirty="0"/>
+          </a:p>
+        </p:txBody>
+      </p:sp>
+    </p:spTree>
+  </p:cSld>
+  <p:clrMapOvr>
+    <a:masterClrMapping/>
+  </p:clrMapOvr>
+</p:sld>
+</file>
+
+<file path=ppt/slides/slide20.xml><?xml version="1.0" encoding="utf-8"?>
+<p:sld xmlns:a="http://schemas.openxmlformats.org/drawingml/2006/main" xmlns:r="http://schemas.openxmlformats.org/officeDocument/2006/relationships" xmlns:p="http://schemas.openxmlformats.org/presentationml/2006/main">
+  <p:cSld name="Slide 20">
+    <p:bg>
+      <p:bgPr>
+        <a:solidFill>
+          <a:srgbClr val="0A0A0F"/>
+        </a:solidFill>
+      </p:bgPr>
+    </p:bg>
+    <p:spTree>
+      <p:nvGrpSpPr>
+        <p:cNvPr id="1" name=""/>
+        <p:cNvGrpSpPr/>
+        <p:nvPr/>
+      </p:nvGrpSpPr>
+      <p:grpSpPr>
+        <a:xfrm>
+          <a:off x="0" y="0"/>
+          <a:ext cx="0" cy="0"/>
+          <a:chOff x="0" y="0"/>
+          <a:chExt cx="0" cy="0"/>
+        </a:xfrm>
+      </p:grpSpPr>
+      <p:sp>
+        <p:nvSpPr>
+          <p:cNvPr id="2" name="Text 0"/>
+          <p:cNvSpPr txBox="1"/>
+          <p:nvPr/>
+        </p:nvSpPr>
+        <p:spPr>
+          <a:xfrm>
+            <a:off x="548640" y="411480"/>
+            <a:ext cx="11094415" cy="1005840"/>
+          </a:xfrm>
+          <a:prstGeom prst="rect">
+            <a:avLst/>
+          </a:prstGeom>
+          <a:noFill/>
+          <a:ln/>
+        </p:spPr>
+        <p:txBody>
+          <a:bodyPr wrap="square" lIns="0" tIns="0" rIns="0" bIns="0" rtlCol="0" anchor="t"/>
+          <a:lstStyle/>
+          <a:p>
+            <a:pPr algn="l" indent="0" marL="0">
+              <a:buNone/>
+            </a:pPr>
+            <a:r>
+              <a:rPr lang="en-US" sz="3000" b="1" dirty="0">
+                <a:solidFill>
+                  <a:srgbClr val="FFFFFF"/>
+                </a:solidFill>
+                <a:latin typeface="Calibri" pitchFamily="34" charset="0"/>
+                <a:ea typeface="Calibri" pitchFamily="34" charset="-122"/>
+                <a:cs typeface="Calibri" pitchFamily="34" charset="-120"/>
+              </a:rPr>
+              <a:t>Tre ting å huske</a:t>
+            </a:r>
+            <a:endParaRPr lang="en-US" sz="3000" dirty="0"/>
+          </a:p>
+        </p:txBody>
+      </p:sp>
+      <p:sp>
+        <p:nvSpPr>
+          <p:cNvPr id="3" name="Shape 1"/>
+          <p:cNvSpPr/>
+          <p:nvPr/>
+        </p:nvSpPr>
+        <p:spPr>
+          <a:xfrm>
+            <a:off x="548640" y="1691640"/>
+            <a:ext cx="3515258" cy="3566160"/>
+          </a:xfrm>
+          <a:prstGeom prst="roundRect">
+            <a:avLst>
+              <a:gd name="adj" fmla="val 3121"/>
+            </a:avLst>
+          </a:prstGeom>
+          <a:solidFill>
+            <a:srgbClr val="18181B"/>
+          </a:solidFill>
+          <a:ln w="9525">
+            <a:solidFill>
+              <a:srgbClr val="2E2E35"/>
+            </a:solidFill>
+            <a:prstDash val="solid"/>
+          </a:ln>
+        </p:spPr>
+      </p:sp>
+      <p:sp>
+        <p:nvSpPr>
+          <p:cNvPr id="4" name="Shape 2"/>
+          <p:cNvSpPr/>
+          <p:nvPr/>
+        </p:nvSpPr>
+        <p:spPr>
+          <a:xfrm>
+            <a:off x="822960" y="1965960"/>
+            <a:ext cx="640080" cy="640080"/>
+          </a:xfrm>
+          <a:prstGeom prst="ellipse">
+            <a:avLst/>
+          </a:prstGeom>
+          <a:solidFill>
+            <a:srgbClr val="F2CD3A"/>
+          </a:solidFill>
+          <a:ln w="12700">
+            <a:solidFill>
+              <a:srgbClr val="F2CD3A"/>
+            </a:solidFill>
+            <a:prstDash val="solid"/>
+          </a:ln>
+        </p:spPr>
+      </p:sp>
+      <p:pic>
+        <p:nvPicPr>
+          <p:cNvPr id="5" name="Image 0" descr="preencoded.png">    </p:cNvPr>
+          <p:cNvPicPr>
+            <a:picLocks noChangeAspect="1"/>
+          </p:cNvPicPr>
+          <p:nvPr/>
+        </p:nvPicPr>
+        <p:blipFill>
+          <a:blip r:embed="rId1"/>
+          <a:stretch>
+            <a:fillRect/>
+          </a:stretch>
+        </p:blipFill>
+        <p:spPr>
+          <a:xfrm>
+            <a:off x="976579" y="2119579"/>
+            <a:ext cx="332842" cy="332842"/>
+          </a:xfrm>
+          <a:prstGeom prst="rect">
+            <a:avLst/>
+          </a:prstGeom>
+        </p:spPr>
+      </p:pic>
+      <p:sp>
+        <p:nvSpPr>
+          <p:cNvPr id="6" name="Text 3"/>
+          <p:cNvSpPr txBox="1"/>
+          <p:nvPr/>
+        </p:nvSpPr>
+        <p:spPr>
+          <a:xfrm>
+            <a:off x="822960" y="2788920"/>
+            <a:ext cx="2966618" cy="457200"/>
+          </a:xfrm>
+          <a:prstGeom prst="rect">
+            <a:avLst/>
+          </a:prstGeom>
+          <a:noFill/>
+          <a:ln/>
+        </p:spPr>
+        <p:txBody>
+          <a:bodyPr wrap="square" lIns="0" tIns="0" rIns="0" bIns="0" rtlCol="0" anchor="t"/>
+          <a:lstStyle/>
+          <a:p>
+            <a:pPr indent="0" marL="0">
+              <a:buNone/>
+            </a:pPr>
+            <a:r>
+              <a:rPr lang="en-US" sz="2000" b="1" dirty="0">
+                <a:solidFill>
+                  <a:srgbClr val="F2CD3A"/>
+                </a:solidFill>
+                <a:latin typeface="Calibri" pitchFamily="34" charset="0"/>
+                <a:ea typeface="Calibri" pitchFamily="34" charset="-122"/>
+                <a:cs typeface="Calibri" pitchFamily="34" charset="-120"/>
+              </a:rPr>
+              <a:t>Energi</a:t>
+            </a:r>
+            <a:endParaRPr lang="en-US" sz="2000" dirty="0"/>
+          </a:p>
+        </p:txBody>
+      </p:sp>
+      <p:sp>
+        <p:nvSpPr>
+          <p:cNvPr id="7" name="Text 4"/>
+          <p:cNvSpPr txBox="1"/>
+          <p:nvPr/>
+        </p:nvSpPr>
+        <p:spPr>
+          <a:xfrm>
+            <a:off x="822960" y="3337560"/>
+            <a:ext cx="2966618" cy="1645920"/>
+          </a:xfrm>
+          <a:prstGeom prst="rect">
+            <a:avLst/>
+          </a:prstGeom>
+          <a:noFill/>
+          <a:ln/>
+        </p:spPr>
+        <p:txBody>
+          <a:bodyPr wrap="square" lIns="0" tIns="0" rIns="0" bIns="0" rtlCol="0" anchor="t"/>
+          <a:lstStyle/>
+          <a:p>
+            <a:pPr indent="0" marL="0">
+              <a:buNone/>
+            </a:pPr>
+            <a:r>
+              <a:rPr lang="en-US" sz="1500" dirty="0">
+                <a:solidFill>
+                  <a:srgbClr val="E4E4E7"/>
+                </a:solidFill>
+                <a:latin typeface="Calibri" pitchFamily="34" charset="0"/>
+                <a:ea typeface="Calibri" pitchFamily="34" charset="-122"/>
+                <a:cs typeface="Calibri" pitchFamily="34" charset="-120"/>
+              </a:rPr>
+              <a:t>Proof of work koster det minerne får betalt, på enhver kjede. I stor skala får Nexa inntil 13 000× flere transaksjoner ut av hver kilowattime enn Bitcoin, på gjenbrukbare GPU-er, ikke ASIC-er som kastes.</a:t>
+            </a:r>
+            <a:endParaRPr lang="en-US" sz="1500" dirty="0"/>
+          </a:p>
+        </p:txBody>
+      </p:sp>
+      <p:sp>
+        <p:nvSpPr>
+          <p:cNvPr id="8" name="Shape 5"/>
+          <p:cNvSpPr/>
+          <p:nvPr/>
+        </p:nvSpPr>
+        <p:spPr>
+          <a:xfrm>
+            <a:off x="4338218" y="1691640"/>
+            <a:ext cx="3515258" cy="3566160"/>
+          </a:xfrm>
+          <a:prstGeom prst="roundRect">
+            <a:avLst>
+              <a:gd name="adj" fmla="val 3121"/>
+            </a:avLst>
+          </a:prstGeom>
+          <a:solidFill>
+            <a:srgbClr val="18181B"/>
+          </a:solidFill>
+          <a:ln w="9525">
+            <a:solidFill>
+              <a:srgbClr val="2E2E35"/>
+            </a:solidFill>
+            <a:prstDash val="solid"/>
+          </a:ln>
+        </p:spPr>
+      </p:sp>
+      <p:sp>
+        <p:nvSpPr>
+          <p:cNvPr id="9" name="Shape 6"/>
+          <p:cNvSpPr/>
+          <p:nvPr/>
+        </p:nvSpPr>
+        <p:spPr>
+          <a:xfrm>
+            <a:off x="4612538" y="1965960"/>
+            <a:ext cx="640080" cy="640080"/>
+          </a:xfrm>
+          <a:prstGeom prst="ellipse">
+            <a:avLst/>
+          </a:prstGeom>
+          <a:solidFill>
+            <a:srgbClr val="F2CD3A"/>
+          </a:solidFill>
+          <a:ln w="12700">
+            <a:solidFill>
+              <a:srgbClr val="F2CD3A"/>
+            </a:solidFill>
+            <a:prstDash val="solid"/>
+          </a:ln>
+        </p:spPr>
+      </p:sp>
+      <p:pic>
+        <p:nvPicPr>
+          <p:cNvPr id="10" name="Image 1" descr="preencoded.png">    </p:cNvPr>
+          <p:cNvPicPr>
+            <a:picLocks noChangeAspect="1"/>
+          </p:cNvPicPr>
+          <p:nvPr/>
+        </p:nvPicPr>
+        <p:blipFill>
+          <a:blip r:embed="rId2"/>
+          <a:stretch>
+            <a:fillRect/>
+          </a:stretch>
+        </p:blipFill>
+        <p:spPr>
+          <a:xfrm>
+            <a:off x="4766158" y="2119579"/>
+            <a:ext cx="332842" cy="332842"/>
+          </a:xfrm>
+          <a:prstGeom prst="rect">
+            <a:avLst/>
+          </a:prstGeom>
+        </p:spPr>
+      </p:pic>
+      <p:sp>
+        <p:nvSpPr>
+          <p:cNvPr id="11" name="Text 7"/>
+          <p:cNvSpPr txBox="1"/>
+          <p:nvPr/>
+        </p:nvSpPr>
+        <p:spPr>
+          <a:xfrm>
+            <a:off x="4612538" y="2788920"/>
+            <a:ext cx="2966618" cy="457200"/>
+          </a:xfrm>
+          <a:prstGeom prst="rect">
+            <a:avLst/>
+          </a:prstGeom>
+          <a:noFill/>
+          <a:ln/>
+        </p:spPr>
+        <p:txBody>
+          <a:bodyPr wrap="square" lIns="0" tIns="0" rIns="0" bIns="0" rtlCol="0" anchor="t"/>
+          <a:lstStyle/>
+          <a:p>
+            <a:pPr indent="0" marL="0">
+              <a:buNone/>
+            </a:pPr>
+            <a:r>
+              <a:rPr lang="en-US" sz="2000" b="1" dirty="0">
+                <a:solidFill>
+                  <a:srgbClr val="F2CD3A"/>
+                </a:solidFill>
+                <a:latin typeface="Calibri" pitchFamily="34" charset="0"/>
+                <a:ea typeface="Calibri" pitchFamily="34" charset="-122"/>
+                <a:cs typeface="Calibri" pitchFamily="34" charset="-120"/>
+              </a:rPr>
+              <a:t>Rettferdighet</a:t>
+            </a:r>
+            <a:endParaRPr lang="en-US" sz="2000" dirty="0"/>
+          </a:p>
+        </p:txBody>
+      </p:sp>
+      <p:sp>
+        <p:nvSpPr>
+          <p:cNvPr id="12" name="Text 8"/>
+          <p:cNvSpPr txBox="1"/>
+          <p:nvPr/>
+        </p:nvSpPr>
+        <p:spPr>
+          <a:xfrm>
+            <a:off x="4612538" y="3337560"/>
+            <a:ext cx="2966618" cy="1645920"/>
+          </a:xfrm>
+          <a:prstGeom prst="rect">
+            <a:avLst/>
+          </a:prstGeom>
+          <a:noFill/>
+          <a:ln/>
+        </p:spPr>
+        <p:txBody>
+          <a:bodyPr wrap="square" lIns="0" tIns="0" rIns="0" bIns="0" rtlCol="0" anchor="t"/>
+          <a:lstStyle/>
+          <a:p>
+            <a:pPr indent="0" marL="0">
+              <a:buNone/>
+            </a:pPr>
+            <a:r>
+              <a:rPr lang="en-US" sz="1500" dirty="0">
+                <a:solidFill>
+                  <a:srgbClr val="E4E4E7"/>
+                </a:solidFill>
+                <a:latin typeface="Calibri" pitchFamily="34" charset="0"/>
+                <a:ea typeface="Calibri" pitchFamily="34" charset="-122"/>
+                <a:cs typeface="Calibri" pitchFamily="34" charset="-120"/>
+              </a:rPr>
+              <a:t>Ingen premine, ingen ICO, ingen venturekapital. 100 % av tilbudet utvunnet offentlig siden 2022, åpent for alle med et skjermkort.</a:t>
+            </a:r>
+            <a:endParaRPr lang="en-US" sz="1500" dirty="0"/>
+          </a:p>
+        </p:txBody>
+      </p:sp>
+      <p:sp>
+        <p:nvSpPr>
+          <p:cNvPr id="13" name="Shape 9"/>
+          <p:cNvSpPr/>
+          <p:nvPr/>
+        </p:nvSpPr>
+        <p:spPr>
+          <a:xfrm>
+            <a:off x="8127797" y="1691640"/>
+            <a:ext cx="3515258" cy="3566160"/>
+          </a:xfrm>
+          <a:prstGeom prst="roundRect">
+            <a:avLst>
+              <a:gd name="adj" fmla="val 3121"/>
+            </a:avLst>
+          </a:prstGeom>
+          <a:solidFill>
+            <a:srgbClr val="18181B"/>
+          </a:solidFill>
+          <a:ln w="9525">
+            <a:solidFill>
+              <a:srgbClr val="2E2E35"/>
+            </a:solidFill>
+            <a:prstDash val="solid"/>
+          </a:ln>
+        </p:spPr>
+      </p:sp>
+      <p:sp>
+        <p:nvSpPr>
+          <p:cNvPr id="14" name="Shape 10"/>
+          <p:cNvSpPr/>
+          <p:nvPr/>
+        </p:nvSpPr>
+        <p:spPr>
+          <a:xfrm>
+            <a:off x="8402117" y="1965960"/>
+            <a:ext cx="640080" cy="640080"/>
+          </a:xfrm>
+          <a:prstGeom prst="ellipse">
+            <a:avLst/>
+          </a:prstGeom>
+          <a:solidFill>
+            <a:srgbClr val="F2CD3A"/>
+          </a:solidFill>
+          <a:ln w="12700">
+            <a:solidFill>
+              <a:srgbClr val="F2CD3A"/>
+            </a:solidFill>
+            <a:prstDash val="solid"/>
+          </a:ln>
+        </p:spPr>
+      </p:sp>
+      <p:pic>
+        <p:nvPicPr>
+          <p:cNvPr id="15" name="Image 2" descr="preencoded.png">    </p:cNvPr>
+          <p:cNvPicPr>
+            <a:picLocks noChangeAspect="1"/>
+          </p:cNvPicPr>
+          <p:nvPr/>
+        </p:nvPicPr>
+        <p:blipFill>
+          <a:blip r:embed="rId3"/>
+          <a:stretch>
+            <a:fillRect/>
+          </a:stretch>
+        </p:blipFill>
+        <p:spPr>
+          <a:xfrm>
+            <a:off x="8555736" y="2119579"/>
+            <a:ext cx="332842" cy="332842"/>
+          </a:xfrm>
+          <a:prstGeom prst="rect">
+            <a:avLst/>
+          </a:prstGeom>
+        </p:spPr>
+      </p:pic>
+      <p:sp>
+        <p:nvSpPr>
+          <p:cNvPr id="16" name="Text 11"/>
+          <p:cNvSpPr txBox="1"/>
+          <p:nvPr/>
+        </p:nvSpPr>
+        <p:spPr>
+          <a:xfrm>
+            <a:off x="8402117" y="2788920"/>
+            <a:ext cx="2966618" cy="457200"/>
+          </a:xfrm>
+          <a:prstGeom prst="rect">
+            <a:avLst/>
+          </a:prstGeom>
+          <a:noFill/>
+          <a:ln/>
+        </p:spPr>
+        <p:txBody>
+          <a:bodyPr wrap="square" lIns="0" tIns="0" rIns="0" bIns="0" rtlCol="0" anchor="t"/>
+          <a:lstStyle/>
+          <a:p>
+            <a:pPr indent="0" marL="0">
+              <a:buNone/>
+            </a:pPr>
+            <a:r>
+              <a:rPr lang="en-US" sz="2000" b="1" dirty="0">
+                <a:solidFill>
+                  <a:srgbClr val="F2CD3A"/>
+                </a:solidFill>
+                <a:latin typeface="Calibri" pitchFamily="34" charset="0"/>
+                <a:ea typeface="Calibri" pitchFamily="34" charset="-122"/>
+                <a:cs typeface="Calibri" pitchFamily="34" charset="-120"/>
+              </a:rPr>
+              <a:t>Nytte</a:t>
+            </a:r>
+            <a:endParaRPr lang="en-US" sz="2000" dirty="0"/>
+          </a:p>
+        </p:txBody>
+      </p:sp>
+      <p:sp>
+        <p:nvSpPr>
+          <p:cNvPr id="17" name="Text 12"/>
+          <p:cNvSpPr txBox="1"/>
+          <p:nvPr/>
+        </p:nvSpPr>
+        <p:spPr>
+          <a:xfrm>
+            <a:off x="8402117" y="3337560"/>
+            <a:ext cx="2966618" cy="1645920"/>
+          </a:xfrm>
+          <a:prstGeom prst="rect">
+            <a:avLst/>
+          </a:prstGeom>
+          <a:noFill/>
+          <a:ln/>
+        </p:spPr>
+        <p:txBody>
+          <a:bodyPr wrap="square" lIns="0" tIns="0" rIns="0" bIns="0" rtlCol="0" anchor="t"/>
+          <a:lstStyle/>
+          <a:p>
+            <a:pPr indent="0" marL="0">
+              <a:buNone/>
+            </a:pPr>
+            <a:r>
+              <a:rPr lang="en-US" sz="1500" dirty="0">
+                <a:solidFill>
+                  <a:srgbClr val="E4E4E7"/>
+                </a:solidFill>
+                <a:latin typeface="Calibri" pitchFamily="34" charset="0"/>
+                <a:ea typeface="Calibri" pitchFamily="34" charset="-122"/>
+                <a:cs typeface="Calibri" pitchFamily="34" charset="-120"/>
+              </a:rPr>
+              <a:t>Betalinger på to sekunder for under et øre, protokoll-innebygde tokens for spill, billetter og identitet, og open outcry-handel over CAPD. Bygget for bruk, ikke for spekulasjon.</a:t>
+            </a:r>
+            <a:endParaRPr lang="en-US" sz="1500" dirty="0"/>
+          </a:p>
+        </p:txBody>
+      </p:sp>
+      <p:sp>
+        <p:nvSpPr>
+          <p:cNvPr id="18" name="Text 13"/>
+          <p:cNvSpPr txBox="1"/>
+          <p:nvPr/>
+        </p:nvSpPr>
+        <p:spPr>
+          <a:xfrm>
+            <a:off x="548640" y="5486400"/>
+            <a:ext cx="11094415" cy="731520"/>
+          </a:xfrm>
+          <a:prstGeom prst="rect">
+            <a:avLst/>
+          </a:prstGeom>
+          <a:noFill/>
+          <a:ln/>
+        </p:spPr>
+        <p:txBody>
+          <a:bodyPr wrap="square" lIns="0" tIns="0" rIns="0" bIns="0" rtlCol="0" anchor="ctr"/>
+          <a:lstStyle/>
+          <a:p>
+            <a:pPr indent="0" marL="0">
+              <a:buNone/>
+            </a:pPr>
+            <a:r>
+              <a:rPr lang="en-US" sz="1100" dirty="0">
+                <a:solidFill>
+                  <a:srgbClr val="A1A1AA"/>
+                </a:solidFill>
+                <a:latin typeface="Calibri" pitchFamily="34" charset="0"/>
+                <a:ea typeface="Calibri" pitchFamily="34" charset="-122"/>
+                <a:cs typeface="Calibri" pitchFamily="34" charset="-120"/>
+              </a:rPr>
+              <a:t>Kilder: Cambridge CBECI (2026) · de Vries &amp; Stoll, Bitcoin's growing e-waste problem (2021) · ethereum.org · nexa.org og spec.nexa.org · Statistisk sentralbyrå (SSB) · Regjeringens datasenterregulering (juni 2025) · NTNU: Borgelt m.fl. (2026), Hertwich m.fl. (2014), HighEFF (2024) · jqrgen.medium.com (sept. 2026)</a:t>
+            </a:r>
+            <a:endParaRPr lang="en-US" sz="1100" dirty="0"/>
+          </a:p>
+        </p:txBody>
+      </p:sp>
+      <p:pic>
+        <p:nvPicPr>
+          <p:cNvPr id="20" name="Image 3" descr="preencoded.png">    </p:cNvPr>
+          <p:cNvPicPr>
+            <a:picLocks noChangeAspect="1"/>
+          </p:cNvPicPr>
+          <p:nvPr/>
+        </p:nvPicPr>
+        <p:blipFill>
+          <a:blip r:embed="rId4"/>
+          <a:stretch>
+            <a:fillRect/>
+          </a:stretch>
+        </p:blipFill>
+        <p:spPr>
+          <a:xfrm>
+            <a:off x="548640" y="6355080"/>
+            <a:ext cx="256032" cy="246888"/>
+          </a:xfrm>
+          <a:prstGeom prst="rect">
+            <a:avLst/>
+          </a:prstGeom>
+        </p:spPr>
+      </p:pic>
+      <p:sp>
+        <p:nvSpPr>
+          <p:cNvPr id="21" name="Text 14"/>
+          <p:cNvSpPr txBox="1"/>
+          <p:nvPr/>
+        </p:nvSpPr>
+        <p:spPr>
+          <a:xfrm>
+            <a:off x="877824" y="6400800"/>
+            <a:ext cx="2743200" cy="274320"/>
+          </a:xfrm>
+          <a:prstGeom prst="rect">
+            <a:avLst/>
+          </a:prstGeom>
+          <a:noFill/>
+          <a:ln/>
+        </p:spPr>
+        <p:txBody>
+          <a:bodyPr wrap="square" lIns="0" tIns="0" rIns="0" bIns="0" rtlCol="0" anchor="ctr"/>
+          <a:lstStyle/>
+          <a:p>
+            <a:pPr algn="l" indent="0" marL="0">
+              <a:buNone/>
+            </a:pPr>
+            <a:r>
+              <a:rPr lang="en-US" sz="1000" dirty="0">
+                <a:solidFill>
+                  <a:srgbClr val="A1A1AA"/>
+                </a:solidFill>
+                <a:latin typeface="Calibri" pitchFamily="34" charset="0"/>
+                <a:ea typeface="Calibri" pitchFamily="34" charset="-122"/>
+                <a:cs typeface="Calibri" pitchFamily="34" charset="-120"/>
+              </a:rPr>
+              <a:t>Nexa · 2026</a:t>
+            </a:r>
+            <a:endParaRPr lang="en-US" sz="1000" dirty="0"/>
+          </a:p>
+        </p:txBody>
+      </p:sp>
+      <p:sp>
+        <p:nvSpPr>
+          <p:cNvPr id="22" name="Text 15"/>
+          <p:cNvSpPr txBox="1"/>
+          <p:nvPr/>
+        </p:nvSpPr>
+        <p:spPr>
+          <a:xfrm>
+            <a:off x="11094415" y="6400800"/>
+            <a:ext cx="548640" cy="274320"/>
+          </a:xfrm>
+          <a:prstGeom prst="rect">
+            <a:avLst/>
+          </a:prstGeom>
+          <a:noFill/>
+          <a:ln/>
+        </p:spPr>
+        <p:txBody>
+          <a:bodyPr wrap="square" lIns="0" tIns="0" rIns="0" bIns="0" rtlCol="0" anchor="ctr"/>
+          <a:lstStyle/>
+          <a:p>
+            <a:pPr algn="r" indent="0" marL="0">
+              <a:buNone/>
+            </a:pPr>
+            <a:r>
+              <a:rPr lang="en-US" sz="1000" dirty="0">
+                <a:solidFill>
+                  <a:srgbClr val="A1A1AA"/>
+                </a:solidFill>
+                <a:latin typeface="Calibri" pitchFamily="34" charset="0"/>
+                <a:ea typeface="Calibri" pitchFamily="34" charset="-122"/>
+                <a:cs typeface="Calibri" pitchFamily="34" charset="-120"/>
+              </a:rPr>
+              <a:t>20</a:t>
             </a:r>
             <a:endParaRPr lang="en-US" sz="1000" dirty="0"/>
           </a:p>

</xml_diff>